<commit_message>
refine: redesign report and deck to research-grade submission format
Agent-Logs-Url: https://github.com/DARREN-2000/temporary/sessions/ebe55dcb-c35c-423a-99c4-c8786057d660

Co-authored-by: DARREN-2000 <59622013+DARREN-2000@users.noreply.github.com>
</commit_message>
<xml_diff>
--- a/Meilisearch_Olam_Agri_Presentation.pptx
+++ b/Meilisearch_Olam_Agri_Presentation.pptx
@@ -16,7 +16,7 @@
     <p:sldId id="264" r:id="rId15"/>
     <p:sldId id="265" r:id="rId16"/>
   </p:sldIdLst>
-  <p:sldSz cx="9144000" cy="6858000" type="screen4x3"/>
+  <p:sldSz cx="12191695" cy="6858000" type="screen4x3"/>
   <p:notesSz cx="6858000" cy="9144000"/>
   <p:defaultTextStyle>
     <a:defPPr>
@@ -3099,48 +3099,243 @@
       <p:grpSpPr/>
       <p:sp>
         <p:nvSpPr>
-          <p:cNvPr id="2" name="Title 1"/>
-          <p:cNvSpPr>
-            <a:spLocks noGrp="1"/>
-          </p:cNvSpPr>
-          <p:nvPr>
-            <p:ph type="ctrTitle"/>
-          </p:nvPr>
-        </p:nvSpPr>
-        <p:spPr/>
-        <p:txBody>
-          <a:bodyPr/>
+          <p:cNvPr id="2" name="Rectangle 1"/>
+          <p:cNvSpPr/>
+          <p:nvPr/>
+        </p:nvSpPr>
+        <p:spPr>
+          <a:xfrm>
+            <a:off x="0" y="0"/>
+            <a:ext cx="12191695" cy="6858000"/>
+          </a:xfrm>
+          <a:prstGeom prst="rect">
+            <a:avLst/>
+          </a:prstGeom>
+          <a:solidFill>
+            <a:srgbClr val="F6F8F4"/>
+          </a:solidFill>
+          <a:ln>
+            <a:noFill/>
+          </a:ln>
+        </p:spPr>
+        <p:style>
+          <a:lnRef idx="1">
+            <a:schemeClr val="accent1"/>
+          </a:lnRef>
+          <a:fillRef idx="3">
+            <a:schemeClr val="accent1"/>
+          </a:fillRef>
+          <a:effectRef idx="2">
+            <a:schemeClr val="accent1"/>
+          </a:effectRef>
+          <a:fontRef idx="minor">
+            <a:schemeClr val="lt1"/>
+          </a:fontRef>
+        </p:style>
+        <p:txBody>
+          <a:bodyPr rtlCol="0" anchor="ctr"/>
+          <a:lstStyle/>
+          <a:p>
+            <a:pPr algn="ctr"/>
+          </a:p>
+        </p:txBody>
+      </p:sp>
+      <p:sp>
+        <p:nvSpPr>
+          <p:cNvPr id="3" name="Rectangle 2"/>
+          <p:cNvSpPr/>
+          <p:nvPr/>
+        </p:nvSpPr>
+        <p:spPr>
+          <a:xfrm>
+            <a:off x="0" y="0"/>
+            <a:ext cx="12191695" cy="777240"/>
+          </a:xfrm>
+          <a:prstGeom prst="rect">
+            <a:avLst/>
+          </a:prstGeom>
+          <a:solidFill>
+            <a:srgbClr val="123524"/>
+          </a:solidFill>
+          <a:ln>
+            <a:noFill/>
+          </a:ln>
+        </p:spPr>
+        <p:style>
+          <a:lnRef idx="1">
+            <a:schemeClr val="accent1"/>
+          </a:lnRef>
+          <a:fillRef idx="3">
+            <a:schemeClr val="accent1"/>
+          </a:fillRef>
+          <a:effectRef idx="2">
+            <a:schemeClr val="accent1"/>
+          </a:effectRef>
+          <a:fontRef idx="minor">
+            <a:schemeClr val="lt1"/>
+          </a:fontRef>
+        </p:style>
+        <p:txBody>
+          <a:bodyPr rtlCol="0" anchor="ctr"/>
+          <a:lstStyle/>
+          <a:p>
+            <a:pPr algn="ctr"/>
+          </a:p>
+        </p:txBody>
+      </p:sp>
+      <p:sp>
+        <p:nvSpPr>
+          <p:cNvPr id="4" name="TextBox 3"/>
+          <p:cNvSpPr txBox="1"/>
+          <p:nvPr/>
+        </p:nvSpPr>
+        <p:spPr>
+          <a:xfrm>
+            <a:off x="502920" y="146304"/>
+            <a:ext cx="8961120" cy="457200"/>
+          </a:xfrm>
+          <a:prstGeom prst="rect">
+            <a:avLst/>
+          </a:prstGeom>
+          <a:noFill/>
+        </p:spPr>
+        <p:txBody>
+          <a:bodyPr wrap="none">
+            <a:spAutoFit/>
+          </a:bodyPr>
           <a:lstStyle/>
           <a:p>
             <a:pPr>
-              <a:defRPr sz="3400"/>
-            </a:pPr>
-            <a:r>
-              <a:t>Meilisearch for Olam Agri</a:t>
-            </a:r>
-          </a:p>
-        </p:txBody>
-      </p:sp>
-      <p:sp>
-        <p:nvSpPr>
-          <p:cNvPr id="3" name="Subtitle 2"/>
-          <p:cNvSpPr>
-            <a:spLocks noGrp="1"/>
-          </p:cNvSpPr>
-          <p:nvPr>
-            <p:ph type="subTitle" idx="1"/>
-          </p:nvPr>
-        </p:nvSpPr>
-        <p:spPr/>
-        <p:txBody>
-          <a:bodyPr/>
+              <a:defRPr sz="2400" b="1">
+                <a:solidFill>
+                  <a:srgbClr val="FFFFFF"/>
+                </a:solidFill>
+              </a:defRPr>
+            </a:pPr>
+            <a:r>
+              <a:t>Meilisearch Adoption Blueprint for Olam Agri</a:t>
+            </a:r>
+          </a:p>
+        </p:txBody>
+      </p:sp>
+      <p:sp>
+        <p:nvSpPr>
+          <p:cNvPr id="5" name="TextBox 4"/>
+          <p:cNvSpPr txBox="1"/>
+          <p:nvPr/>
+        </p:nvSpPr>
+        <p:spPr>
+          <a:xfrm>
+            <a:off x="10332720" y="182880"/>
+            <a:ext cx="1645920" cy="320040"/>
+          </a:xfrm>
+          <a:prstGeom prst="rect">
+            <a:avLst/>
+          </a:prstGeom>
+          <a:noFill/>
+        </p:spPr>
+        <p:txBody>
+          <a:bodyPr wrap="none">
+            <a:spAutoFit/>
+          </a:bodyPr>
+          <a:lstStyle/>
+          <a:p>
+            <a:pPr algn="r">
+              <a:defRPr sz="1000">
+                <a:solidFill>
+                  <a:srgbClr val="DCE9E2"/>
+                </a:solidFill>
+              </a:defRPr>
+            </a:pPr>
+            <a:r>
+              <a:t>Olam Agri | Research Brief</a:t>
+            </a:r>
+          </a:p>
+        </p:txBody>
+      </p:sp>
+      <p:sp>
+        <p:nvSpPr>
+          <p:cNvPr id="6" name="TextBox 5"/>
+          <p:cNvSpPr txBox="1"/>
+          <p:nvPr/>
+        </p:nvSpPr>
+        <p:spPr>
+          <a:xfrm>
+            <a:off x="685800" y="1874519"/>
+            <a:ext cx="10789920" cy="1463040"/>
+          </a:xfrm>
+          <a:prstGeom prst="rect">
+            <a:avLst/>
+          </a:prstGeom>
+          <a:noFill/>
+        </p:spPr>
+        <p:txBody>
+          <a:bodyPr wrap="none">
+            <a:spAutoFit/>
+          </a:bodyPr>
           <a:lstStyle/>
           <a:p>
             <a:pPr>
-              <a:defRPr sz="1800"/>
-            </a:pPr>
-            <a:r>
-              <a:t>Verified integration brief | Cleaned for executive presentation</a:t>
+              <a:defRPr sz="3400" b="1">
+                <a:solidFill>
+                  <a:srgbClr val="1E3C2C"/>
+                </a:solidFill>
+              </a:defRPr>
+            </a:pPr>
+            <a:r>
+              <a:t>Architecture, performance behavior, self-hosting strategy, and implementation blockers</a:t>
+            </a:r>
+          </a:p>
+        </p:txBody>
+      </p:sp>
+      <p:sp>
+        <p:nvSpPr>
+          <p:cNvPr id="7" name="TextBox 6"/>
+          <p:cNvSpPr txBox="1"/>
+          <p:nvPr/>
+        </p:nvSpPr>
+        <p:spPr>
+          <a:xfrm>
+            <a:off x="685800" y="4069080"/>
+            <a:ext cx="7315200" cy="1280160"/>
+          </a:xfrm>
+          <a:prstGeom prst="rect">
+            <a:avLst/>
+          </a:prstGeom>
+          <a:noFill/>
+        </p:spPr>
+        <p:txBody>
+          <a:bodyPr wrap="none">
+            <a:spAutoFit/>
+          </a:bodyPr>
+          <a:lstStyle/>
+          <a:p>
+            <a:pPr>
+              <a:defRPr sz="1700">
+                <a:solidFill>
+                  <a:srgbClr val="4E6558"/>
+                </a:solidFill>
+              </a:defRPr>
+            </a:pPr>
+            <a:r>
+              <a:t>Technical Brief</a:t>
+            </a:r>
+          </a:p>
+          <a:p>
+            <a:pPr>
+              <a:defRPr sz="1700">
+                <a:solidFill>
+                  <a:srgbClr val="4E6558"/>
+                </a:solidFill>
+              </a:defRPr>
+            </a:pPr>
+            <a:r>
+              <a:t>30 March 2026</a:t>
+            </a:r>
+          </a:p>
+          <a:p>
+            <a:r>
+              <a:t>Prepared for submission and presentation</a:t>
             </a:r>
           </a:p>
         </p:txBody>
@@ -3165,61 +3360,304 @@
       <p:grpSpPr/>
       <p:sp>
         <p:nvSpPr>
-          <p:cNvPr id="2" name="Title 1"/>
-          <p:cNvSpPr>
-            <a:spLocks noGrp="1"/>
-          </p:cNvSpPr>
-          <p:nvPr>
-            <p:ph type="title"/>
-          </p:nvPr>
-        </p:nvSpPr>
-        <p:spPr/>
-        <p:txBody>
-          <a:bodyPr/>
-          <a:lstStyle/>
-          <a:p>
-            <a:r>
-              <a:t>9) Sources used for verification</a:t>
-            </a:r>
-          </a:p>
-        </p:txBody>
-      </p:sp>
-      <p:sp>
-        <p:nvSpPr>
-          <p:cNvPr id="3" name="Content Placeholder 2"/>
-          <p:cNvSpPr>
-            <a:spLocks noGrp="1"/>
-          </p:cNvSpPr>
-          <p:nvPr>
-            <p:ph idx="1"/>
-          </p:nvPr>
-        </p:nvSpPr>
-        <p:spPr/>
-        <p:txBody>
-          <a:bodyPr/>
+          <p:cNvPr id="2" name="Rectangle 1"/>
+          <p:cNvSpPr/>
+          <p:nvPr/>
+        </p:nvSpPr>
+        <p:spPr>
+          <a:xfrm>
+            <a:off x="0" y="0"/>
+            <a:ext cx="12191695" cy="6858000"/>
+          </a:xfrm>
+          <a:prstGeom prst="rect">
+            <a:avLst/>
+          </a:prstGeom>
+          <a:solidFill>
+            <a:srgbClr val="F6F8F4"/>
+          </a:solidFill>
+          <a:ln>
+            <a:noFill/>
+          </a:ln>
+        </p:spPr>
+        <p:style>
+          <a:lnRef idx="1">
+            <a:schemeClr val="accent1"/>
+          </a:lnRef>
+          <a:fillRef idx="3">
+            <a:schemeClr val="accent1"/>
+          </a:fillRef>
+          <a:effectRef idx="2">
+            <a:schemeClr val="accent1"/>
+          </a:effectRef>
+          <a:fontRef idx="minor">
+            <a:schemeClr val="lt1"/>
+          </a:fontRef>
+        </p:style>
+        <p:txBody>
+          <a:bodyPr rtlCol="0" anchor="ctr"/>
+          <a:lstStyle/>
+          <a:p>
+            <a:pPr algn="ctr"/>
+          </a:p>
+        </p:txBody>
+      </p:sp>
+      <p:sp>
+        <p:nvSpPr>
+          <p:cNvPr id="3" name="Rectangle 2"/>
+          <p:cNvSpPr/>
+          <p:nvPr/>
+        </p:nvSpPr>
+        <p:spPr>
+          <a:xfrm>
+            <a:off x="0" y="0"/>
+            <a:ext cx="12191695" cy="777240"/>
+          </a:xfrm>
+          <a:prstGeom prst="rect">
+            <a:avLst/>
+          </a:prstGeom>
+          <a:solidFill>
+            <a:srgbClr val="123524"/>
+          </a:solidFill>
+          <a:ln>
+            <a:noFill/>
+          </a:ln>
+        </p:spPr>
+        <p:style>
+          <a:lnRef idx="1">
+            <a:schemeClr val="accent1"/>
+          </a:lnRef>
+          <a:fillRef idx="3">
+            <a:schemeClr val="accent1"/>
+          </a:fillRef>
+          <a:effectRef idx="2">
+            <a:schemeClr val="accent1"/>
+          </a:effectRef>
+          <a:fontRef idx="minor">
+            <a:schemeClr val="lt1"/>
+          </a:fontRef>
+        </p:style>
+        <p:txBody>
+          <a:bodyPr rtlCol="0" anchor="ctr"/>
+          <a:lstStyle/>
+          <a:p>
+            <a:pPr algn="ctr"/>
+          </a:p>
+        </p:txBody>
+      </p:sp>
+      <p:sp>
+        <p:nvSpPr>
+          <p:cNvPr id="4" name="TextBox 3"/>
+          <p:cNvSpPr txBox="1"/>
+          <p:nvPr/>
+        </p:nvSpPr>
+        <p:spPr>
+          <a:xfrm>
+            <a:off x="502920" y="146304"/>
+            <a:ext cx="8961120" cy="457200"/>
+          </a:xfrm>
+          <a:prstGeom prst="rect">
+            <a:avLst/>
+          </a:prstGeom>
+          <a:noFill/>
+        </p:spPr>
+        <p:txBody>
+          <a:bodyPr wrap="none">
+            <a:spAutoFit/>
+          </a:bodyPr>
           <a:lstStyle/>
           <a:p>
             <a:pPr>
-              <a:defRPr sz="2200"/>
-            </a:pPr>
-            <a:r>
-              <a:t>Official Meilisearch docs: FAQ, known limits, configuration, performance, security, deployment, editions, sharding/replication</a:t>
-            </a:r>
-          </a:p>
+              <a:defRPr sz="2400" b="1">
+                <a:solidFill>
+                  <a:srgbClr val="FFFFFF"/>
+                </a:solidFill>
+              </a:defRPr>
+            </a:pPr>
+            <a:r>
+              <a:t>References</a:t>
+            </a:r>
+          </a:p>
+        </p:txBody>
+      </p:sp>
+      <p:sp>
+        <p:nvSpPr>
+          <p:cNvPr id="5" name="TextBox 4"/>
+          <p:cNvSpPr txBox="1"/>
+          <p:nvPr/>
+        </p:nvSpPr>
+        <p:spPr>
+          <a:xfrm>
+            <a:off x="10332720" y="182880"/>
+            <a:ext cx="1645920" cy="320040"/>
+          </a:xfrm>
+          <a:prstGeom prst="rect">
+            <a:avLst/>
+          </a:prstGeom>
+          <a:noFill/>
+        </p:spPr>
+        <p:txBody>
+          <a:bodyPr wrap="none">
+            <a:spAutoFit/>
+          </a:bodyPr>
+          <a:lstStyle/>
+          <a:p>
+            <a:pPr algn="r">
+              <a:defRPr sz="1000">
+                <a:solidFill>
+                  <a:srgbClr val="DCE9E2"/>
+                </a:solidFill>
+              </a:defRPr>
+            </a:pPr>
+            <a:r>
+              <a:t>Olam Agri | Research Brief</a:t>
+            </a:r>
+          </a:p>
+        </p:txBody>
+      </p:sp>
+      <p:sp>
+        <p:nvSpPr>
+          <p:cNvPr id="6" name="TextBox 5"/>
+          <p:cNvSpPr txBox="1"/>
+          <p:nvPr/>
+        </p:nvSpPr>
+        <p:spPr>
+          <a:xfrm>
+            <a:off x="640080" y="987552"/>
+            <a:ext cx="10972800" cy="502920"/>
+          </a:xfrm>
+          <a:prstGeom prst="rect">
+            <a:avLst/>
+          </a:prstGeom>
+          <a:noFill/>
+        </p:spPr>
+        <p:txBody>
+          <a:bodyPr wrap="none">
+            <a:spAutoFit/>
+          </a:bodyPr>
+          <a:lstStyle/>
           <a:p>
             <a:pPr>
-              <a:defRPr sz="2200"/>
-            </a:pPr>
-            <a:r>
-              <a:t>Input references reviewed: two provided Meilisearch-Olam PDFs</a:t>
-            </a:r>
-          </a:p>
+              <a:defRPr sz="1600">
+                <a:solidFill>
+                  <a:srgbClr val="586E61"/>
+                </a:solidFill>
+              </a:defRPr>
+            </a:pPr>
+            <a:r>
+              <a:t>Primary documentation used in this technical brief.</a:t>
+            </a:r>
+          </a:p>
+        </p:txBody>
+      </p:sp>
+      <p:sp>
+        <p:nvSpPr>
+          <p:cNvPr id="7" name="Rounded Rectangle 6"/>
+          <p:cNvSpPr/>
+          <p:nvPr/>
+        </p:nvSpPr>
+        <p:spPr>
+          <a:xfrm>
+            <a:off x="548640" y="1508760"/>
+            <a:ext cx="11064240" cy="4892040"/>
+          </a:xfrm>
+          <a:prstGeom prst="roundRect">
+            <a:avLst/>
+          </a:prstGeom>
+          <a:solidFill>
+            <a:srgbClr val="FFFFFF"/>
+          </a:solidFill>
+          <a:ln>
+            <a:solidFill>
+              <a:srgbClr val="D8E1DA"/>
+            </a:solidFill>
+          </a:ln>
+        </p:spPr>
+        <p:style>
+          <a:lnRef idx="1">
+            <a:schemeClr val="accent1"/>
+          </a:lnRef>
+          <a:fillRef idx="3">
+            <a:schemeClr val="accent1"/>
+          </a:fillRef>
+          <a:effectRef idx="2">
+            <a:schemeClr val="accent1"/>
+          </a:effectRef>
+          <a:fontRef idx="minor">
+            <a:schemeClr val="lt1"/>
+          </a:fontRef>
+        </p:style>
+        <p:txBody>
+          <a:bodyPr rtlCol="0" anchor="ctr"/>
+          <a:lstStyle/>
+          <a:p>
+            <a:pPr algn="ctr"/>
+          </a:p>
+        </p:txBody>
+      </p:sp>
+      <p:sp>
+        <p:nvSpPr>
+          <p:cNvPr id="8" name="TextBox 7"/>
+          <p:cNvSpPr txBox="1"/>
+          <p:nvPr/>
+        </p:nvSpPr>
+        <p:spPr>
+          <a:xfrm>
+            <a:off x="914400" y="1828800"/>
+            <a:ext cx="10332720" cy="4297680"/>
+          </a:xfrm>
+          <a:prstGeom prst="rect">
+            <a:avLst/>
+          </a:prstGeom>
+          <a:noFill/>
+        </p:spPr>
+        <p:txBody>
+          <a:bodyPr wrap="square">
+            <a:spAutoFit/>
+          </a:bodyPr>
+          <a:lstStyle/>
           <a:p>
             <a:pPr>
-              <a:defRPr sz="2200"/>
-            </a:pPr>
-            <a:r>
-              <a:t>Presentation content includes only validated or clearly marked assumptions</a:t>
+              <a:spcAft>
+                <a:spcPts val="1000"/>
+              </a:spcAft>
+              <a:defRPr sz="2200">
+                <a:solidFill>
+                  <a:srgbClr val="23372A"/>
+                </a:solidFill>
+              </a:defRPr>
+            </a:pPr>
+            <a:r>
+              <a:t>Meilisearch: FAQ, Known Limitations, Configuration Reference</a:t>
+            </a:r>
+          </a:p>
+          <a:p>
+            <a:pPr>
+              <a:spcAft>
+                <a:spcPts val="1000"/>
+              </a:spcAft>
+              <a:defRPr sz="2200">
+                <a:solidFill>
+                  <a:srgbClr val="23372A"/>
+                </a:solidFill>
+              </a:defRPr>
+            </a:pPr>
+            <a:r>
+              <a:t>Meilisearch: RAM/Threading performance guidance, Docker and local install guides</a:t>
+            </a:r>
+          </a:p>
+          <a:p>
+            <a:pPr>
+              <a:spcAft>
+                <a:spcPts val="1000"/>
+              </a:spcAft>
+              <a:defRPr sz="2200">
+                <a:solidFill>
+                  <a:srgbClr val="23372A"/>
+                </a:solidFill>
+              </a:defRPr>
+            </a:pPr>
+            <a:r>
+              <a:t>Meilisearch: Security &amp; tenant tokens, Community vs Enterprise, sharding/replication overview</a:t>
             </a:r>
           </a:p>
         </p:txBody>
@@ -3244,69 +3682,304 @@
       <p:grpSpPr/>
       <p:sp>
         <p:nvSpPr>
-          <p:cNvPr id="2" name="Title 1"/>
-          <p:cNvSpPr>
-            <a:spLocks noGrp="1"/>
-          </p:cNvSpPr>
-          <p:nvPr>
-            <p:ph type="title"/>
-          </p:nvPr>
-        </p:nvSpPr>
-        <p:spPr/>
-        <p:txBody>
-          <a:bodyPr/>
-          <a:lstStyle/>
-          <a:p>
-            <a:r>
-              <a:t>1) What was validated</a:t>
-            </a:r>
-          </a:p>
-        </p:txBody>
-      </p:sp>
-      <p:sp>
-        <p:nvSpPr>
-          <p:cNvPr id="3" name="Content Placeholder 2"/>
-          <p:cNvSpPr>
-            <a:spLocks noGrp="1"/>
-          </p:cNvSpPr>
-          <p:nvPr>
-            <p:ph idx="1"/>
-          </p:nvPr>
-        </p:nvSpPr>
-        <p:spPr/>
-        <p:txBody>
-          <a:bodyPr/>
+          <p:cNvPr id="2" name="Rectangle 1"/>
+          <p:cNvSpPr/>
+          <p:nvPr/>
+        </p:nvSpPr>
+        <p:spPr>
+          <a:xfrm>
+            <a:off x="0" y="0"/>
+            <a:ext cx="12191695" cy="6858000"/>
+          </a:xfrm>
+          <a:prstGeom prst="rect">
+            <a:avLst/>
+          </a:prstGeom>
+          <a:solidFill>
+            <a:srgbClr val="F6F8F4"/>
+          </a:solidFill>
+          <a:ln>
+            <a:noFill/>
+          </a:ln>
+        </p:spPr>
+        <p:style>
+          <a:lnRef idx="1">
+            <a:schemeClr val="accent1"/>
+          </a:lnRef>
+          <a:fillRef idx="3">
+            <a:schemeClr val="accent1"/>
+          </a:fillRef>
+          <a:effectRef idx="2">
+            <a:schemeClr val="accent1"/>
+          </a:effectRef>
+          <a:fontRef idx="minor">
+            <a:schemeClr val="lt1"/>
+          </a:fontRef>
+        </p:style>
+        <p:txBody>
+          <a:bodyPr rtlCol="0" anchor="ctr"/>
+          <a:lstStyle/>
+          <a:p>
+            <a:pPr algn="ctr"/>
+          </a:p>
+        </p:txBody>
+      </p:sp>
+      <p:sp>
+        <p:nvSpPr>
+          <p:cNvPr id="3" name="Rectangle 2"/>
+          <p:cNvSpPr/>
+          <p:nvPr/>
+        </p:nvSpPr>
+        <p:spPr>
+          <a:xfrm>
+            <a:off x="0" y="0"/>
+            <a:ext cx="12191695" cy="777240"/>
+          </a:xfrm>
+          <a:prstGeom prst="rect">
+            <a:avLst/>
+          </a:prstGeom>
+          <a:solidFill>
+            <a:srgbClr val="123524"/>
+          </a:solidFill>
+          <a:ln>
+            <a:noFill/>
+          </a:ln>
+        </p:spPr>
+        <p:style>
+          <a:lnRef idx="1">
+            <a:schemeClr val="accent1"/>
+          </a:lnRef>
+          <a:fillRef idx="3">
+            <a:schemeClr val="accent1"/>
+          </a:fillRef>
+          <a:effectRef idx="2">
+            <a:schemeClr val="accent1"/>
+          </a:effectRef>
+          <a:fontRef idx="minor">
+            <a:schemeClr val="lt1"/>
+          </a:fontRef>
+        </p:style>
+        <p:txBody>
+          <a:bodyPr rtlCol="0" anchor="ctr"/>
+          <a:lstStyle/>
+          <a:p>
+            <a:pPr algn="ctr"/>
+          </a:p>
+        </p:txBody>
+      </p:sp>
+      <p:sp>
+        <p:nvSpPr>
+          <p:cNvPr id="4" name="TextBox 3"/>
+          <p:cNvSpPr txBox="1"/>
+          <p:nvPr/>
+        </p:nvSpPr>
+        <p:spPr>
+          <a:xfrm>
+            <a:off x="502920" y="146304"/>
+            <a:ext cx="8961120" cy="457200"/>
+          </a:xfrm>
+          <a:prstGeom prst="rect">
+            <a:avLst/>
+          </a:prstGeom>
+          <a:noFill/>
+        </p:spPr>
+        <p:txBody>
+          <a:bodyPr wrap="none">
+            <a:spAutoFit/>
+          </a:bodyPr>
           <a:lstStyle/>
           <a:p>
             <a:pPr>
-              <a:defRPr sz="2200"/>
-            </a:pPr>
-            <a:r>
-              <a:t>Reviewed both provided PDFs and extracted technical claims</a:t>
-            </a:r>
-          </a:p>
+              <a:defRPr sz="2400" b="1">
+                <a:solidFill>
+                  <a:srgbClr val="FFFFFF"/>
+                </a:solidFill>
+              </a:defRPr>
+            </a:pPr>
+            <a:r>
+              <a:t>Executive Position</a:t>
+            </a:r>
+          </a:p>
+        </p:txBody>
+      </p:sp>
+      <p:sp>
+        <p:nvSpPr>
+          <p:cNvPr id="5" name="TextBox 4"/>
+          <p:cNvSpPr txBox="1"/>
+          <p:nvPr/>
+        </p:nvSpPr>
+        <p:spPr>
+          <a:xfrm>
+            <a:off x="10332720" y="182880"/>
+            <a:ext cx="1645920" cy="320040"/>
+          </a:xfrm>
+          <a:prstGeom prst="rect">
+            <a:avLst/>
+          </a:prstGeom>
+          <a:noFill/>
+        </p:spPr>
+        <p:txBody>
+          <a:bodyPr wrap="none">
+            <a:spAutoFit/>
+          </a:bodyPr>
+          <a:lstStyle/>
+          <a:p>
+            <a:pPr algn="r">
+              <a:defRPr sz="1000">
+                <a:solidFill>
+                  <a:srgbClr val="DCE9E2"/>
+                </a:solidFill>
+              </a:defRPr>
+            </a:pPr>
+            <a:r>
+              <a:t>Olam Agri | Research Brief</a:t>
+            </a:r>
+          </a:p>
+        </p:txBody>
+      </p:sp>
+      <p:sp>
+        <p:nvSpPr>
+          <p:cNvPr id="6" name="TextBox 5"/>
+          <p:cNvSpPr txBox="1"/>
+          <p:nvPr/>
+        </p:nvSpPr>
+        <p:spPr>
+          <a:xfrm>
+            <a:off x="640080" y="987552"/>
+            <a:ext cx="10972800" cy="502920"/>
+          </a:xfrm>
+          <a:prstGeom prst="rect">
+            <a:avLst/>
+          </a:prstGeom>
+          <a:noFill/>
+        </p:spPr>
+        <p:txBody>
+          <a:bodyPr wrap="none">
+            <a:spAutoFit/>
+          </a:bodyPr>
+          <a:lstStyle/>
           <a:p>
             <a:pPr>
-              <a:defRPr sz="2200"/>
-            </a:pPr>
-            <a:r>
-              <a:t>Cross-checked critical claims against official Meilisearch documentation</a:t>
-            </a:r>
-          </a:p>
+              <a:defRPr sz="1600">
+                <a:solidFill>
+                  <a:srgbClr val="586E61"/>
+                </a:solidFill>
+              </a:defRPr>
+            </a:pPr>
+            <a:r>
+              <a:t>Meilisearch is viable for Olam Agri interactive retrieval if integrated as a governed search layer.</a:t>
+            </a:r>
+          </a:p>
+        </p:txBody>
+      </p:sp>
+      <p:sp>
+        <p:nvSpPr>
+          <p:cNvPr id="7" name="Rounded Rectangle 6"/>
+          <p:cNvSpPr/>
+          <p:nvPr/>
+        </p:nvSpPr>
+        <p:spPr>
+          <a:xfrm>
+            <a:off x="548640" y="1508760"/>
+            <a:ext cx="11064240" cy="4892040"/>
+          </a:xfrm>
+          <a:prstGeom prst="roundRect">
+            <a:avLst/>
+          </a:prstGeom>
+          <a:solidFill>
+            <a:srgbClr val="FFFFFF"/>
+          </a:solidFill>
+          <a:ln>
+            <a:solidFill>
+              <a:srgbClr val="D8E1DA"/>
+            </a:solidFill>
+          </a:ln>
+        </p:spPr>
+        <p:style>
+          <a:lnRef idx="1">
+            <a:schemeClr val="accent1"/>
+          </a:lnRef>
+          <a:fillRef idx="3">
+            <a:schemeClr val="accent1"/>
+          </a:fillRef>
+          <a:effectRef idx="2">
+            <a:schemeClr val="accent1"/>
+          </a:effectRef>
+          <a:fontRef idx="minor">
+            <a:schemeClr val="lt1"/>
+          </a:fontRef>
+        </p:style>
+        <p:txBody>
+          <a:bodyPr rtlCol="0" anchor="ctr"/>
+          <a:lstStyle/>
+          <a:p>
+            <a:pPr algn="ctr"/>
+          </a:p>
+        </p:txBody>
+      </p:sp>
+      <p:sp>
+        <p:nvSpPr>
+          <p:cNvPr id="8" name="TextBox 7"/>
+          <p:cNvSpPr txBox="1"/>
+          <p:nvPr/>
+        </p:nvSpPr>
+        <p:spPr>
+          <a:xfrm>
+            <a:off x="914400" y="1828800"/>
+            <a:ext cx="10332720" cy="4297680"/>
+          </a:xfrm>
+          <a:prstGeom prst="rect">
+            <a:avLst/>
+          </a:prstGeom>
+          <a:noFill/>
+        </p:spPr>
+        <p:txBody>
+          <a:bodyPr wrap="square">
+            <a:spAutoFit/>
+          </a:bodyPr>
+          <a:lstStyle/>
           <a:p>
             <a:pPr>
-              <a:defRPr sz="2200"/>
-            </a:pPr>
-            <a:r>
-              <a:t>Kept only verifiable points for decision-making</a:t>
+              <a:spcAft>
+                <a:spcPts val="1000"/>
+              </a:spcAft>
+              <a:defRPr sz="2200">
+                <a:solidFill>
+                  <a:srgbClr val="23372A"/>
+                </a:solidFill>
+              </a:defRPr>
+            </a:pPr>
+            <a:r>
+              <a:t>Use middleware-centric ingestion rather than direct source-to-search writes</a:t>
             </a:r>
           </a:p>
           <a:p>
             <a:pPr>
-              <a:defRPr sz="2200"/>
-            </a:pPr>
-            <a:r>
-              <a:t>Flagged assumptions that need Olam internal confirmation</a:t>
+              <a:spcAft>
+                <a:spcPts val="1000"/>
+              </a:spcAft>
+              <a:defRPr sz="2200">
+                <a:solidFill>
+                  <a:srgbClr val="23372A"/>
+                </a:solidFill>
+              </a:defRPr>
+            </a:pPr>
+            <a:r>
+              <a:t>Treat indexing controls as production safeguards, not optional tuning</a:t>
+            </a:r>
+          </a:p>
+          <a:p>
+            <a:pPr>
+              <a:spcAft>
+                <a:spcPts val="1000"/>
+              </a:spcAft>
+              <a:defRPr sz="2200">
+                <a:solidFill>
+                  <a:srgbClr val="23372A"/>
+                </a:solidFill>
+              </a:defRPr>
+            </a:pPr>
+            <a:r>
+              <a:t>Decide early whether HA/horizontal scale requires Enterprise Edition</a:t>
             </a:r>
           </a:p>
         </p:txBody>
@@ -3331,69 +4004,304 @@
       <p:grpSpPr/>
       <p:sp>
         <p:nvSpPr>
-          <p:cNvPr id="2" name="Title 1"/>
-          <p:cNvSpPr>
-            <a:spLocks noGrp="1"/>
-          </p:cNvSpPr>
-          <p:nvPr>
-            <p:ph type="title"/>
-          </p:nvPr>
-        </p:nvSpPr>
-        <p:spPr/>
-        <p:txBody>
-          <a:bodyPr/>
-          <a:lstStyle/>
-          <a:p>
-            <a:r>
-              <a:t>2) Will performance go down?</a:t>
-            </a:r>
-          </a:p>
-        </p:txBody>
-      </p:sp>
-      <p:sp>
-        <p:nvSpPr>
-          <p:cNvPr id="3" name="Content Placeholder 2"/>
-          <p:cNvSpPr>
-            <a:spLocks noGrp="1"/>
-          </p:cNvSpPr>
-          <p:nvPr>
-            <p:ph idx="1"/>
-          </p:nvPr>
-        </p:nvSpPr>
-        <p:spPr/>
-        <p:txBody>
-          <a:bodyPr/>
+          <p:cNvPr id="2" name="Rectangle 1"/>
+          <p:cNvSpPr/>
+          <p:nvPr/>
+        </p:nvSpPr>
+        <p:spPr>
+          <a:xfrm>
+            <a:off x="0" y="0"/>
+            <a:ext cx="12191695" cy="6858000"/>
+          </a:xfrm>
+          <a:prstGeom prst="rect">
+            <a:avLst/>
+          </a:prstGeom>
+          <a:solidFill>
+            <a:srgbClr val="F6F8F4"/>
+          </a:solidFill>
+          <a:ln>
+            <a:noFill/>
+          </a:ln>
+        </p:spPr>
+        <p:style>
+          <a:lnRef idx="1">
+            <a:schemeClr val="accent1"/>
+          </a:lnRef>
+          <a:fillRef idx="3">
+            <a:schemeClr val="accent1"/>
+          </a:fillRef>
+          <a:effectRef idx="2">
+            <a:schemeClr val="accent1"/>
+          </a:effectRef>
+          <a:fontRef idx="minor">
+            <a:schemeClr val="lt1"/>
+          </a:fontRef>
+        </p:style>
+        <p:txBody>
+          <a:bodyPr rtlCol="0" anchor="ctr"/>
+          <a:lstStyle/>
+          <a:p>
+            <a:pPr algn="ctr"/>
+          </a:p>
+        </p:txBody>
+      </p:sp>
+      <p:sp>
+        <p:nvSpPr>
+          <p:cNvPr id="3" name="Rectangle 2"/>
+          <p:cNvSpPr/>
+          <p:nvPr/>
+        </p:nvSpPr>
+        <p:spPr>
+          <a:xfrm>
+            <a:off x="0" y="0"/>
+            <a:ext cx="12191695" cy="777240"/>
+          </a:xfrm>
+          <a:prstGeom prst="rect">
+            <a:avLst/>
+          </a:prstGeom>
+          <a:solidFill>
+            <a:srgbClr val="123524"/>
+          </a:solidFill>
+          <a:ln>
+            <a:noFill/>
+          </a:ln>
+        </p:spPr>
+        <p:style>
+          <a:lnRef idx="1">
+            <a:schemeClr val="accent1"/>
+          </a:lnRef>
+          <a:fillRef idx="3">
+            <a:schemeClr val="accent1"/>
+          </a:fillRef>
+          <a:effectRef idx="2">
+            <a:schemeClr val="accent1"/>
+          </a:effectRef>
+          <a:fontRef idx="minor">
+            <a:schemeClr val="lt1"/>
+          </a:fontRef>
+        </p:style>
+        <p:txBody>
+          <a:bodyPr rtlCol="0" anchor="ctr"/>
+          <a:lstStyle/>
+          <a:p>
+            <a:pPr algn="ctr"/>
+          </a:p>
+        </p:txBody>
+      </p:sp>
+      <p:sp>
+        <p:nvSpPr>
+          <p:cNvPr id="4" name="TextBox 3"/>
+          <p:cNvSpPr txBox="1"/>
+          <p:nvPr/>
+        </p:nvSpPr>
+        <p:spPr>
+          <a:xfrm>
+            <a:off x="502920" y="146304"/>
+            <a:ext cx="8961120" cy="457200"/>
+          </a:xfrm>
+          <a:prstGeom prst="rect">
+            <a:avLst/>
+          </a:prstGeom>
+          <a:noFill/>
+        </p:spPr>
+        <p:txBody>
+          <a:bodyPr wrap="none">
+            <a:spAutoFit/>
+          </a:bodyPr>
           <a:lstStyle/>
           <a:p>
             <a:pPr>
-              <a:defRPr sz="2200"/>
-            </a:pPr>
-            <a:r>
-              <a:t>Possible during heavy indexing if unmanaged</a:t>
-            </a:r>
-          </a:p>
+              <a:defRPr sz="2400" b="1">
+                <a:solidFill>
+                  <a:srgbClr val="FFFFFF"/>
+                </a:solidFill>
+              </a:defRPr>
+            </a:pPr>
+            <a:r>
+              <a:t>Reference Architecture</a:t>
+            </a:r>
+          </a:p>
+        </p:txBody>
+      </p:sp>
+      <p:sp>
+        <p:nvSpPr>
+          <p:cNvPr id="5" name="TextBox 4"/>
+          <p:cNvSpPr txBox="1"/>
+          <p:nvPr/>
+        </p:nvSpPr>
+        <p:spPr>
+          <a:xfrm>
+            <a:off x="10332720" y="182880"/>
+            <a:ext cx="1645920" cy="320040"/>
+          </a:xfrm>
+          <a:prstGeom prst="rect">
+            <a:avLst/>
+          </a:prstGeom>
+          <a:noFill/>
+        </p:spPr>
+        <p:txBody>
+          <a:bodyPr wrap="none">
+            <a:spAutoFit/>
+          </a:bodyPr>
+          <a:lstStyle/>
+          <a:p>
+            <a:pPr algn="r">
+              <a:defRPr sz="1000">
+                <a:solidFill>
+                  <a:srgbClr val="DCE9E2"/>
+                </a:solidFill>
+              </a:defRPr>
+            </a:pPr>
+            <a:r>
+              <a:t>Olam Agri | Research Brief</a:t>
+            </a:r>
+          </a:p>
+        </p:txBody>
+      </p:sp>
+      <p:sp>
+        <p:nvSpPr>
+          <p:cNvPr id="6" name="TextBox 5"/>
+          <p:cNvSpPr txBox="1"/>
+          <p:nvPr/>
+        </p:nvSpPr>
+        <p:spPr>
+          <a:xfrm>
+            <a:off x="640080" y="987552"/>
+            <a:ext cx="10972800" cy="502920"/>
+          </a:xfrm>
+          <a:prstGeom prst="rect">
+            <a:avLst/>
+          </a:prstGeom>
+          <a:noFill/>
+        </p:spPr>
+        <p:txBody>
+          <a:bodyPr wrap="none">
+            <a:spAutoFit/>
+          </a:bodyPr>
+          <a:lstStyle/>
           <a:p>
             <a:pPr>
-              <a:defRPr sz="2200"/>
-            </a:pPr>
-            <a:r>
-              <a:t>Indexing is memory- and CPU-intensive by design</a:t>
-            </a:r>
-          </a:p>
+              <a:defRPr sz="1600">
+                <a:solidFill>
+                  <a:srgbClr val="586E61"/>
+                </a:solidFill>
+              </a:defRPr>
+            </a:pPr>
+            <a:r>
+              <a:t>Data should move through a transformation and orchestration layer before indexing.</a:t>
+            </a:r>
+          </a:p>
+        </p:txBody>
+      </p:sp>
+      <p:sp>
+        <p:nvSpPr>
+          <p:cNvPr id="7" name="Rounded Rectangle 6"/>
+          <p:cNvSpPr/>
+          <p:nvPr/>
+        </p:nvSpPr>
+        <p:spPr>
+          <a:xfrm>
+            <a:off x="548640" y="1508760"/>
+            <a:ext cx="11064240" cy="4892040"/>
+          </a:xfrm>
+          <a:prstGeom prst="roundRect">
+            <a:avLst/>
+          </a:prstGeom>
+          <a:solidFill>
+            <a:srgbClr val="FFFFFF"/>
+          </a:solidFill>
+          <a:ln>
+            <a:solidFill>
+              <a:srgbClr val="D8E1DA"/>
+            </a:solidFill>
+          </a:ln>
+        </p:spPr>
+        <p:style>
+          <a:lnRef idx="1">
+            <a:schemeClr val="accent1"/>
+          </a:lnRef>
+          <a:fillRef idx="3">
+            <a:schemeClr val="accent1"/>
+          </a:fillRef>
+          <a:effectRef idx="2">
+            <a:schemeClr val="accent1"/>
+          </a:effectRef>
+          <a:fontRef idx="minor">
+            <a:schemeClr val="lt1"/>
+          </a:fontRef>
+        </p:style>
+        <p:txBody>
+          <a:bodyPr rtlCol="0" anchor="ctr"/>
+          <a:lstStyle/>
+          <a:p>
+            <a:pPr algn="ctr"/>
+          </a:p>
+        </p:txBody>
+      </p:sp>
+      <p:sp>
+        <p:nvSpPr>
+          <p:cNvPr id="8" name="TextBox 7"/>
+          <p:cNvSpPr txBox="1"/>
+          <p:nvPr/>
+        </p:nvSpPr>
+        <p:spPr>
+          <a:xfrm>
+            <a:off x="914400" y="1828800"/>
+            <a:ext cx="10332720" cy="4297680"/>
+          </a:xfrm>
+          <a:prstGeom prst="rect">
+            <a:avLst/>
+          </a:prstGeom>
+          <a:noFill/>
+        </p:spPr>
+        <p:txBody>
+          <a:bodyPr wrap="square">
+            <a:spAutoFit/>
+          </a:bodyPr>
+          <a:lstStyle/>
           <a:p>
             <a:pPr>
-              <a:defRPr sz="2200"/>
-            </a:pPr>
-            <a:r>
-              <a:t>Search quality can degrade during large updates without controls</a:t>
+              <a:spcAft>
+                <a:spcPts val="1000"/>
+              </a:spcAft>
+              <a:defRPr sz="2200">
+                <a:solidFill>
+                  <a:srgbClr val="23372A"/>
+                </a:solidFill>
+              </a:defRPr>
+            </a:pPr>
+            <a:r>
+              <a:t>Source systems (SAP and adjacent platforms) remain systems of record</a:t>
             </a:r>
           </a:p>
           <a:p>
             <a:pPr>
-              <a:defRPr sz="2200"/>
-            </a:pPr>
-            <a:r>
-              <a:t>Mitigation: bound indexing memory/threads + use controlled batch ingestion</a:t>
+              <a:spcAft>
+                <a:spcPts val="1000"/>
+              </a:spcAft>
+              <a:defRPr sz="2200">
+                <a:solidFill>
+                  <a:srgbClr val="23372A"/>
+                </a:solidFill>
+              </a:defRPr>
+            </a:pPr>
+            <a:r>
+              <a:t>Middleware performs denormalization, enrichment, and idempotent update handling</a:t>
+            </a:r>
+          </a:p>
+          <a:p>
+            <a:pPr>
+              <a:spcAft>
+                <a:spcPts val="1000"/>
+              </a:spcAft>
+              <a:defRPr sz="2200">
+                <a:solidFill>
+                  <a:srgbClr val="23372A"/>
+                </a:solidFill>
+              </a:defRPr>
+            </a:pPr>
+            <a:r>
+              <a:t>Applications query Meilisearch for low-latency retrieval paths</a:t>
             </a:r>
           </a:p>
         </p:txBody>
@@ -3418,77 +4326,452 @@
       <p:grpSpPr/>
       <p:sp>
         <p:nvSpPr>
-          <p:cNvPr id="2" name="Title 1"/>
-          <p:cNvSpPr>
-            <a:spLocks noGrp="1"/>
-          </p:cNvSpPr>
-          <p:nvPr>
-            <p:ph type="title"/>
-          </p:nvPr>
-        </p:nvSpPr>
-        <p:spPr/>
-        <p:txBody>
-          <a:bodyPr/>
-          <a:lstStyle/>
-          <a:p>
-            <a:r>
-              <a:t>3) Integration pattern for Olam Agri</a:t>
-            </a:r>
-          </a:p>
-        </p:txBody>
-      </p:sp>
-      <p:sp>
-        <p:nvSpPr>
-          <p:cNvPr id="3" name="Content Placeholder 2"/>
-          <p:cNvSpPr>
-            <a:spLocks noGrp="1"/>
-          </p:cNvSpPr>
-          <p:nvPr>
-            <p:ph idx="1"/>
-          </p:nvPr>
-        </p:nvSpPr>
-        <p:spPr/>
-        <p:txBody>
-          <a:bodyPr/>
+          <p:cNvPr id="2" name="Rectangle 1"/>
+          <p:cNvSpPr/>
+          <p:nvPr/>
+        </p:nvSpPr>
+        <p:spPr>
+          <a:xfrm>
+            <a:off x="0" y="0"/>
+            <a:ext cx="12191695" cy="6858000"/>
+          </a:xfrm>
+          <a:prstGeom prst="rect">
+            <a:avLst/>
+          </a:prstGeom>
+          <a:solidFill>
+            <a:srgbClr val="F6F8F4"/>
+          </a:solidFill>
+          <a:ln>
+            <a:noFill/>
+          </a:ln>
+        </p:spPr>
+        <p:style>
+          <a:lnRef idx="1">
+            <a:schemeClr val="accent1"/>
+          </a:lnRef>
+          <a:fillRef idx="3">
+            <a:schemeClr val="accent1"/>
+          </a:fillRef>
+          <a:effectRef idx="2">
+            <a:schemeClr val="accent1"/>
+          </a:effectRef>
+          <a:fontRef idx="minor">
+            <a:schemeClr val="lt1"/>
+          </a:fontRef>
+        </p:style>
+        <p:txBody>
+          <a:bodyPr rtlCol="0" anchor="ctr"/>
+          <a:lstStyle/>
+          <a:p>
+            <a:pPr algn="ctr"/>
+          </a:p>
+        </p:txBody>
+      </p:sp>
+      <p:sp>
+        <p:nvSpPr>
+          <p:cNvPr id="3" name="Rectangle 2"/>
+          <p:cNvSpPr/>
+          <p:nvPr/>
+        </p:nvSpPr>
+        <p:spPr>
+          <a:xfrm>
+            <a:off x="0" y="0"/>
+            <a:ext cx="12191695" cy="777240"/>
+          </a:xfrm>
+          <a:prstGeom prst="rect">
+            <a:avLst/>
+          </a:prstGeom>
+          <a:solidFill>
+            <a:srgbClr val="123524"/>
+          </a:solidFill>
+          <a:ln>
+            <a:noFill/>
+          </a:ln>
+        </p:spPr>
+        <p:style>
+          <a:lnRef idx="1">
+            <a:schemeClr val="accent1"/>
+          </a:lnRef>
+          <a:fillRef idx="3">
+            <a:schemeClr val="accent1"/>
+          </a:fillRef>
+          <a:effectRef idx="2">
+            <a:schemeClr val="accent1"/>
+          </a:effectRef>
+          <a:fontRef idx="minor">
+            <a:schemeClr val="lt1"/>
+          </a:fontRef>
+        </p:style>
+        <p:txBody>
+          <a:bodyPr rtlCol="0" anchor="ctr"/>
+          <a:lstStyle/>
+          <a:p>
+            <a:pPr algn="ctr"/>
+          </a:p>
+        </p:txBody>
+      </p:sp>
+      <p:sp>
+        <p:nvSpPr>
+          <p:cNvPr id="4" name="TextBox 3"/>
+          <p:cNvSpPr txBox="1"/>
+          <p:nvPr/>
+        </p:nvSpPr>
+        <p:spPr>
+          <a:xfrm>
+            <a:off x="502920" y="146304"/>
+            <a:ext cx="8961120" cy="457200"/>
+          </a:xfrm>
+          <a:prstGeom prst="rect">
+            <a:avLst/>
+          </a:prstGeom>
+          <a:noFill/>
+        </p:spPr>
+        <p:txBody>
+          <a:bodyPr wrap="none">
+            <a:spAutoFit/>
+          </a:bodyPr>
           <a:lstStyle/>
           <a:p>
             <a:pPr>
-              <a:defRPr sz="2200"/>
-            </a:pPr>
-            <a:r>
-              <a:t>SAP/operational systems  →  Middleware  →  Meilisearch  →  Applications</a:t>
-            </a:r>
-          </a:p>
+              <a:defRPr sz="2400" b="1">
+                <a:solidFill>
+                  <a:srgbClr val="FFFFFF"/>
+                </a:solidFill>
+              </a:defRPr>
+            </a:pPr>
+            <a:r>
+              <a:t>Performance and Resource Envelope</a:t>
+            </a:r>
+          </a:p>
+        </p:txBody>
+      </p:sp>
+      <p:sp>
+        <p:nvSpPr>
+          <p:cNvPr id="5" name="TextBox 4"/>
+          <p:cNvSpPr txBox="1"/>
+          <p:nvPr/>
+        </p:nvSpPr>
+        <p:spPr>
+          <a:xfrm>
+            <a:off x="10332720" y="182880"/>
+            <a:ext cx="1645920" cy="320040"/>
+          </a:xfrm>
+          <a:prstGeom prst="rect">
+            <a:avLst/>
+          </a:prstGeom>
+          <a:noFill/>
+        </p:spPr>
+        <p:txBody>
+          <a:bodyPr wrap="none">
+            <a:spAutoFit/>
+          </a:bodyPr>
+          <a:lstStyle/>
+          <a:p>
+            <a:pPr algn="r">
+              <a:defRPr sz="1000">
+                <a:solidFill>
+                  <a:srgbClr val="DCE9E2"/>
+                </a:solidFill>
+              </a:defRPr>
+            </a:pPr>
+            <a:r>
+              <a:t>Olam Agri | Research Brief</a:t>
+            </a:r>
+          </a:p>
+        </p:txBody>
+      </p:sp>
+      <p:sp>
+        <p:nvSpPr>
+          <p:cNvPr id="6" name="Rounded Rectangle 5"/>
+          <p:cNvSpPr/>
+          <p:nvPr/>
+        </p:nvSpPr>
+        <p:spPr>
+          <a:xfrm>
+            <a:off x="548640" y="1188720"/>
+            <a:ext cx="5440680" cy="5440680"/>
+          </a:xfrm>
+          <a:prstGeom prst="roundRect">
+            <a:avLst/>
+          </a:prstGeom>
+          <a:solidFill>
+            <a:srgbClr val="FFFFFF"/>
+          </a:solidFill>
+          <a:ln>
+            <a:solidFill>
+              <a:srgbClr val="D8E1DA"/>
+            </a:solidFill>
+          </a:ln>
+        </p:spPr>
+        <p:style>
+          <a:lnRef idx="1">
+            <a:schemeClr val="accent1"/>
+          </a:lnRef>
+          <a:fillRef idx="3">
+            <a:schemeClr val="accent1"/>
+          </a:fillRef>
+          <a:effectRef idx="2">
+            <a:schemeClr val="accent1"/>
+          </a:effectRef>
+          <a:fontRef idx="minor">
+            <a:schemeClr val="lt1"/>
+          </a:fontRef>
+        </p:style>
+        <p:txBody>
+          <a:bodyPr rtlCol="0" anchor="ctr"/>
+          <a:lstStyle/>
+          <a:p>
+            <a:pPr algn="ctr"/>
+          </a:p>
+        </p:txBody>
+      </p:sp>
+      <p:sp>
+        <p:nvSpPr>
+          <p:cNvPr id="7" name="Rounded Rectangle 6"/>
+          <p:cNvSpPr/>
+          <p:nvPr/>
+        </p:nvSpPr>
+        <p:spPr>
+          <a:xfrm>
+            <a:off x="6172200" y="1188720"/>
+            <a:ext cx="5440680" cy="5440680"/>
+          </a:xfrm>
+          <a:prstGeom prst="roundRect">
+            <a:avLst/>
+          </a:prstGeom>
+          <a:solidFill>
+            <a:srgbClr val="FFFFFF"/>
+          </a:solidFill>
+          <a:ln>
+            <a:solidFill>
+              <a:srgbClr val="D8E1DA"/>
+            </a:solidFill>
+          </a:ln>
+        </p:spPr>
+        <p:style>
+          <a:lnRef idx="1">
+            <a:schemeClr val="accent1"/>
+          </a:lnRef>
+          <a:fillRef idx="3">
+            <a:schemeClr val="accent1"/>
+          </a:fillRef>
+          <a:effectRef idx="2">
+            <a:schemeClr val="accent1"/>
+          </a:effectRef>
+          <a:fontRef idx="minor">
+            <a:schemeClr val="lt1"/>
+          </a:fontRef>
+        </p:style>
+        <p:txBody>
+          <a:bodyPr rtlCol="0" anchor="ctr"/>
+          <a:lstStyle/>
+          <a:p>
+            <a:pPr algn="ctr"/>
+          </a:p>
+        </p:txBody>
+      </p:sp>
+      <p:sp>
+        <p:nvSpPr>
+          <p:cNvPr id="8" name="TextBox 7"/>
+          <p:cNvSpPr txBox="1"/>
+          <p:nvPr/>
+        </p:nvSpPr>
+        <p:spPr>
+          <a:xfrm>
+            <a:off x="868680" y="1417320"/>
+            <a:ext cx="4846320" cy="457200"/>
+          </a:xfrm>
+          <a:prstGeom prst="rect">
+            <a:avLst/>
+          </a:prstGeom>
+          <a:noFill/>
+        </p:spPr>
+        <p:txBody>
+          <a:bodyPr wrap="none">
+            <a:spAutoFit/>
+          </a:bodyPr>
+          <a:lstStyle/>
           <a:p>
             <a:pPr>
-              <a:defRPr sz="2200"/>
-            </a:pPr>
-            <a:r>
-              <a:t>Middleware responsibilities:</a:t>
-            </a:r>
-          </a:p>
+              <a:defRPr sz="1900" b="1">
+                <a:solidFill>
+                  <a:srgbClr val="2C5E42"/>
+                </a:solidFill>
+              </a:defRPr>
+            </a:pPr>
+            <a:r>
+              <a:t>Observed behavior to design for</a:t>
+            </a:r>
+          </a:p>
+        </p:txBody>
+      </p:sp>
+      <p:sp>
+        <p:nvSpPr>
+          <p:cNvPr id="9" name="TextBox 8"/>
+          <p:cNvSpPr txBox="1"/>
+          <p:nvPr/>
+        </p:nvSpPr>
+        <p:spPr>
+          <a:xfrm>
+            <a:off x="6492240" y="1417320"/>
+            <a:ext cx="4846320" cy="457200"/>
+          </a:xfrm>
+          <a:prstGeom prst="rect">
+            <a:avLst/>
+          </a:prstGeom>
+          <a:noFill/>
+        </p:spPr>
+        <p:txBody>
+          <a:bodyPr wrap="none">
+            <a:spAutoFit/>
+          </a:bodyPr>
+          <a:lstStyle/>
           <a:p>
             <a:pPr>
-              <a:defRPr sz="2200"/>
-            </a:pPr>
-            <a:r>
-              <a:t>Denormalize SAP relational data into search documents</a:t>
-            </a:r>
-          </a:p>
+              <a:defRPr sz="1900" b="1">
+                <a:solidFill>
+                  <a:srgbClr val="2C5E42"/>
+                </a:solidFill>
+              </a:defRPr>
+            </a:pPr>
+            <a:r>
+              <a:t>Operational controls</a:t>
+            </a:r>
+          </a:p>
+        </p:txBody>
+      </p:sp>
+      <p:sp>
+        <p:nvSpPr>
+          <p:cNvPr id="10" name="TextBox 9"/>
+          <p:cNvSpPr txBox="1"/>
+          <p:nvPr/>
+        </p:nvSpPr>
+        <p:spPr>
+          <a:xfrm>
+            <a:off x="868680" y="1920240"/>
+            <a:ext cx="4754880" cy="4389120"/>
+          </a:xfrm>
+          <a:prstGeom prst="rect">
+            <a:avLst/>
+          </a:prstGeom>
+          <a:noFill/>
+        </p:spPr>
+        <p:txBody>
+          <a:bodyPr wrap="none">
+            <a:spAutoFit/>
+          </a:bodyPr>
+          <a:lstStyle/>
           <a:p>
             <a:pPr>
-              <a:defRPr sz="2200"/>
-            </a:pPr>
-            <a:r>
-              <a:t>Run CDC/incremental sync and idempotent upserts</a:t>
+              <a:spcAft>
+                <a:spcPts val="800"/>
+              </a:spcAft>
+              <a:defRPr sz="1650">
+                <a:solidFill>
+                  <a:srgbClr val="283E31"/>
+                </a:solidFill>
+              </a:defRPr>
+            </a:pPr>
+            <a:r>
+              <a:t>• Indexing is memory-intensive and multi-threaded</a:t>
             </a:r>
           </a:p>
           <a:p>
             <a:pPr>
-              <a:defRPr sz="2200"/>
-            </a:pPr>
-            <a:r>
-              <a:t>Generate tenant tokens and enforce access control in backend</a:t>
+              <a:spcAft>
+                <a:spcPts val="800"/>
+              </a:spcAft>
+              <a:defRPr sz="1650">
+                <a:solidFill>
+                  <a:srgbClr val="283E31"/>
+                </a:solidFill>
+              </a:defRPr>
+            </a:pPr>
+            <a:r>
+              <a:t>• Unbounded indexing can degrade query responsiveness</a:t>
+            </a:r>
+          </a:p>
+          <a:p>
+            <a:pPr>
+              <a:spcAft>
+                <a:spcPts val="800"/>
+              </a:spcAft>
+              <a:defRPr sz="1650">
+                <a:solidFill>
+                  <a:srgbClr val="283E31"/>
+                </a:solidFill>
+              </a:defRPr>
+            </a:pPr>
+            <a:r>
+              <a:t>• Large payload spikes increase OOM and latency risk</a:t>
+            </a:r>
+          </a:p>
+        </p:txBody>
+      </p:sp>
+      <p:sp>
+        <p:nvSpPr>
+          <p:cNvPr id="11" name="TextBox 10"/>
+          <p:cNvSpPr txBox="1"/>
+          <p:nvPr/>
+        </p:nvSpPr>
+        <p:spPr>
+          <a:xfrm>
+            <a:off x="6492240" y="1920240"/>
+            <a:ext cx="4754880" cy="4389120"/>
+          </a:xfrm>
+          <a:prstGeom prst="rect">
+            <a:avLst/>
+          </a:prstGeom>
+          <a:noFill/>
+        </p:spPr>
+        <p:txBody>
+          <a:bodyPr wrap="none">
+            <a:spAutoFit/>
+          </a:bodyPr>
+          <a:lstStyle/>
+          <a:p>
+            <a:pPr>
+              <a:spcAft>
+                <a:spcPts val="800"/>
+              </a:spcAft>
+              <a:defRPr sz="1650">
+                <a:solidFill>
+                  <a:srgbClr val="283E31"/>
+                </a:solidFill>
+              </a:defRPr>
+            </a:pPr>
+            <a:r>
+              <a:t>• Set max-indexing-memory below host capacity</a:t>
+            </a:r>
+          </a:p>
+          <a:p>
+            <a:pPr>
+              <a:spcAft>
+                <a:spcPts val="800"/>
+              </a:spcAft>
+              <a:defRPr sz="1650">
+                <a:solidFill>
+                  <a:srgbClr val="283E31"/>
+                </a:solidFill>
+              </a:defRPr>
+            </a:pPr>
+            <a:r>
+              <a:t>• Constrain max-indexing-threads for query headroom</a:t>
+            </a:r>
+          </a:p>
+          <a:p>
+            <a:pPr>
+              <a:spcAft>
+                <a:spcPts val="800"/>
+              </a:spcAft>
+              <a:defRPr sz="1650">
+                <a:solidFill>
+                  <a:srgbClr val="283E31"/>
+                </a:solidFill>
+              </a:defRPr>
+            </a:pPr>
+            <a:r>
+              <a:t>• Ingest via bounded batches and monitored windows</a:t>
             </a:r>
           </a:p>
         </p:txBody>
@@ -3513,77 +4796,452 @@
       <p:grpSpPr/>
       <p:sp>
         <p:nvSpPr>
-          <p:cNvPr id="2" name="Title 1"/>
-          <p:cNvSpPr>
-            <a:spLocks noGrp="1"/>
-          </p:cNvSpPr>
-          <p:nvPr>
-            <p:ph type="title"/>
-          </p:nvPr>
-        </p:nvSpPr>
-        <p:spPr/>
-        <p:txBody>
-          <a:bodyPr/>
-          <a:lstStyle/>
-          <a:p>
-            <a:r>
-              <a:t>4) Requirements (practical baseline)</a:t>
-            </a:r>
-          </a:p>
-        </p:txBody>
-      </p:sp>
-      <p:sp>
-        <p:nvSpPr>
-          <p:cNvPr id="3" name="Content Placeholder 2"/>
-          <p:cNvSpPr>
-            <a:spLocks noGrp="1"/>
-          </p:cNvSpPr>
-          <p:nvPr>
-            <p:ph idx="1"/>
-          </p:nvPr>
-        </p:nvSpPr>
-        <p:spPr/>
-        <p:txBody>
-          <a:bodyPr/>
+          <p:cNvPr id="2" name="Rectangle 1"/>
+          <p:cNvSpPr/>
+          <p:nvPr/>
+        </p:nvSpPr>
+        <p:spPr>
+          <a:xfrm>
+            <a:off x="0" y="0"/>
+            <a:ext cx="12191695" cy="6858000"/>
+          </a:xfrm>
+          <a:prstGeom prst="rect">
+            <a:avLst/>
+          </a:prstGeom>
+          <a:solidFill>
+            <a:srgbClr val="F6F8F4"/>
+          </a:solidFill>
+          <a:ln>
+            <a:noFill/>
+          </a:ln>
+        </p:spPr>
+        <p:style>
+          <a:lnRef idx="1">
+            <a:schemeClr val="accent1"/>
+          </a:lnRef>
+          <a:fillRef idx="3">
+            <a:schemeClr val="accent1"/>
+          </a:fillRef>
+          <a:effectRef idx="2">
+            <a:schemeClr val="accent1"/>
+          </a:effectRef>
+          <a:fontRef idx="minor">
+            <a:schemeClr val="lt1"/>
+          </a:fontRef>
+        </p:style>
+        <p:txBody>
+          <a:bodyPr rtlCol="0" anchor="ctr"/>
+          <a:lstStyle/>
+          <a:p>
+            <a:pPr algn="ctr"/>
+          </a:p>
+        </p:txBody>
+      </p:sp>
+      <p:sp>
+        <p:nvSpPr>
+          <p:cNvPr id="3" name="Rectangle 2"/>
+          <p:cNvSpPr/>
+          <p:nvPr/>
+        </p:nvSpPr>
+        <p:spPr>
+          <a:xfrm>
+            <a:off x="0" y="0"/>
+            <a:ext cx="12191695" cy="777240"/>
+          </a:xfrm>
+          <a:prstGeom prst="rect">
+            <a:avLst/>
+          </a:prstGeom>
+          <a:solidFill>
+            <a:srgbClr val="123524"/>
+          </a:solidFill>
+          <a:ln>
+            <a:noFill/>
+          </a:ln>
+        </p:spPr>
+        <p:style>
+          <a:lnRef idx="1">
+            <a:schemeClr val="accent1"/>
+          </a:lnRef>
+          <a:fillRef idx="3">
+            <a:schemeClr val="accent1"/>
+          </a:fillRef>
+          <a:effectRef idx="2">
+            <a:schemeClr val="accent1"/>
+          </a:effectRef>
+          <a:fontRef idx="minor">
+            <a:schemeClr val="lt1"/>
+          </a:fontRef>
+        </p:style>
+        <p:txBody>
+          <a:bodyPr rtlCol="0" anchor="ctr"/>
+          <a:lstStyle/>
+          <a:p>
+            <a:pPr algn="ctr"/>
+          </a:p>
+        </p:txBody>
+      </p:sp>
+      <p:sp>
+        <p:nvSpPr>
+          <p:cNvPr id="4" name="TextBox 3"/>
+          <p:cNvSpPr txBox="1"/>
+          <p:nvPr/>
+        </p:nvSpPr>
+        <p:spPr>
+          <a:xfrm>
+            <a:off x="502920" y="146304"/>
+            <a:ext cx="8961120" cy="457200"/>
+          </a:xfrm>
+          <a:prstGeom prst="rect">
+            <a:avLst/>
+          </a:prstGeom>
+          <a:noFill/>
+        </p:spPr>
+        <p:txBody>
+          <a:bodyPr wrap="none">
+            <a:spAutoFit/>
+          </a:bodyPr>
           <a:lstStyle/>
           <a:p>
             <a:pPr>
-              <a:defRPr sz="2200"/>
-            </a:pPr>
-            <a:r>
-              <a:t>Production mode + master key (&gt;=16 bytes)</a:t>
-            </a:r>
-          </a:p>
+              <a:defRPr sz="2400" b="1">
+                <a:solidFill>
+                  <a:srgbClr val="FFFFFF"/>
+                </a:solidFill>
+              </a:defRPr>
+            </a:pPr>
+            <a:r>
+              <a:t>Requirements for Production Readiness</a:t>
+            </a:r>
+          </a:p>
+        </p:txBody>
+      </p:sp>
+      <p:sp>
+        <p:nvSpPr>
+          <p:cNvPr id="5" name="TextBox 4"/>
+          <p:cNvSpPr txBox="1"/>
+          <p:nvPr/>
+        </p:nvSpPr>
+        <p:spPr>
+          <a:xfrm>
+            <a:off x="10332720" y="182880"/>
+            <a:ext cx="1645920" cy="320040"/>
+          </a:xfrm>
+          <a:prstGeom prst="rect">
+            <a:avLst/>
+          </a:prstGeom>
+          <a:noFill/>
+        </p:spPr>
+        <p:txBody>
+          <a:bodyPr wrap="none">
+            <a:spAutoFit/>
+          </a:bodyPr>
+          <a:lstStyle/>
+          <a:p>
+            <a:pPr algn="r">
+              <a:defRPr sz="1000">
+                <a:solidFill>
+                  <a:srgbClr val="DCE9E2"/>
+                </a:solidFill>
+              </a:defRPr>
+            </a:pPr>
+            <a:r>
+              <a:t>Olam Agri | Research Brief</a:t>
+            </a:r>
+          </a:p>
+        </p:txBody>
+      </p:sp>
+      <p:sp>
+        <p:nvSpPr>
+          <p:cNvPr id="6" name="Rounded Rectangle 5"/>
+          <p:cNvSpPr/>
+          <p:nvPr/>
+        </p:nvSpPr>
+        <p:spPr>
+          <a:xfrm>
+            <a:off x="548640" y="1188720"/>
+            <a:ext cx="5440680" cy="5440680"/>
+          </a:xfrm>
+          <a:prstGeom prst="roundRect">
+            <a:avLst/>
+          </a:prstGeom>
+          <a:solidFill>
+            <a:srgbClr val="FFFFFF"/>
+          </a:solidFill>
+          <a:ln>
+            <a:solidFill>
+              <a:srgbClr val="D8E1DA"/>
+            </a:solidFill>
+          </a:ln>
+        </p:spPr>
+        <p:style>
+          <a:lnRef idx="1">
+            <a:schemeClr val="accent1"/>
+          </a:lnRef>
+          <a:fillRef idx="3">
+            <a:schemeClr val="accent1"/>
+          </a:fillRef>
+          <a:effectRef idx="2">
+            <a:schemeClr val="accent1"/>
+          </a:effectRef>
+          <a:fontRef idx="minor">
+            <a:schemeClr val="lt1"/>
+          </a:fontRef>
+        </p:style>
+        <p:txBody>
+          <a:bodyPr rtlCol="0" anchor="ctr"/>
+          <a:lstStyle/>
+          <a:p>
+            <a:pPr algn="ctr"/>
+          </a:p>
+        </p:txBody>
+      </p:sp>
+      <p:sp>
+        <p:nvSpPr>
+          <p:cNvPr id="7" name="Rounded Rectangle 6"/>
+          <p:cNvSpPr/>
+          <p:nvPr/>
+        </p:nvSpPr>
+        <p:spPr>
+          <a:xfrm>
+            <a:off x="6172200" y="1188720"/>
+            <a:ext cx="5440680" cy="5440680"/>
+          </a:xfrm>
+          <a:prstGeom prst="roundRect">
+            <a:avLst/>
+          </a:prstGeom>
+          <a:solidFill>
+            <a:srgbClr val="FFFFFF"/>
+          </a:solidFill>
+          <a:ln>
+            <a:solidFill>
+              <a:srgbClr val="D8E1DA"/>
+            </a:solidFill>
+          </a:ln>
+        </p:spPr>
+        <p:style>
+          <a:lnRef idx="1">
+            <a:schemeClr val="accent1"/>
+          </a:lnRef>
+          <a:fillRef idx="3">
+            <a:schemeClr val="accent1"/>
+          </a:fillRef>
+          <a:effectRef idx="2">
+            <a:schemeClr val="accent1"/>
+          </a:effectRef>
+          <a:fontRef idx="minor">
+            <a:schemeClr val="lt1"/>
+          </a:fontRef>
+        </p:style>
+        <p:txBody>
+          <a:bodyPr rtlCol="0" anchor="ctr"/>
+          <a:lstStyle/>
+          <a:p>
+            <a:pPr algn="ctr"/>
+          </a:p>
+        </p:txBody>
+      </p:sp>
+      <p:sp>
+        <p:nvSpPr>
+          <p:cNvPr id="8" name="TextBox 7"/>
+          <p:cNvSpPr txBox="1"/>
+          <p:nvPr/>
+        </p:nvSpPr>
+        <p:spPr>
+          <a:xfrm>
+            <a:off x="868680" y="1417320"/>
+            <a:ext cx="4846320" cy="457200"/>
+          </a:xfrm>
+          <a:prstGeom prst="rect">
+            <a:avLst/>
+          </a:prstGeom>
+          <a:noFill/>
+        </p:spPr>
+        <p:txBody>
+          <a:bodyPr wrap="none">
+            <a:spAutoFit/>
+          </a:bodyPr>
+          <a:lstStyle/>
           <a:p>
             <a:pPr>
-              <a:defRPr sz="2200"/>
-            </a:pPr>
-            <a:r>
-              <a:t>Sizing headroom: plan disk generously; start with conservative RAM/CPU</a:t>
-            </a:r>
-          </a:p>
+              <a:defRPr sz="1900" b="1">
+                <a:solidFill>
+                  <a:srgbClr val="2C5E42"/>
+                </a:solidFill>
+              </a:defRPr>
+            </a:pPr>
+            <a:r>
+              <a:t>Technical baseline</a:t>
+            </a:r>
+          </a:p>
+        </p:txBody>
+      </p:sp>
+      <p:sp>
+        <p:nvSpPr>
+          <p:cNvPr id="9" name="TextBox 8"/>
+          <p:cNvSpPr txBox="1"/>
+          <p:nvPr/>
+        </p:nvSpPr>
+        <p:spPr>
+          <a:xfrm>
+            <a:off x="6492240" y="1417320"/>
+            <a:ext cx="4846320" cy="457200"/>
+          </a:xfrm>
+          <a:prstGeom prst="rect">
+            <a:avLst/>
+          </a:prstGeom>
+          <a:noFill/>
+        </p:spPr>
+        <p:txBody>
+          <a:bodyPr wrap="none">
+            <a:spAutoFit/>
+          </a:bodyPr>
+          <a:lstStyle/>
           <a:p>
             <a:pPr>
-              <a:defRPr sz="2200"/>
-            </a:pPr>
-            <a:r>
-              <a:t>Indexing controls: max-indexing-memory and max-indexing-threads</a:t>
-            </a:r>
-          </a:p>
+              <a:defRPr sz="1900" b="1">
+                <a:solidFill>
+                  <a:srgbClr val="2C5E42"/>
+                </a:solidFill>
+              </a:defRPr>
+            </a:pPr>
+            <a:r>
+              <a:t>Operating baseline</a:t>
+            </a:r>
+          </a:p>
+        </p:txBody>
+      </p:sp>
+      <p:sp>
+        <p:nvSpPr>
+          <p:cNvPr id="10" name="TextBox 9"/>
+          <p:cNvSpPr txBox="1"/>
+          <p:nvPr/>
+        </p:nvSpPr>
+        <p:spPr>
+          <a:xfrm>
+            <a:off x="868680" y="1920240"/>
+            <a:ext cx="4754880" cy="4389120"/>
+          </a:xfrm>
+          <a:prstGeom prst="rect">
+            <a:avLst/>
+          </a:prstGeom>
+          <a:noFill/>
+        </p:spPr>
+        <p:txBody>
+          <a:bodyPr wrap="none">
+            <a:spAutoFit/>
+          </a:bodyPr>
+          <a:lstStyle/>
           <a:p>
             <a:pPr>
-              <a:defRPr sz="2200"/>
-            </a:pPr>
-            <a:r>
-              <a:t>Operations: backups (dumps/snapshots), monitoring, restore drills</a:t>
+              <a:spcAft>
+                <a:spcPts val="800"/>
+              </a:spcAft>
+              <a:defRPr sz="1650">
+                <a:solidFill>
+                  <a:srgbClr val="283E31"/>
+                </a:solidFill>
+              </a:defRPr>
+            </a:pPr>
+            <a:r>
+              <a:t>• Production mode with strong master-key governance</a:t>
             </a:r>
           </a:p>
           <a:p>
             <a:pPr>
-              <a:defRPr sz="2200"/>
-            </a:pPr>
-            <a:r>
-              <a:t>Security: API key lifecycle + short-lived tenant tokens</a:t>
+              <a:spcAft>
+                <a:spcPts val="800"/>
+              </a:spcAft>
+              <a:defRPr sz="1650">
+                <a:solidFill>
+                  <a:srgbClr val="283E31"/>
+                </a:solidFill>
+              </a:defRPr>
+            </a:pPr>
+            <a:r>
+              <a:t>• Persistent storage, backups, and upgrade strategy</a:t>
+            </a:r>
+          </a:p>
+          <a:p>
+            <a:pPr>
+              <a:spcAft>
+                <a:spcPts val="800"/>
+              </a:spcAft>
+              <a:defRPr sz="1650">
+                <a:solidFill>
+                  <a:srgbClr val="283E31"/>
+                </a:solidFill>
+              </a:defRPr>
+            </a:pPr>
+            <a:r>
+              <a:t>• Explicit document contracts and primary-key discipline</a:t>
+            </a:r>
+          </a:p>
+        </p:txBody>
+      </p:sp>
+      <p:sp>
+        <p:nvSpPr>
+          <p:cNvPr id="11" name="TextBox 10"/>
+          <p:cNvSpPr txBox="1"/>
+          <p:nvPr/>
+        </p:nvSpPr>
+        <p:spPr>
+          <a:xfrm>
+            <a:off x="6492240" y="1920240"/>
+            <a:ext cx="4754880" cy="4389120"/>
+          </a:xfrm>
+          <a:prstGeom prst="rect">
+            <a:avLst/>
+          </a:prstGeom>
+          <a:noFill/>
+        </p:spPr>
+        <p:txBody>
+          <a:bodyPr wrap="none">
+            <a:spAutoFit/>
+          </a:bodyPr>
+          <a:lstStyle/>
+          <a:p>
+            <a:pPr>
+              <a:spcAft>
+                <a:spcPts val="800"/>
+              </a:spcAft>
+              <a:defRPr sz="1650">
+                <a:solidFill>
+                  <a:srgbClr val="283E31"/>
+                </a:solidFill>
+              </a:defRPr>
+            </a:pPr>
+            <a:r>
+              <a:t>• Runbooks for restore and reindex scenarios</a:t>
+            </a:r>
+          </a:p>
+          <a:p>
+            <a:pPr>
+              <a:spcAft>
+                <a:spcPts val="800"/>
+              </a:spcAft>
+              <a:defRPr sz="1650">
+                <a:solidFill>
+                  <a:srgbClr val="283E31"/>
+                </a:solidFill>
+              </a:defRPr>
+            </a:pPr>
+            <a:r>
+              <a:t>• SLO tracking for latency, freshness, and failures</a:t>
+            </a:r>
+          </a:p>
+          <a:p>
+            <a:pPr>
+              <a:spcAft>
+                <a:spcPts val="800"/>
+              </a:spcAft>
+              <a:defRPr sz="1650">
+                <a:solidFill>
+                  <a:srgbClr val="283E31"/>
+                </a:solidFill>
+              </a:defRPr>
+            </a:pPr>
+            <a:r>
+              <a:t>• Domain ownership for searchable attributes</a:t>
             </a:r>
           </a:p>
         </p:txBody>
@@ -3608,69 +5266,452 @@
       <p:grpSpPr/>
       <p:sp>
         <p:nvSpPr>
-          <p:cNvPr id="2" name="Title 1"/>
-          <p:cNvSpPr>
-            <a:spLocks noGrp="1"/>
-          </p:cNvSpPr>
-          <p:nvPr>
-            <p:ph type="title"/>
-          </p:nvPr>
-        </p:nvSpPr>
-        <p:spPr/>
-        <p:txBody>
-          <a:bodyPr/>
-          <a:lstStyle/>
-          <a:p>
-            <a:r>
-              <a:t>5) Self-hosting options</a:t>
-            </a:r>
-          </a:p>
-        </p:txBody>
-      </p:sp>
-      <p:sp>
-        <p:nvSpPr>
-          <p:cNvPr id="3" name="Content Placeholder 2"/>
-          <p:cNvSpPr>
-            <a:spLocks noGrp="1"/>
-          </p:cNvSpPr>
-          <p:nvPr>
-            <p:ph idx="1"/>
-          </p:nvPr>
-        </p:nvSpPr>
-        <p:spPr/>
-        <p:txBody>
-          <a:bodyPr/>
+          <p:cNvPr id="2" name="Rectangle 1"/>
+          <p:cNvSpPr/>
+          <p:nvPr/>
+        </p:nvSpPr>
+        <p:spPr>
+          <a:xfrm>
+            <a:off x="0" y="0"/>
+            <a:ext cx="12191695" cy="6858000"/>
+          </a:xfrm>
+          <a:prstGeom prst="rect">
+            <a:avLst/>
+          </a:prstGeom>
+          <a:solidFill>
+            <a:srgbClr val="F6F8F4"/>
+          </a:solidFill>
+          <a:ln>
+            <a:noFill/>
+          </a:ln>
+        </p:spPr>
+        <p:style>
+          <a:lnRef idx="1">
+            <a:schemeClr val="accent1"/>
+          </a:lnRef>
+          <a:fillRef idx="3">
+            <a:schemeClr val="accent1"/>
+          </a:fillRef>
+          <a:effectRef idx="2">
+            <a:schemeClr val="accent1"/>
+          </a:effectRef>
+          <a:fontRef idx="minor">
+            <a:schemeClr val="lt1"/>
+          </a:fontRef>
+        </p:style>
+        <p:txBody>
+          <a:bodyPr rtlCol="0" anchor="ctr"/>
+          <a:lstStyle/>
+          <a:p>
+            <a:pPr algn="ctr"/>
+          </a:p>
+        </p:txBody>
+      </p:sp>
+      <p:sp>
+        <p:nvSpPr>
+          <p:cNvPr id="3" name="Rectangle 2"/>
+          <p:cNvSpPr/>
+          <p:nvPr/>
+        </p:nvSpPr>
+        <p:spPr>
+          <a:xfrm>
+            <a:off x="0" y="0"/>
+            <a:ext cx="12191695" cy="777240"/>
+          </a:xfrm>
+          <a:prstGeom prst="rect">
+            <a:avLst/>
+          </a:prstGeom>
+          <a:solidFill>
+            <a:srgbClr val="123524"/>
+          </a:solidFill>
+          <a:ln>
+            <a:noFill/>
+          </a:ln>
+        </p:spPr>
+        <p:style>
+          <a:lnRef idx="1">
+            <a:schemeClr val="accent1"/>
+          </a:lnRef>
+          <a:fillRef idx="3">
+            <a:schemeClr val="accent1"/>
+          </a:fillRef>
+          <a:effectRef idx="2">
+            <a:schemeClr val="accent1"/>
+          </a:effectRef>
+          <a:fontRef idx="minor">
+            <a:schemeClr val="lt1"/>
+          </a:fontRef>
+        </p:style>
+        <p:txBody>
+          <a:bodyPr rtlCol="0" anchor="ctr"/>
+          <a:lstStyle/>
+          <a:p>
+            <a:pPr algn="ctr"/>
+          </a:p>
+        </p:txBody>
+      </p:sp>
+      <p:sp>
+        <p:nvSpPr>
+          <p:cNvPr id="4" name="TextBox 3"/>
+          <p:cNvSpPr txBox="1"/>
+          <p:nvPr/>
+        </p:nvSpPr>
+        <p:spPr>
+          <a:xfrm>
+            <a:off x="502920" y="146304"/>
+            <a:ext cx="8961120" cy="457200"/>
+          </a:xfrm>
+          <a:prstGeom prst="rect">
+            <a:avLst/>
+          </a:prstGeom>
+          <a:noFill/>
+        </p:spPr>
+        <p:txBody>
+          <a:bodyPr wrap="none">
+            <a:spAutoFit/>
+          </a:bodyPr>
           <a:lstStyle/>
           <a:p>
             <a:pPr>
-              <a:defRPr sz="2200"/>
-            </a:pPr>
-            <a:r>
-              <a:t>Community Edition (MIT): single-instance deployments</a:t>
-            </a:r>
-          </a:p>
+              <a:defRPr sz="2400" b="1">
+                <a:solidFill>
+                  <a:srgbClr val="FFFFFF"/>
+                </a:solidFill>
+              </a:defRPr>
+            </a:pPr>
+            <a:r>
+              <a:t>Self-Hosting Decision Matrix</a:t>
+            </a:r>
+          </a:p>
+        </p:txBody>
+      </p:sp>
+      <p:sp>
+        <p:nvSpPr>
+          <p:cNvPr id="5" name="TextBox 4"/>
+          <p:cNvSpPr txBox="1"/>
+          <p:nvPr/>
+        </p:nvSpPr>
+        <p:spPr>
+          <a:xfrm>
+            <a:off x="10332720" y="182880"/>
+            <a:ext cx="1645920" cy="320040"/>
+          </a:xfrm>
+          <a:prstGeom prst="rect">
+            <a:avLst/>
+          </a:prstGeom>
+          <a:noFill/>
+        </p:spPr>
+        <p:txBody>
+          <a:bodyPr wrap="none">
+            <a:spAutoFit/>
+          </a:bodyPr>
+          <a:lstStyle/>
+          <a:p>
+            <a:pPr algn="r">
+              <a:defRPr sz="1000">
+                <a:solidFill>
+                  <a:srgbClr val="DCE9E2"/>
+                </a:solidFill>
+              </a:defRPr>
+            </a:pPr>
+            <a:r>
+              <a:t>Olam Agri | Research Brief</a:t>
+            </a:r>
+          </a:p>
+        </p:txBody>
+      </p:sp>
+      <p:sp>
+        <p:nvSpPr>
+          <p:cNvPr id="6" name="Rounded Rectangle 5"/>
+          <p:cNvSpPr/>
+          <p:nvPr/>
+        </p:nvSpPr>
+        <p:spPr>
+          <a:xfrm>
+            <a:off x="548640" y="1188720"/>
+            <a:ext cx="5440680" cy="5440680"/>
+          </a:xfrm>
+          <a:prstGeom prst="roundRect">
+            <a:avLst/>
+          </a:prstGeom>
+          <a:solidFill>
+            <a:srgbClr val="FFFFFF"/>
+          </a:solidFill>
+          <a:ln>
+            <a:solidFill>
+              <a:srgbClr val="D8E1DA"/>
+            </a:solidFill>
+          </a:ln>
+        </p:spPr>
+        <p:style>
+          <a:lnRef idx="1">
+            <a:schemeClr val="accent1"/>
+          </a:lnRef>
+          <a:fillRef idx="3">
+            <a:schemeClr val="accent1"/>
+          </a:fillRef>
+          <a:effectRef idx="2">
+            <a:schemeClr val="accent1"/>
+          </a:effectRef>
+          <a:fontRef idx="minor">
+            <a:schemeClr val="lt1"/>
+          </a:fontRef>
+        </p:style>
+        <p:txBody>
+          <a:bodyPr rtlCol="0" anchor="ctr"/>
+          <a:lstStyle/>
+          <a:p>
+            <a:pPr algn="ctr"/>
+          </a:p>
+        </p:txBody>
+      </p:sp>
+      <p:sp>
+        <p:nvSpPr>
+          <p:cNvPr id="7" name="Rounded Rectangle 6"/>
+          <p:cNvSpPr/>
+          <p:nvPr/>
+        </p:nvSpPr>
+        <p:spPr>
+          <a:xfrm>
+            <a:off x="6172200" y="1188720"/>
+            <a:ext cx="5440680" cy="5440680"/>
+          </a:xfrm>
+          <a:prstGeom prst="roundRect">
+            <a:avLst/>
+          </a:prstGeom>
+          <a:solidFill>
+            <a:srgbClr val="FFFFFF"/>
+          </a:solidFill>
+          <a:ln>
+            <a:solidFill>
+              <a:srgbClr val="D8E1DA"/>
+            </a:solidFill>
+          </a:ln>
+        </p:spPr>
+        <p:style>
+          <a:lnRef idx="1">
+            <a:schemeClr val="accent1"/>
+          </a:lnRef>
+          <a:fillRef idx="3">
+            <a:schemeClr val="accent1"/>
+          </a:fillRef>
+          <a:effectRef idx="2">
+            <a:schemeClr val="accent1"/>
+          </a:effectRef>
+          <a:fontRef idx="minor">
+            <a:schemeClr val="lt1"/>
+          </a:fontRef>
+        </p:style>
+        <p:txBody>
+          <a:bodyPr rtlCol="0" anchor="ctr"/>
+          <a:lstStyle/>
+          <a:p>
+            <a:pPr algn="ctr"/>
+          </a:p>
+        </p:txBody>
+      </p:sp>
+      <p:sp>
+        <p:nvSpPr>
+          <p:cNvPr id="8" name="TextBox 7"/>
+          <p:cNvSpPr txBox="1"/>
+          <p:nvPr/>
+        </p:nvSpPr>
+        <p:spPr>
+          <a:xfrm>
+            <a:off x="868680" y="1417320"/>
+            <a:ext cx="4846320" cy="457200"/>
+          </a:xfrm>
+          <a:prstGeom prst="rect">
+            <a:avLst/>
+          </a:prstGeom>
+          <a:noFill/>
+        </p:spPr>
+        <p:txBody>
+          <a:bodyPr wrap="none">
+            <a:spAutoFit/>
+          </a:bodyPr>
+          <a:lstStyle/>
           <a:p>
             <a:pPr>
-              <a:defRPr sz="2200"/>
-            </a:pPr>
-            <a:r>
-              <a:t>Enterprise Edition (BUSL): sharding + replication (HA and scale)</a:t>
-            </a:r>
-          </a:p>
+              <a:defRPr sz="1900" b="1">
+                <a:solidFill>
+                  <a:srgbClr val="2C5E42"/>
+                </a:solidFill>
+              </a:defRPr>
+            </a:pPr>
+            <a:r>
+              <a:t>Community Edition</a:t>
+            </a:r>
+          </a:p>
+        </p:txBody>
+      </p:sp>
+      <p:sp>
+        <p:nvSpPr>
+          <p:cNvPr id="9" name="TextBox 8"/>
+          <p:cNvSpPr txBox="1"/>
+          <p:nvPr/>
+        </p:nvSpPr>
+        <p:spPr>
+          <a:xfrm>
+            <a:off x="6492240" y="1417320"/>
+            <a:ext cx="4846320" cy="457200"/>
+          </a:xfrm>
+          <a:prstGeom prst="rect">
+            <a:avLst/>
+          </a:prstGeom>
+          <a:noFill/>
+        </p:spPr>
+        <p:txBody>
+          <a:bodyPr wrap="none">
+            <a:spAutoFit/>
+          </a:bodyPr>
+          <a:lstStyle/>
           <a:p>
             <a:pPr>
-              <a:defRPr sz="2200"/>
-            </a:pPr>
-            <a:r>
-              <a:t>Meilisearch Cloud: fastest rollout, managed operations</a:t>
-            </a:r>
-          </a:p>
+              <a:defRPr sz="1900" b="1">
+                <a:solidFill>
+                  <a:srgbClr val="2C5E42"/>
+                </a:solidFill>
+              </a:defRPr>
+            </a:pPr>
+            <a:r>
+              <a:t>Enterprise Edition / Cloud</a:t>
+            </a:r>
+          </a:p>
+        </p:txBody>
+      </p:sp>
+      <p:sp>
+        <p:nvSpPr>
+          <p:cNvPr id="10" name="TextBox 9"/>
+          <p:cNvSpPr txBox="1"/>
+          <p:nvPr/>
+        </p:nvSpPr>
+        <p:spPr>
+          <a:xfrm>
+            <a:off x="868680" y="1920240"/>
+            <a:ext cx="4754880" cy="4389120"/>
+          </a:xfrm>
+          <a:prstGeom prst="rect">
+            <a:avLst/>
+          </a:prstGeom>
+          <a:noFill/>
+        </p:spPr>
+        <p:txBody>
+          <a:bodyPr wrap="none">
+            <a:spAutoFit/>
+          </a:bodyPr>
+          <a:lstStyle/>
           <a:p>
             <a:pPr>
-              <a:defRPr sz="2200"/>
-            </a:pPr>
-            <a:r>
-              <a:t>Choose based on control needs, scale target, and ops maturity</a:t>
+              <a:spcAft>
+                <a:spcPts val="800"/>
+              </a:spcAft>
+              <a:defRPr sz="1650">
+                <a:solidFill>
+                  <a:srgbClr val="283E31"/>
+                </a:solidFill>
+              </a:defRPr>
+            </a:pPr>
+            <a:r>
+              <a:t>• MIT-licensed and straightforward to deploy</a:t>
+            </a:r>
+          </a:p>
+          <a:p>
+            <a:pPr>
+              <a:spcAft>
+                <a:spcPts val="800"/>
+              </a:spcAft>
+              <a:defRPr sz="1650">
+                <a:solidFill>
+                  <a:srgbClr val="283E31"/>
+                </a:solidFill>
+              </a:defRPr>
+            </a:pPr>
+            <a:r>
+              <a:t>• Strong fit for single-instance, focused workloads</a:t>
+            </a:r>
+          </a:p>
+          <a:p>
+            <a:pPr>
+              <a:spcAft>
+                <a:spcPts val="800"/>
+              </a:spcAft>
+              <a:defRPr sz="1650">
+                <a:solidFill>
+                  <a:srgbClr val="283E31"/>
+                </a:solidFill>
+              </a:defRPr>
+            </a:pPr>
+            <a:r>
+              <a:t>• Not intended for distributed sharding/replication topologies</a:t>
+            </a:r>
+          </a:p>
+        </p:txBody>
+      </p:sp>
+      <p:sp>
+        <p:nvSpPr>
+          <p:cNvPr id="11" name="TextBox 10"/>
+          <p:cNvSpPr txBox="1"/>
+          <p:nvPr/>
+        </p:nvSpPr>
+        <p:spPr>
+          <a:xfrm>
+            <a:off x="6492240" y="1920240"/>
+            <a:ext cx="4754880" cy="4389120"/>
+          </a:xfrm>
+          <a:prstGeom prst="rect">
+            <a:avLst/>
+          </a:prstGeom>
+          <a:noFill/>
+        </p:spPr>
+        <p:txBody>
+          <a:bodyPr wrap="none">
+            <a:spAutoFit/>
+          </a:bodyPr>
+          <a:lstStyle/>
+          <a:p>
+            <a:pPr>
+              <a:spcAft>
+                <a:spcPts val="800"/>
+              </a:spcAft>
+              <a:defRPr sz="1650">
+                <a:solidFill>
+                  <a:srgbClr val="283E31"/>
+                </a:solidFill>
+              </a:defRPr>
+            </a:pPr>
+            <a:r>
+              <a:t>• Enterprise enables sharding and replication</a:t>
+            </a:r>
+          </a:p>
+          <a:p>
+            <a:pPr>
+              <a:spcAft>
+                <a:spcPts val="800"/>
+              </a:spcAft>
+              <a:defRPr sz="1650">
+                <a:solidFill>
+                  <a:srgbClr val="283E31"/>
+                </a:solidFill>
+              </a:defRPr>
+            </a:pPr>
+            <a:r>
+              <a:t>• Cloud reduces ops burden and speeds rollout</a:t>
+            </a:r>
+          </a:p>
+          <a:p>
+            <a:pPr>
+              <a:spcAft>
+                <a:spcPts val="800"/>
+              </a:spcAft>
+              <a:defRPr sz="1650">
+                <a:solidFill>
+                  <a:srgbClr val="283E31"/>
+                </a:solidFill>
+              </a:defRPr>
+            </a:pPr>
+            <a:r>
+              <a:t>• Choose based on HA target, scale path, and control model</a:t>
             </a:r>
           </a:p>
         </p:txBody>
@@ -3695,77 +5736,452 @@
       <p:grpSpPr/>
       <p:sp>
         <p:nvSpPr>
-          <p:cNvPr id="2" name="Title 1"/>
-          <p:cNvSpPr>
-            <a:spLocks noGrp="1"/>
-          </p:cNvSpPr>
-          <p:nvPr>
-            <p:ph type="title"/>
-          </p:nvPr>
-        </p:nvSpPr>
-        <p:spPr/>
-        <p:txBody>
-          <a:bodyPr/>
-          <a:lstStyle/>
-          <a:p>
-            <a:r>
-              <a:t>6) Blockers to plan for</a:t>
-            </a:r>
-          </a:p>
-        </p:txBody>
-      </p:sp>
-      <p:sp>
-        <p:nvSpPr>
-          <p:cNvPr id="3" name="Content Placeholder 2"/>
-          <p:cNvSpPr>
-            <a:spLocks noGrp="1"/>
-          </p:cNvSpPr>
-          <p:nvPr>
-            <p:ph idx="1"/>
-          </p:nvPr>
-        </p:nvSpPr>
-        <p:spPr/>
-        <p:txBody>
-          <a:bodyPr/>
+          <p:cNvPr id="2" name="Rectangle 1"/>
+          <p:cNvSpPr/>
+          <p:nvPr/>
+        </p:nvSpPr>
+        <p:spPr>
+          <a:xfrm>
+            <a:off x="0" y="0"/>
+            <a:ext cx="12191695" cy="6858000"/>
+          </a:xfrm>
+          <a:prstGeom prst="rect">
+            <a:avLst/>
+          </a:prstGeom>
+          <a:solidFill>
+            <a:srgbClr val="F6F8F4"/>
+          </a:solidFill>
+          <a:ln>
+            <a:noFill/>
+          </a:ln>
+        </p:spPr>
+        <p:style>
+          <a:lnRef idx="1">
+            <a:schemeClr val="accent1"/>
+          </a:lnRef>
+          <a:fillRef idx="3">
+            <a:schemeClr val="accent1"/>
+          </a:fillRef>
+          <a:effectRef idx="2">
+            <a:schemeClr val="accent1"/>
+          </a:effectRef>
+          <a:fontRef idx="minor">
+            <a:schemeClr val="lt1"/>
+          </a:fontRef>
+        </p:style>
+        <p:txBody>
+          <a:bodyPr rtlCol="0" anchor="ctr"/>
+          <a:lstStyle/>
+          <a:p>
+            <a:pPr algn="ctr"/>
+          </a:p>
+        </p:txBody>
+      </p:sp>
+      <p:sp>
+        <p:nvSpPr>
+          <p:cNvPr id="3" name="Rectangle 2"/>
+          <p:cNvSpPr/>
+          <p:nvPr/>
+        </p:nvSpPr>
+        <p:spPr>
+          <a:xfrm>
+            <a:off x="0" y="0"/>
+            <a:ext cx="12191695" cy="777240"/>
+          </a:xfrm>
+          <a:prstGeom prst="rect">
+            <a:avLst/>
+          </a:prstGeom>
+          <a:solidFill>
+            <a:srgbClr val="123524"/>
+          </a:solidFill>
+          <a:ln>
+            <a:noFill/>
+          </a:ln>
+        </p:spPr>
+        <p:style>
+          <a:lnRef idx="1">
+            <a:schemeClr val="accent1"/>
+          </a:lnRef>
+          <a:fillRef idx="3">
+            <a:schemeClr val="accent1"/>
+          </a:fillRef>
+          <a:effectRef idx="2">
+            <a:schemeClr val="accent1"/>
+          </a:effectRef>
+          <a:fontRef idx="minor">
+            <a:schemeClr val="lt1"/>
+          </a:fontRef>
+        </p:style>
+        <p:txBody>
+          <a:bodyPr rtlCol="0" anchor="ctr"/>
+          <a:lstStyle/>
+          <a:p>
+            <a:pPr algn="ctr"/>
+          </a:p>
+        </p:txBody>
+      </p:sp>
+      <p:sp>
+        <p:nvSpPr>
+          <p:cNvPr id="4" name="TextBox 3"/>
+          <p:cNvSpPr txBox="1"/>
+          <p:nvPr/>
+        </p:nvSpPr>
+        <p:spPr>
+          <a:xfrm>
+            <a:off x="502920" y="146304"/>
+            <a:ext cx="8961120" cy="457200"/>
+          </a:xfrm>
+          <a:prstGeom prst="rect">
+            <a:avLst/>
+          </a:prstGeom>
+          <a:noFill/>
+        </p:spPr>
+        <p:txBody>
+          <a:bodyPr wrap="none">
+            <a:spAutoFit/>
+          </a:bodyPr>
           <a:lstStyle/>
           <a:p>
             <a:pPr>
-              <a:defRPr sz="2200"/>
-            </a:pPr>
-            <a:r>
-              <a:t>Single-instance limits in Community Edition</a:t>
-            </a:r>
-          </a:p>
+              <a:defRPr sz="2400" b="1">
+                <a:solidFill>
+                  <a:srgbClr val="FFFFFF"/>
+                </a:solidFill>
+              </a:defRPr>
+            </a:pPr>
+            <a:r>
+              <a:t>Principal Blockers</a:t>
+            </a:r>
+          </a:p>
+        </p:txBody>
+      </p:sp>
+      <p:sp>
+        <p:nvSpPr>
+          <p:cNvPr id="5" name="TextBox 4"/>
+          <p:cNvSpPr txBox="1"/>
+          <p:nvPr/>
+        </p:nvSpPr>
+        <p:spPr>
+          <a:xfrm>
+            <a:off x="10332720" y="182880"/>
+            <a:ext cx="1645920" cy="320040"/>
+          </a:xfrm>
+          <a:prstGeom prst="rect">
+            <a:avLst/>
+          </a:prstGeom>
+          <a:noFill/>
+        </p:spPr>
+        <p:txBody>
+          <a:bodyPr wrap="none">
+            <a:spAutoFit/>
+          </a:bodyPr>
+          <a:lstStyle/>
+          <a:p>
+            <a:pPr algn="r">
+              <a:defRPr sz="1000">
+                <a:solidFill>
+                  <a:srgbClr val="DCE9E2"/>
+                </a:solidFill>
+              </a:defRPr>
+            </a:pPr>
+            <a:r>
+              <a:t>Olam Agri | Research Brief</a:t>
+            </a:r>
+          </a:p>
+        </p:txBody>
+      </p:sp>
+      <p:sp>
+        <p:nvSpPr>
+          <p:cNvPr id="6" name="Rounded Rectangle 5"/>
+          <p:cNvSpPr/>
+          <p:nvPr/>
+        </p:nvSpPr>
+        <p:spPr>
+          <a:xfrm>
+            <a:off x="548640" y="1188720"/>
+            <a:ext cx="5440680" cy="5440680"/>
+          </a:xfrm>
+          <a:prstGeom prst="roundRect">
+            <a:avLst/>
+          </a:prstGeom>
+          <a:solidFill>
+            <a:srgbClr val="FFFFFF"/>
+          </a:solidFill>
+          <a:ln>
+            <a:solidFill>
+              <a:srgbClr val="D8E1DA"/>
+            </a:solidFill>
+          </a:ln>
+        </p:spPr>
+        <p:style>
+          <a:lnRef idx="1">
+            <a:schemeClr val="accent1"/>
+          </a:lnRef>
+          <a:fillRef idx="3">
+            <a:schemeClr val="accent1"/>
+          </a:fillRef>
+          <a:effectRef idx="2">
+            <a:schemeClr val="accent1"/>
+          </a:effectRef>
+          <a:fontRef idx="minor">
+            <a:schemeClr val="lt1"/>
+          </a:fontRef>
+        </p:style>
+        <p:txBody>
+          <a:bodyPr rtlCol="0" anchor="ctr"/>
+          <a:lstStyle/>
+          <a:p>
+            <a:pPr algn="ctr"/>
+          </a:p>
+        </p:txBody>
+      </p:sp>
+      <p:sp>
+        <p:nvSpPr>
+          <p:cNvPr id="7" name="Rounded Rectangle 6"/>
+          <p:cNvSpPr/>
+          <p:nvPr/>
+        </p:nvSpPr>
+        <p:spPr>
+          <a:xfrm>
+            <a:off x="6172200" y="1188720"/>
+            <a:ext cx="5440680" cy="5440680"/>
+          </a:xfrm>
+          <a:prstGeom prst="roundRect">
+            <a:avLst/>
+          </a:prstGeom>
+          <a:solidFill>
+            <a:srgbClr val="FFFFFF"/>
+          </a:solidFill>
+          <a:ln>
+            <a:solidFill>
+              <a:srgbClr val="D8E1DA"/>
+            </a:solidFill>
+          </a:ln>
+        </p:spPr>
+        <p:style>
+          <a:lnRef idx="1">
+            <a:schemeClr val="accent1"/>
+          </a:lnRef>
+          <a:fillRef idx="3">
+            <a:schemeClr val="accent1"/>
+          </a:fillRef>
+          <a:effectRef idx="2">
+            <a:schemeClr val="accent1"/>
+          </a:effectRef>
+          <a:fontRef idx="minor">
+            <a:schemeClr val="lt1"/>
+          </a:fontRef>
+        </p:style>
+        <p:txBody>
+          <a:bodyPr rtlCol="0" anchor="ctr"/>
+          <a:lstStyle/>
+          <a:p>
+            <a:pPr algn="ctr"/>
+          </a:p>
+        </p:txBody>
+      </p:sp>
+      <p:sp>
+        <p:nvSpPr>
+          <p:cNvPr id="8" name="TextBox 7"/>
+          <p:cNvSpPr txBox="1"/>
+          <p:nvPr/>
+        </p:nvSpPr>
+        <p:spPr>
+          <a:xfrm>
+            <a:off x="868680" y="1417320"/>
+            <a:ext cx="4846320" cy="457200"/>
+          </a:xfrm>
+          <a:prstGeom prst="rect">
+            <a:avLst/>
+          </a:prstGeom>
+          <a:noFill/>
+        </p:spPr>
+        <p:txBody>
+          <a:bodyPr wrap="none">
+            <a:spAutoFit/>
+          </a:bodyPr>
+          <a:lstStyle/>
           <a:p>
             <a:pPr>
-              <a:defRPr sz="2200"/>
-            </a:pPr>
-            <a:r>
-              <a:t>High data-modeling effort from SAP to search-optimized JSON</a:t>
-            </a:r>
-          </a:p>
+              <a:defRPr sz="1900" b="1">
+                <a:solidFill>
+                  <a:srgbClr val="2C5E42"/>
+                </a:solidFill>
+              </a:defRPr>
+            </a:pPr>
+            <a:r>
+              <a:t>Architecture and data risks</a:t>
+            </a:r>
+          </a:p>
+        </p:txBody>
+      </p:sp>
+      <p:sp>
+        <p:nvSpPr>
+          <p:cNvPr id="9" name="TextBox 8"/>
+          <p:cNvSpPr txBox="1"/>
+          <p:nvPr/>
+        </p:nvSpPr>
+        <p:spPr>
+          <a:xfrm>
+            <a:off x="6492240" y="1417320"/>
+            <a:ext cx="4846320" cy="457200"/>
+          </a:xfrm>
+          <a:prstGeom prst="rect">
+            <a:avLst/>
+          </a:prstGeom>
+          <a:noFill/>
+        </p:spPr>
+        <p:txBody>
+          <a:bodyPr wrap="none">
+            <a:spAutoFit/>
+          </a:bodyPr>
+          <a:lstStyle/>
           <a:p>
             <a:pPr>
-              <a:defRPr sz="2200"/>
-            </a:pPr>
-            <a:r>
-              <a:t>Complexity of near-real-time synchronization pipelines</a:t>
-            </a:r>
-          </a:p>
+              <a:defRPr sz="1900" b="1">
+                <a:solidFill>
+                  <a:srgbClr val="2C5E42"/>
+                </a:solidFill>
+              </a:defRPr>
+            </a:pPr>
+            <a:r>
+              <a:t>Governance and operations risks</a:t>
+            </a:r>
+          </a:p>
+        </p:txBody>
+      </p:sp>
+      <p:sp>
+        <p:nvSpPr>
+          <p:cNvPr id="10" name="TextBox 9"/>
+          <p:cNvSpPr txBox="1"/>
+          <p:nvPr/>
+        </p:nvSpPr>
+        <p:spPr>
+          <a:xfrm>
+            <a:off x="868680" y="1920240"/>
+            <a:ext cx="4754880" cy="4389120"/>
+          </a:xfrm>
+          <a:prstGeom prst="rect">
+            <a:avLst/>
+          </a:prstGeom>
+          <a:noFill/>
+        </p:spPr>
+        <p:txBody>
+          <a:bodyPr wrap="none">
+            <a:spAutoFit/>
+          </a:bodyPr>
+          <a:lstStyle/>
           <a:p>
             <a:pPr>
-              <a:defRPr sz="2200"/>
-            </a:pPr>
-            <a:r>
-              <a:t>Security and multi-tenancy governance implementation</a:t>
+              <a:spcAft>
+                <a:spcPts val="800"/>
+              </a:spcAft>
+              <a:defRPr sz="1650">
+                <a:solidFill>
+                  <a:srgbClr val="283E31"/>
+                </a:solidFill>
+              </a:defRPr>
+            </a:pPr>
+            <a:r>
+              <a:t>• Relational-to-search modeling effort is substantial</a:t>
             </a:r>
           </a:p>
           <a:p>
             <a:pPr>
-              <a:defRPr sz="2200"/>
-            </a:pPr>
-            <a:r>
-              <a:t>Need for production-grade runbooks and monitoring discipline</a:t>
+              <a:spcAft>
+                <a:spcPts val="800"/>
+              </a:spcAft>
+              <a:defRPr sz="1650">
+                <a:solidFill>
+                  <a:srgbClr val="283E31"/>
+                </a:solidFill>
+              </a:defRPr>
+            </a:pPr>
+            <a:r>
+              <a:t>• Real-time sync reliability requires robust orchestration</a:t>
+            </a:r>
+          </a:p>
+          <a:p>
+            <a:pPr>
+              <a:spcAft>
+                <a:spcPts val="800"/>
+              </a:spcAft>
+              <a:defRPr sz="1650">
+                <a:solidFill>
+                  <a:srgbClr val="283E31"/>
+                </a:solidFill>
+              </a:defRPr>
+            </a:pPr>
+            <a:r>
+              <a:t>• Community Edition scaling limits must be acknowledged</a:t>
+            </a:r>
+          </a:p>
+        </p:txBody>
+      </p:sp>
+      <p:sp>
+        <p:nvSpPr>
+          <p:cNvPr id="11" name="TextBox 10"/>
+          <p:cNvSpPr txBox="1"/>
+          <p:nvPr/>
+        </p:nvSpPr>
+        <p:spPr>
+          <a:xfrm>
+            <a:off x="6492240" y="1920240"/>
+            <a:ext cx="4754880" cy="4389120"/>
+          </a:xfrm>
+          <a:prstGeom prst="rect">
+            <a:avLst/>
+          </a:prstGeom>
+          <a:noFill/>
+        </p:spPr>
+        <p:txBody>
+          <a:bodyPr wrap="none">
+            <a:spAutoFit/>
+          </a:bodyPr>
+          <a:lstStyle/>
+          <a:p>
+            <a:pPr>
+              <a:spcAft>
+                <a:spcPts val="800"/>
+              </a:spcAft>
+              <a:defRPr sz="1650">
+                <a:solidFill>
+                  <a:srgbClr val="283E31"/>
+                </a:solidFill>
+              </a:defRPr>
+            </a:pPr>
+            <a:r>
+              <a:t>• Frontend key misuse can break data isolation</a:t>
+            </a:r>
+          </a:p>
+          <a:p>
+            <a:pPr>
+              <a:spcAft>
+                <a:spcPts val="800"/>
+              </a:spcAft>
+              <a:defRPr sz="1650">
+                <a:solidFill>
+                  <a:srgbClr val="283E31"/>
+                </a:solidFill>
+              </a:defRPr>
+            </a:pPr>
+            <a:r>
+              <a:t>• Weak backup/restore discipline elevates outage impact</a:t>
+            </a:r>
+          </a:p>
+          <a:p>
+            <a:pPr>
+              <a:spcAft>
+                <a:spcPts val="800"/>
+              </a:spcAft>
+              <a:defRPr sz="1650">
+                <a:solidFill>
+                  <a:srgbClr val="283E31"/>
+                </a:solidFill>
+              </a:defRPr>
+            </a:pPr>
+            <a:r>
+              <a:t>• Late edition switching can cause avoidable rework</a:t>
             </a:r>
           </a:p>
         </p:txBody>
@@ -3790,69 +6206,584 @@
       <p:grpSpPr/>
       <p:sp>
         <p:nvSpPr>
-          <p:cNvPr id="2" name="Title 1"/>
-          <p:cNvSpPr>
-            <a:spLocks noGrp="1"/>
-          </p:cNvSpPr>
-          <p:nvPr>
-            <p:ph type="title"/>
-          </p:nvPr>
-        </p:nvSpPr>
-        <p:spPr/>
-        <p:txBody>
-          <a:bodyPr/>
-          <a:lstStyle/>
-          <a:p>
-            <a:r>
-              <a:t>7) 90-day rollout plan</a:t>
-            </a:r>
-          </a:p>
-        </p:txBody>
-      </p:sp>
-      <p:sp>
-        <p:nvSpPr>
-          <p:cNvPr id="3" name="Content Placeholder 2"/>
-          <p:cNvSpPr>
-            <a:spLocks noGrp="1"/>
-          </p:cNvSpPr>
-          <p:nvPr>
-            <p:ph idx="1"/>
-          </p:nvPr>
-        </p:nvSpPr>
-        <p:spPr/>
-        <p:txBody>
-          <a:bodyPr/>
+          <p:cNvPr id="2" name="Rectangle 1"/>
+          <p:cNvSpPr/>
+          <p:nvPr/>
+        </p:nvSpPr>
+        <p:spPr>
+          <a:xfrm>
+            <a:off x="0" y="0"/>
+            <a:ext cx="12191695" cy="6858000"/>
+          </a:xfrm>
+          <a:prstGeom prst="rect">
+            <a:avLst/>
+          </a:prstGeom>
+          <a:solidFill>
+            <a:srgbClr val="F6F8F4"/>
+          </a:solidFill>
+          <a:ln>
+            <a:noFill/>
+          </a:ln>
+        </p:spPr>
+        <p:style>
+          <a:lnRef idx="1">
+            <a:schemeClr val="accent1"/>
+          </a:lnRef>
+          <a:fillRef idx="3">
+            <a:schemeClr val="accent1"/>
+          </a:fillRef>
+          <a:effectRef idx="2">
+            <a:schemeClr val="accent1"/>
+          </a:effectRef>
+          <a:fontRef idx="minor">
+            <a:schemeClr val="lt1"/>
+          </a:fontRef>
+        </p:style>
+        <p:txBody>
+          <a:bodyPr rtlCol="0" anchor="ctr"/>
+          <a:lstStyle/>
+          <a:p>
+            <a:pPr algn="ctr"/>
+          </a:p>
+        </p:txBody>
+      </p:sp>
+      <p:sp>
+        <p:nvSpPr>
+          <p:cNvPr id="3" name="Rectangle 2"/>
+          <p:cNvSpPr/>
+          <p:nvPr/>
+        </p:nvSpPr>
+        <p:spPr>
+          <a:xfrm>
+            <a:off x="0" y="0"/>
+            <a:ext cx="12191695" cy="777240"/>
+          </a:xfrm>
+          <a:prstGeom prst="rect">
+            <a:avLst/>
+          </a:prstGeom>
+          <a:solidFill>
+            <a:srgbClr val="123524"/>
+          </a:solidFill>
+          <a:ln>
+            <a:noFill/>
+          </a:ln>
+        </p:spPr>
+        <p:style>
+          <a:lnRef idx="1">
+            <a:schemeClr val="accent1"/>
+          </a:lnRef>
+          <a:fillRef idx="3">
+            <a:schemeClr val="accent1"/>
+          </a:fillRef>
+          <a:effectRef idx="2">
+            <a:schemeClr val="accent1"/>
+          </a:effectRef>
+          <a:fontRef idx="minor">
+            <a:schemeClr val="lt1"/>
+          </a:fontRef>
+        </p:style>
+        <p:txBody>
+          <a:bodyPr rtlCol="0" anchor="ctr"/>
+          <a:lstStyle/>
+          <a:p>
+            <a:pPr algn="ctr"/>
+          </a:p>
+        </p:txBody>
+      </p:sp>
+      <p:sp>
+        <p:nvSpPr>
+          <p:cNvPr id="4" name="TextBox 3"/>
+          <p:cNvSpPr txBox="1"/>
+          <p:nvPr/>
+        </p:nvSpPr>
+        <p:spPr>
+          <a:xfrm>
+            <a:off x="502920" y="146304"/>
+            <a:ext cx="8961120" cy="457200"/>
+          </a:xfrm>
+          <a:prstGeom prst="rect">
+            <a:avLst/>
+          </a:prstGeom>
+          <a:noFill/>
+        </p:spPr>
+        <p:txBody>
+          <a:bodyPr wrap="none">
+            <a:spAutoFit/>
+          </a:bodyPr>
           <a:lstStyle/>
           <a:p>
             <a:pPr>
-              <a:defRPr sz="2200"/>
-            </a:pPr>
-            <a:r>
-              <a:t>Phase 1 (Weeks 1-2): use-case scope, KPIs, edition choice</a:t>
-            </a:r>
-          </a:p>
+              <a:defRPr sz="2400" b="1">
+                <a:solidFill>
+                  <a:srgbClr val="FFFFFF"/>
+                </a:solidFill>
+              </a:defRPr>
+            </a:pPr>
+            <a:r>
+              <a:t>Implementation Roadmap (12 Weeks)</a:t>
+            </a:r>
+          </a:p>
+        </p:txBody>
+      </p:sp>
+      <p:sp>
+        <p:nvSpPr>
+          <p:cNvPr id="5" name="TextBox 4"/>
+          <p:cNvSpPr txBox="1"/>
+          <p:nvPr/>
+        </p:nvSpPr>
+        <p:spPr>
+          <a:xfrm>
+            <a:off x="10332720" y="182880"/>
+            <a:ext cx="1645920" cy="320040"/>
+          </a:xfrm>
+          <a:prstGeom prst="rect">
+            <a:avLst/>
+          </a:prstGeom>
+          <a:noFill/>
+        </p:spPr>
+        <p:txBody>
+          <a:bodyPr wrap="none">
+            <a:spAutoFit/>
+          </a:bodyPr>
+          <a:lstStyle/>
+          <a:p>
+            <a:pPr algn="r">
+              <a:defRPr sz="1000">
+                <a:solidFill>
+                  <a:srgbClr val="DCE9E2"/>
+                </a:solidFill>
+              </a:defRPr>
+            </a:pPr>
+            <a:r>
+              <a:t>Olam Agri | Research Brief</a:t>
+            </a:r>
+          </a:p>
+        </p:txBody>
+      </p:sp>
+      <p:sp>
+        <p:nvSpPr>
+          <p:cNvPr id="6" name="Rounded Rectangle 5"/>
+          <p:cNvSpPr/>
+          <p:nvPr/>
+        </p:nvSpPr>
+        <p:spPr>
+          <a:xfrm>
+            <a:off x="731520" y="1600200"/>
+            <a:ext cx="2743200" cy="4297680"/>
+          </a:xfrm>
+          <a:prstGeom prst="roundRect">
+            <a:avLst/>
+          </a:prstGeom>
+          <a:solidFill>
+            <a:srgbClr val="FFFFFF"/>
+          </a:solidFill>
+          <a:ln>
+            <a:solidFill>
+              <a:srgbClr val="D4E0D8"/>
+            </a:solidFill>
+          </a:ln>
+        </p:spPr>
+        <p:style>
+          <a:lnRef idx="1">
+            <a:schemeClr val="accent1"/>
+          </a:lnRef>
+          <a:fillRef idx="3">
+            <a:schemeClr val="accent1"/>
+          </a:fillRef>
+          <a:effectRef idx="2">
+            <a:schemeClr val="accent1"/>
+          </a:effectRef>
+          <a:fontRef idx="minor">
+            <a:schemeClr val="lt1"/>
+          </a:fontRef>
+        </p:style>
+        <p:txBody>
+          <a:bodyPr rtlCol="0" anchor="ctr"/>
+          <a:lstStyle/>
+          <a:p>
+            <a:pPr algn="ctr"/>
+          </a:p>
+        </p:txBody>
+      </p:sp>
+      <p:sp>
+        <p:nvSpPr>
+          <p:cNvPr id="7" name="TextBox 6"/>
+          <p:cNvSpPr txBox="1"/>
+          <p:nvPr/>
+        </p:nvSpPr>
+        <p:spPr>
+          <a:xfrm>
+            <a:off x="914400" y="1783080"/>
+            <a:ext cx="2377440" cy="3840480"/>
+          </a:xfrm>
+          <a:prstGeom prst="rect">
+            <a:avLst/>
+          </a:prstGeom>
+          <a:noFill/>
+        </p:spPr>
+        <p:txBody>
+          <a:bodyPr wrap="square">
+            <a:spAutoFit/>
+          </a:bodyPr>
+          <a:lstStyle/>
           <a:p>
             <a:pPr>
-              <a:defRPr sz="2200"/>
-            </a:pPr>
-            <a:r>
-              <a:t>Phase 2 (Weeks 3-4): one-domain PoC + security baseline</a:t>
+              <a:defRPr sz="1600" b="1">
+                <a:solidFill>
+                  <a:srgbClr val="2C5E42"/>
+                </a:solidFill>
+              </a:defRPr>
+            </a:pPr>
+            <a:r>
+              <a:t>Weeks 1–2</a:t>
             </a:r>
           </a:p>
           <a:p>
             <a:pPr>
-              <a:defRPr sz="2200"/>
-            </a:pPr>
-            <a:r>
-              <a:t>Phase 3 (Weeks 5-8): CDC/middleware hardening + relevance tuning</a:t>
+              <a:spcAft>
+                <a:spcPts val="800"/>
+              </a:spcAft>
+              <a:defRPr sz="1800" b="1">
+                <a:solidFill>
+                  <a:srgbClr val="203529"/>
+                </a:solidFill>
+              </a:defRPr>
+            </a:pPr>
+            <a:r>
+              <a:t>Scope and Decision Gate</a:t>
             </a:r>
           </a:p>
           <a:p>
             <a:pPr>
-              <a:defRPr sz="2200"/>
-            </a:pPr>
-            <a:r>
-              <a:t>Phase 4 (Weeks 9-12): performance tests + backup/restore drills + go-live gate</a:t>
+              <a:defRPr sz="1450">
+                <a:solidFill>
+                  <a:srgbClr val="465A4E"/>
+                </a:solidFill>
+              </a:defRPr>
+            </a:pPr>
+            <a:r>
+              <a:t>Select domain, define SLOs, choose CE/EE/Cloud</a:t>
+            </a:r>
+          </a:p>
+        </p:txBody>
+      </p:sp>
+      <p:sp>
+        <p:nvSpPr>
+          <p:cNvPr id="8" name="Rounded Rectangle 7"/>
+          <p:cNvSpPr/>
+          <p:nvPr/>
+        </p:nvSpPr>
+        <p:spPr>
+          <a:xfrm>
+            <a:off x="3611880" y="1600200"/>
+            <a:ext cx="2743200" cy="4297680"/>
+          </a:xfrm>
+          <a:prstGeom prst="roundRect">
+            <a:avLst/>
+          </a:prstGeom>
+          <a:solidFill>
+            <a:srgbClr val="FFFFFF"/>
+          </a:solidFill>
+          <a:ln>
+            <a:solidFill>
+              <a:srgbClr val="D4E0D8"/>
+            </a:solidFill>
+          </a:ln>
+        </p:spPr>
+        <p:style>
+          <a:lnRef idx="1">
+            <a:schemeClr val="accent1"/>
+          </a:lnRef>
+          <a:fillRef idx="3">
+            <a:schemeClr val="accent1"/>
+          </a:fillRef>
+          <a:effectRef idx="2">
+            <a:schemeClr val="accent1"/>
+          </a:effectRef>
+          <a:fontRef idx="minor">
+            <a:schemeClr val="lt1"/>
+          </a:fontRef>
+        </p:style>
+        <p:txBody>
+          <a:bodyPr rtlCol="0" anchor="ctr"/>
+          <a:lstStyle/>
+          <a:p>
+            <a:pPr algn="ctr"/>
+          </a:p>
+        </p:txBody>
+      </p:sp>
+      <p:sp>
+        <p:nvSpPr>
+          <p:cNvPr id="9" name="TextBox 8"/>
+          <p:cNvSpPr txBox="1"/>
+          <p:nvPr/>
+        </p:nvSpPr>
+        <p:spPr>
+          <a:xfrm>
+            <a:off x="3794760" y="1783080"/>
+            <a:ext cx="2377440" cy="3840480"/>
+          </a:xfrm>
+          <a:prstGeom prst="rect">
+            <a:avLst/>
+          </a:prstGeom>
+          <a:noFill/>
+        </p:spPr>
+        <p:txBody>
+          <a:bodyPr wrap="square">
+            <a:spAutoFit/>
+          </a:bodyPr>
+          <a:lstStyle/>
+          <a:p>
+            <a:pPr>
+              <a:defRPr sz="1600" b="1">
+                <a:solidFill>
+                  <a:srgbClr val="2C5E42"/>
+                </a:solidFill>
+              </a:defRPr>
+            </a:pPr>
+            <a:r>
+              <a:t>Weeks 3–4</a:t>
+            </a:r>
+          </a:p>
+          <a:p>
+            <a:pPr>
+              <a:spcAft>
+                <a:spcPts val="800"/>
+              </a:spcAft>
+              <a:defRPr sz="1800" b="1">
+                <a:solidFill>
+                  <a:srgbClr val="203529"/>
+                </a:solidFill>
+              </a:defRPr>
+            </a:pPr>
+            <a:r>
+              <a:t>Pilot Build</a:t>
+            </a:r>
+          </a:p>
+          <a:p>
+            <a:pPr>
+              <a:defRPr sz="1450">
+                <a:solidFill>
+                  <a:srgbClr val="465A4E"/>
+                </a:solidFill>
+              </a:defRPr>
+            </a:pPr>
+            <a:r>
+              <a:t>Deliver first index, access model, and baseline tuning</a:t>
+            </a:r>
+          </a:p>
+        </p:txBody>
+      </p:sp>
+      <p:sp>
+        <p:nvSpPr>
+          <p:cNvPr id="10" name="Rounded Rectangle 9"/>
+          <p:cNvSpPr/>
+          <p:nvPr/>
+        </p:nvSpPr>
+        <p:spPr>
+          <a:xfrm>
+            <a:off x="6492240" y="1600200"/>
+            <a:ext cx="2743200" cy="4297680"/>
+          </a:xfrm>
+          <a:prstGeom prst="roundRect">
+            <a:avLst/>
+          </a:prstGeom>
+          <a:solidFill>
+            <a:srgbClr val="FFFFFF"/>
+          </a:solidFill>
+          <a:ln>
+            <a:solidFill>
+              <a:srgbClr val="D4E0D8"/>
+            </a:solidFill>
+          </a:ln>
+        </p:spPr>
+        <p:style>
+          <a:lnRef idx="1">
+            <a:schemeClr val="accent1"/>
+          </a:lnRef>
+          <a:fillRef idx="3">
+            <a:schemeClr val="accent1"/>
+          </a:fillRef>
+          <a:effectRef idx="2">
+            <a:schemeClr val="accent1"/>
+          </a:effectRef>
+          <a:fontRef idx="minor">
+            <a:schemeClr val="lt1"/>
+          </a:fontRef>
+        </p:style>
+        <p:txBody>
+          <a:bodyPr rtlCol="0" anchor="ctr"/>
+          <a:lstStyle/>
+          <a:p>
+            <a:pPr algn="ctr"/>
+          </a:p>
+        </p:txBody>
+      </p:sp>
+      <p:sp>
+        <p:nvSpPr>
+          <p:cNvPr id="11" name="TextBox 10"/>
+          <p:cNvSpPr txBox="1"/>
+          <p:nvPr/>
+        </p:nvSpPr>
+        <p:spPr>
+          <a:xfrm>
+            <a:off x="6675120" y="1783080"/>
+            <a:ext cx="2377440" cy="3840480"/>
+          </a:xfrm>
+          <a:prstGeom prst="rect">
+            <a:avLst/>
+          </a:prstGeom>
+          <a:noFill/>
+        </p:spPr>
+        <p:txBody>
+          <a:bodyPr wrap="square">
+            <a:spAutoFit/>
+          </a:bodyPr>
+          <a:lstStyle/>
+          <a:p>
+            <a:pPr>
+              <a:defRPr sz="1600" b="1">
+                <a:solidFill>
+                  <a:srgbClr val="2C5E42"/>
+                </a:solidFill>
+              </a:defRPr>
+            </a:pPr>
+            <a:r>
+              <a:t>Weeks 5–8</a:t>
+            </a:r>
+          </a:p>
+          <a:p>
+            <a:pPr>
+              <a:spcAft>
+                <a:spcPts val="800"/>
+              </a:spcAft>
+              <a:defRPr sz="1800" b="1">
+                <a:solidFill>
+                  <a:srgbClr val="203529"/>
+                </a:solidFill>
+              </a:defRPr>
+            </a:pPr>
+            <a:r>
+              <a:t>Pipeline Hardening</a:t>
+            </a:r>
+          </a:p>
+          <a:p>
+            <a:pPr>
+              <a:defRPr sz="1450">
+                <a:solidFill>
+                  <a:srgbClr val="465A4E"/>
+                </a:solidFill>
+              </a:defRPr>
+            </a:pPr>
+            <a:r>
+              <a:t>CDC/incremental sync, retries, relevance refinement</a:t>
+            </a:r>
+          </a:p>
+        </p:txBody>
+      </p:sp>
+      <p:sp>
+        <p:nvSpPr>
+          <p:cNvPr id="12" name="Rounded Rectangle 11"/>
+          <p:cNvSpPr/>
+          <p:nvPr/>
+        </p:nvSpPr>
+        <p:spPr>
+          <a:xfrm>
+            <a:off x="9372600" y="1600200"/>
+            <a:ext cx="2743200" cy="4297680"/>
+          </a:xfrm>
+          <a:prstGeom prst="roundRect">
+            <a:avLst/>
+          </a:prstGeom>
+          <a:solidFill>
+            <a:srgbClr val="FFFFFF"/>
+          </a:solidFill>
+          <a:ln>
+            <a:solidFill>
+              <a:srgbClr val="D4E0D8"/>
+            </a:solidFill>
+          </a:ln>
+        </p:spPr>
+        <p:style>
+          <a:lnRef idx="1">
+            <a:schemeClr val="accent1"/>
+          </a:lnRef>
+          <a:fillRef idx="3">
+            <a:schemeClr val="accent1"/>
+          </a:fillRef>
+          <a:effectRef idx="2">
+            <a:schemeClr val="accent1"/>
+          </a:effectRef>
+          <a:fontRef idx="minor">
+            <a:schemeClr val="lt1"/>
+          </a:fontRef>
+        </p:style>
+        <p:txBody>
+          <a:bodyPr rtlCol="0" anchor="ctr"/>
+          <a:lstStyle/>
+          <a:p>
+            <a:pPr algn="ctr"/>
+          </a:p>
+        </p:txBody>
+      </p:sp>
+      <p:sp>
+        <p:nvSpPr>
+          <p:cNvPr id="13" name="TextBox 12"/>
+          <p:cNvSpPr txBox="1"/>
+          <p:nvPr/>
+        </p:nvSpPr>
+        <p:spPr>
+          <a:xfrm>
+            <a:off x="9555480" y="1783080"/>
+            <a:ext cx="2377440" cy="3840480"/>
+          </a:xfrm>
+          <a:prstGeom prst="rect">
+            <a:avLst/>
+          </a:prstGeom>
+          <a:noFill/>
+        </p:spPr>
+        <p:txBody>
+          <a:bodyPr wrap="square">
+            <a:spAutoFit/>
+          </a:bodyPr>
+          <a:lstStyle/>
+          <a:p>
+            <a:pPr>
+              <a:defRPr sz="1600" b="1">
+                <a:solidFill>
+                  <a:srgbClr val="2C5E42"/>
+                </a:solidFill>
+              </a:defRPr>
+            </a:pPr>
+            <a:r>
+              <a:t>Weeks 9–12</a:t>
+            </a:r>
+          </a:p>
+          <a:p>
+            <a:pPr>
+              <a:spcAft>
+                <a:spcPts val="800"/>
+              </a:spcAft>
+              <a:defRPr sz="1800" b="1">
+                <a:solidFill>
+                  <a:srgbClr val="203529"/>
+                </a:solidFill>
+              </a:defRPr>
+            </a:pPr>
+            <a:r>
+              <a:t>Production Readiness</a:t>
+            </a:r>
+          </a:p>
+          <a:p>
+            <a:pPr>
+              <a:defRPr sz="1450">
+                <a:solidFill>
+                  <a:srgbClr val="465A4E"/>
+                </a:solidFill>
+              </a:defRPr>
+            </a:pPr>
+            <a:r>
+              <a:t>Load tests, backup/restore drills, staged rollout</a:t>
             </a:r>
           </a:p>
         </p:txBody>
@@ -3877,69 +6808,304 @@
       <p:grpSpPr/>
       <p:sp>
         <p:nvSpPr>
-          <p:cNvPr id="2" name="Title 1"/>
-          <p:cNvSpPr>
-            <a:spLocks noGrp="1"/>
-          </p:cNvSpPr>
-          <p:nvPr>
-            <p:ph type="title"/>
-          </p:nvPr>
-        </p:nvSpPr>
-        <p:spPr/>
-        <p:txBody>
-          <a:bodyPr/>
-          <a:lstStyle/>
-          <a:p>
-            <a:r>
-              <a:t>8) Recommendation</a:t>
-            </a:r>
-          </a:p>
-        </p:txBody>
-      </p:sp>
-      <p:sp>
-        <p:nvSpPr>
-          <p:cNvPr id="3" name="Content Placeholder 2"/>
-          <p:cNvSpPr>
-            <a:spLocks noGrp="1"/>
-          </p:cNvSpPr>
-          <p:nvPr>
-            <p:ph idx="1"/>
-          </p:nvPr>
-        </p:nvSpPr>
-        <p:spPr/>
-        <p:txBody>
-          <a:bodyPr/>
+          <p:cNvPr id="2" name="Rectangle 1"/>
+          <p:cNvSpPr/>
+          <p:nvPr/>
+        </p:nvSpPr>
+        <p:spPr>
+          <a:xfrm>
+            <a:off x="0" y="0"/>
+            <a:ext cx="12191695" cy="6858000"/>
+          </a:xfrm>
+          <a:prstGeom prst="rect">
+            <a:avLst/>
+          </a:prstGeom>
+          <a:solidFill>
+            <a:srgbClr val="F6F8F4"/>
+          </a:solidFill>
+          <a:ln>
+            <a:noFill/>
+          </a:ln>
+        </p:spPr>
+        <p:style>
+          <a:lnRef idx="1">
+            <a:schemeClr val="accent1"/>
+          </a:lnRef>
+          <a:fillRef idx="3">
+            <a:schemeClr val="accent1"/>
+          </a:fillRef>
+          <a:effectRef idx="2">
+            <a:schemeClr val="accent1"/>
+          </a:effectRef>
+          <a:fontRef idx="minor">
+            <a:schemeClr val="lt1"/>
+          </a:fontRef>
+        </p:style>
+        <p:txBody>
+          <a:bodyPr rtlCol="0" anchor="ctr"/>
+          <a:lstStyle/>
+          <a:p>
+            <a:pPr algn="ctr"/>
+          </a:p>
+        </p:txBody>
+      </p:sp>
+      <p:sp>
+        <p:nvSpPr>
+          <p:cNvPr id="3" name="Rectangle 2"/>
+          <p:cNvSpPr/>
+          <p:nvPr/>
+        </p:nvSpPr>
+        <p:spPr>
+          <a:xfrm>
+            <a:off x="0" y="0"/>
+            <a:ext cx="12191695" cy="777240"/>
+          </a:xfrm>
+          <a:prstGeom prst="rect">
+            <a:avLst/>
+          </a:prstGeom>
+          <a:solidFill>
+            <a:srgbClr val="123524"/>
+          </a:solidFill>
+          <a:ln>
+            <a:noFill/>
+          </a:ln>
+        </p:spPr>
+        <p:style>
+          <a:lnRef idx="1">
+            <a:schemeClr val="accent1"/>
+          </a:lnRef>
+          <a:fillRef idx="3">
+            <a:schemeClr val="accent1"/>
+          </a:fillRef>
+          <a:effectRef idx="2">
+            <a:schemeClr val="accent1"/>
+          </a:effectRef>
+          <a:fontRef idx="minor">
+            <a:schemeClr val="lt1"/>
+          </a:fontRef>
+        </p:style>
+        <p:txBody>
+          <a:bodyPr rtlCol="0" anchor="ctr"/>
+          <a:lstStyle/>
+          <a:p>
+            <a:pPr algn="ctr"/>
+          </a:p>
+        </p:txBody>
+      </p:sp>
+      <p:sp>
+        <p:nvSpPr>
+          <p:cNvPr id="4" name="TextBox 3"/>
+          <p:cNvSpPr txBox="1"/>
+          <p:nvPr/>
+        </p:nvSpPr>
+        <p:spPr>
+          <a:xfrm>
+            <a:off x="502920" y="146304"/>
+            <a:ext cx="8961120" cy="457200"/>
+          </a:xfrm>
+          <a:prstGeom prst="rect">
+            <a:avLst/>
+          </a:prstGeom>
+          <a:noFill/>
+        </p:spPr>
+        <p:txBody>
+          <a:bodyPr wrap="none">
+            <a:spAutoFit/>
+          </a:bodyPr>
           <a:lstStyle/>
           <a:p>
             <a:pPr>
-              <a:defRPr sz="2200"/>
-            </a:pPr>
-            <a:r>
-              <a:t>Proceed with a controlled pilot first</a:t>
-            </a:r>
-          </a:p>
+              <a:defRPr sz="2400" b="1">
+                <a:solidFill>
+                  <a:srgbClr val="FFFFFF"/>
+                </a:solidFill>
+              </a:defRPr>
+            </a:pPr>
+            <a:r>
+              <a:t>Recommended Path Forward</a:t>
+            </a:r>
+          </a:p>
+        </p:txBody>
+      </p:sp>
+      <p:sp>
+        <p:nvSpPr>
+          <p:cNvPr id="5" name="TextBox 4"/>
+          <p:cNvSpPr txBox="1"/>
+          <p:nvPr/>
+        </p:nvSpPr>
+        <p:spPr>
+          <a:xfrm>
+            <a:off x="10332720" y="182880"/>
+            <a:ext cx="1645920" cy="320040"/>
+          </a:xfrm>
+          <a:prstGeom prst="rect">
+            <a:avLst/>
+          </a:prstGeom>
+          <a:noFill/>
+        </p:spPr>
+        <p:txBody>
+          <a:bodyPr wrap="none">
+            <a:spAutoFit/>
+          </a:bodyPr>
+          <a:lstStyle/>
+          <a:p>
+            <a:pPr algn="r">
+              <a:defRPr sz="1000">
+                <a:solidFill>
+                  <a:srgbClr val="DCE9E2"/>
+                </a:solidFill>
+              </a:defRPr>
+            </a:pPr>
+            <a:r>
+              <a:t>Olam Agri | Research Brief</a:t>
+            </a:r>
+          </a:p>
+        </p:txBody>
+      </p:sp>
+      <p:sp>
+        <p:nvSpPr>
+          <p:cNvPr id="6" name="TextBox 5"/>
+          <p:cNvSpPr txBox="1"/>
+          <p:nvPr/>
+        </p:nvSpPr>
+        <p:spPr>
+          <a:xfrm>
+            <a:off x="640080" y="987552"/>
+            <a:ext cx="10972800" cy="502920"/>
+          </a:xfrm>
+          <a:prstGeom prst="rect">
+            <a:avLst/>
+          </a:prstGeom>
+          <a:noFill/>
+        </p:spPr>
+        <p:txBody>
+          <a:bodyPr wrap="none">
+            <a:spAutoFit/>
+          </a:bodyPr>
+          <a:lstStyle/>
           <a:p>
             <a:pPr>
-              <a:defRPr sz="2200"/>
-            </a:pPr>
-            <a:r>
-              <a:t>Use middleware-first architecture (not direct SAP→search writes)</a:t>
-            </a:r>
-          </a:p>
+              <a:defRPr sz="1600">
+                <a:solidFill>
+                  <a:srgbClr val="586E61"/>
+                </a:solidFill>
+              </a:defRPr>
+            </a:pPr>
+            <a:r>
+              <a:t>Start narrow, harden early, and scale with explicit gates.</a:t>
+            </a:r>
+          </a:p>
+        </p:txBody>
+      </p:sp>
+      <p:sp>
+        <p:nvSpPr>
+          <p:cNvPr id="7" name="Rounded Rectangle 6"/>
+          <p:cNvSpPr/>
+          <p:nvPr/>
+        </p:nvSpPr>
+        <p:spPr>
+          <a:xfrm>
+            <a:off x="548640" y="1508760"/>
+            <a:ext cx="11064240" cy="4892040"/>
+          </a:xfrm>
+          <a:prstGeom prst="roundRect">
+            <a:avLst/>
+          </a:prstGeom>
+          <a:solidFill>
+            <a:srgbClr val="FFFFFF"/>
+          </a:solidFill>
+          <a:ln>
+            <a:solidFill>
+              <a:srgbClr val="D8E1DA"/>
+            </a:solidFill>
+          </a:ln>
+        </p:spPr>
+        <p:style>
+          <a:lnRef idx="1">
+            <a:schemeClr val="accent1"/>
+          </a:lnRef>
+          <a:fillRef idx="3">
+            <a:schemeClr val="accent1"/>
+          </a:fillRef>
+          <a:effectRef idx="2">
+            <a:schemeClr val="accent1"/>
+          </a:effectRef>
+          <a:fontRef idx="minor">
+            <a:schemeClr val="lt1"/>
+          </a:fontRef>
+        </p:style>
+        <p:txBody>
+          <a:bodyPr rtlCol="0" anchor="ctr"/>
+          <a:lstStyle/>
+          <a:p>
+            <a:pPr algn="ctr"/>
+          </a:p>
+        </p:txBody>
+      </p:sp>
+      <p:sp>
+        <p:nvSpPr>
+          <p:cNvPr id="8" name="TextBox 7"/>
+          <p:cNvSpPr txBox="1"/>
+          <p:nvPr/>
+        </p:nvSpPr>
+        <p:spPr>
+          <a:xfrm>
+            <a:off x="914400" y="1828800"/>
+            <a:ext cx="10332720" cy="4297680"/>
+          </a:xfrm>
+          <a:prstGeom prst="rect">
+            <a:avLst/>
+          </a:prstGeom>
+          <a:noFill/>
+        </p:spPr>
+        <p:txBody>
+          <a:bodyPr wrap="square">
+            <a:spAutoFit/>
+          </a:bodyPr>
+          <a:lstStyle/>
           <a:p>
             <a:pPr>
-              <a:defRPr sz="2200"/>
-            </a:pPr>
-            <a:r>
-              <a:t>Set explicit performance SLOs and tune indexing limits early</a:t>
+              <a:spcAft>
+                <a:spcPts val="1000"/>
+              </a:spcAft>
+              <a:defRPr sz="2200">
+                <a:solidFill>
+                  <a:srgbClr val="23372A"/>
+                </a:solidFill>
+              </a:defRPr>
+            </a:pPr>
+            <a:r>
+              <a:t>Begin with one high-value domain and measurable SLOs</a:t>
             </a:r>
           </a:p>
           <a:p>
             <a:pPr>
-              <a:defRPr sz="2200"/>
-            </a:pPr>
-            <a:r>
-              <a:t>If HA/horizontal scale is mandatory, plan Enterprise edition from day one</a:t>
+              <a:spcAft>
+                <a:spcPts val="1000"/>
+              </a:spcAft>
+              <a:defRPr sz="2200">
+                <a:solidFill>
+                  <a:srgbClr val="23372A"/>
+                </a:solidFill>
+              </a:defRPr>
+            </a:pPr>
+            <a:r>
+              <a:t>Institutionalize ingestion controls before widening scope</a:t>
+            </a:r>
+          </a:p>
+          <a:p>
+            <a:pPr>
+              <a:spcAft>
+                <a:spcPts val="1000"/>
+              </a:spcAft>
+              <a:defRPr sz="2200">
+                <a:solidFill>
+                  <a:srgbClr val="23372A"/>
+                </a:solidFill>
+              </a:defRPr>
+            </a:pPr>
+            <a:r>
+              <a:t>Use edition decision gates tied to capacity and HA thresholds</a:t>
             </a:r>
           </a:p>
         </p:txBody>

</xml_diff>

<commit_message>
revise: simplify report and slides for clearer human-readable delivery
Agent-Logs-Url: https://github.com/DARREN-2000/temporary/sessions/a753241f-4d7d-4468-9811-acf80481a380

Co-authored-by: DARREN-2000 <59622013+DARREN-2000@users.noreply.github.com>
</commit_message>
<xml_diff>
--- a/Meilisearch_Olam_Agri_Presentation.pptx
+++ b/Meilisearch_Olam_Agri_Presentation.pptx
@@ -14,7 +14,6 @@
     <p:sldId id="262" r:id="rId13"/>
     <p:sldId id="263" r:id="rId14"/>
     <p:sldId id="264" r:id="rId15"/>
-    <p:sldId id="265" r:id="rId16"/>
   </p:sldIdLst>
   <p:sldSz cx="12191695" cy="6858000" type="screen4x3"/>
   <p:notesSz cx="6858000" cy="9144000"/>
@@ -3112,7 +3111,7 @@
             <a:avLst/>
           </a:prstGeom>
           <a:solidFill>
-            <a:srgbClr val="F6F8F4"/>
+            <a:srgbClr val="F7F9F6"/>
           </a:solidFill>
           <a:ln>
             <a:noFill/>
@@ -3149,13 +3148,13 @@
         <p:spPr>
           <a:xfrm>
             <a:off x="0" y="0"/>
-            <a:ext cx="12191695" cy="777240"/>
+            <a:ext cx="12191695" cy="749808"/>
           </a:xfrm>
           <a:prstGeom prst="rect">
             <a:avLst/>
           </a:prstGeom>
           <a:solidFill>
-            <a:srgbClr val="123524"/>
+            <a:srgbClr val="18402C"/>
           </a:solidFill>
           <a:ln>
             <a:noFill/>
@@ -3191,8 +3190,8 @@
         </p:nvSpPr>
         <p:spPr>
           <a:xfrm>
-            <a:off x="502920" y="146304"/>
-            <a:ext cx="8961120" cy="457200"/>
+            <a:off x="502920" y="128016"/>
+            <a:ext cx="9601200" cy="457200"/>
           </a:xfrm>
           <a:prstGeom prst="rect">
             <a:avLst/>
@@ -3213,7 +3212,7 @@
               </a:defRPr>
             </a:pPr>
             <a:r>
-              <a:t>Meilisearch Adoption Blueprint for Olam Agri</a:t>
+              <a:t>Meilisearch Plan for Olam Agri</a:t>
             </a:r>
           </a:p>
         </p:txBody>
@@ -3226,8 +3225,8 @@
         </p:nvSpPr>
         <p:spPr>
           <a:xfrm>
-            <a:off x="10332720" y="182880"/>
-            <a:ext cx="1645920" cy="320040"/>
+            <a:off x="9875520" y="182880"/>
+            <a:ext cx="2103120" cy="320040"/>
           </a:xfrm>
           <a:prstGeom prst="rect">
             <a:avLst/>
@@ -3243,12 +3242,12 @@
             <a:pPr algn="r">
               <a:defRPr sz="1000">
                 <a:solidFill>
-                  <a:srgbClr val="DCE9E2"/>
+                  <a:srgbClr val="D7E3DD"/>
                 </a:solidFill>
               </a:defRPr>
             </a:pPr>
             <a:r>
-              <a:t>Olam Agri | Research Brief</a:t>
+              <a:t>Olam Agri</a:t>
             </a:r>
           </a:p>
         </p:txBody>
@@ -3261,8 +3260,8 @@
         </p:nvSpPr>
         <p:spPr>
           <a:xfrm>
-            <a:off x="685800" y="1874519"/>
-            <a:ext cx="10789920" cy="1463040"/>
+            <a:off x="685800" y="1828800"/>
+            <a:ext cx="10789920" cy="1371600"/>
           </a:xfrm>
           <a:prstGeom prst="rect">
             <a:avLst/>
@@ -3276,14 +3275,14 @@
           <a:lstStyle/>
           <a:p>
             <a:pPr>
-              <a:defRPr sz="3400" b="1">
-                <a:solidFill>
-                  <a:srgbClr val="1E3C2C"/>
+              <a:defRPr sz="3600" b="1">
+                <a:solidFill>
+                  <a:srgbClr val="1D3226"/>
                 </a:solidFill>
               </a:defRPr>
             </a:pPr>
             <a:r>
-              <a:t>Architecture, performance behavior, self-hosting strategy, and implementation blockers</a:t>
+              <a:t>Simple rollout plan for fast and reliable search</a:t>
             </a:r>
           </a:p>
         </p:txBody>
@@ -3296,8 +3295,8 @@
         </p:nvSpPr>
         <p:spPr>
           <a:xfrm>
-            <a:off x="685800" y="4069080"/>
-            <a:ext cx="7315200" cy="1280160"/>
+            <a:off x="685800" y="3931920"/>
+            <a:ext cx="7772400" cy="914400"/>
           </a:xfrm>
           <a:prstGeom prst="rect">
             <a:avLst/>
@@ -3311,353 +3310,14 @@
           <a:lstStyle/>
           <a:p>
             <a:pPr>
-              <a:defRPr sz="1700">
-                <a:solidFill>
-                  <a:srgbClr val="4E6558"/>
+              <a:defRPr sz="2000">
+                <a:solidFill>
+                  <a:srgbClr val="50685C"/>
                 </a:solidFill>
               </a:defRPr>
             </a:pPr>
             <a:r>
-              <a:t>Technical Brief</a:t>
-            </a:r>
-          </a:p>
-          <a:p>
-            <a:pPr>
-              <a:defRPr sz="1700">
-                <a:solidFill>
-                  <a:srgbClr val="4E6558"/>
-                </a:solidFill>
-              </a:defRPr>
-            </a:pPr>
-            <a:r>
-              <a:t>30 March 2026</a:t>
-            </a:r>
-          </a:p>
-          <a:p>
-            <a:r>
-              <a:t>Prepared for submission and presentation</a:t>
-            </a:r>
-          </a:p>
-        </p:txBody>
-      </p:sp>
-    </p:spTree>
-  </p:cSld>
-  <p:clrMapOvr>
-    <a:masterClrMapping/>
-  </p:clrMapOvr>
-</p:sld>
-</file>
-
-<file path=ppt/slides/slide10.xml><?xml version="1.0" encoding="utf-8"?>
-<p:sld xmlns:a="http://schemas.openxmlformats.org/drawingml/2006/main" xmlns:p="http://schemas.openxmlformats.org/presentationml/2006/main" xmlns:r="http://schemas.openxmlformats.org/officeDocument/2006/relationships">
-  <p:cSld>
-    <p:spTree>
-      <p:nvGrpSpPr>
-        <p:cNvPr id="1" name=""/>
-        <p:cNvGrpSpPr/>
-        <p:nvPr/>
-      </p:nvGrpSpPr>
-      <p:grpSpPr/>
-      <p:sp>
-        <p:nvSpPr>
-          <p:cNvPr id="2" name="Rectangle 1"/>
-          <p:cNvSpPr/>
-          <p:nvPr/>
-        </p:nvSpPr>
-        <p:spPr>
-          <a:xfrm>
-            <a:off x="0" y="0"/>
-            <a:ext cx="12191695" cy="6858000"/>
-          </a:xfrm>
-          <a:prstGeom prst="rect">
-            <a:avLst/>
-          </a:prstGeom>
-          <a:solidFill>
-            <a:srgbClr val="F6F8F4"/>
-          </a:solidFill>
-          <a:ln>
-            <a:noFill/>
-          </a:ln>
-        </p:spPr>
-        <p:style>
-          <a:lnRef idx="1">
-            <a:schemeClr val="accent1"/>
-          </a:lnRef>
-          <a:fillRef idx="3">
-            <a:schemeClr val="accent1"/>
-          </a:fillRef>
-          <a:effectRef idx="2">
-            <a:schemeClr val="accent1"/>
-          </a:effectRef>
-          <a:fontRef idx="minor">
-            <a:schemeClr val="lt1"/>
-          </a:fontRef>
-        </p:style>
-        <p:txBody>
-          <a:bodyPr rtlCol="0" anchor="ctr"/>
-          <a:lstStyle/>
-          <a:p>
-            <a:pPr algn="ctr"/>
-          </a:p>
-        </p:txBody>
-      </p:sp>
-      <p:sp>
-        <p:nvSpPr>
-          <p:cNvPr id="3" name="Rectangle 2"/>
-          <p:cNvSpPr/>
-          <p:nvPr/>
-        </p:nvSpPr>
-        <p:spPr>
-          <a:xfrm>
-            <a:off x="0" y="0"/>
-            <a:ext cx="12191695" cy="777240"/>
-          </a:xfrm>
-          <a:prstGeom prst="rect">
-            <a:avLst/>
-          </a:prstGeom>
-          <a:solidFill>
-            <a:srgbClr val="123524"/>
-          </a:solidFill>
-          <a:ln>
-            <a:noFill/>
-          </a:ln>
-        </p:spPr>
-        <p:style>
-          <a:lnRef idx="1">
-            <a:schemeClr val="accent1"/>
-          </a:lnRef>
-          <a:fillRef idx="3">
-            <a:schemeClr val="accent1"/>
-          </a:fillRef>
-          <a:effectRef idx="2">
-            <a:schemeClr val="accent1"/>
-          </a:effectRef>
-          <a:fontRef idx="minor">
-            <a:schemeClr val="lt1"/>
-          </a:fontRef>
-        </p:style>
-        <p:txBody>
-          <a:bodyPr rtlCol="0" anchor="ctr"/>
-          <a:lstStyle/>
-          <a:p>
-            <a:pPr algn="ctr"/>
-          </a:p>
-        </p:txBody>
-      </p:sp>
-      <p:sp>
-        <p:nvSpPr>
-          <p:cNvPr id="4" name="TextBox 3"/>
-          <p:cNvSpPr txBox="1"/>
-          <p:nvPr/>
-        </p:nvSpPr>
-        <p:spPr>
-          <a:xfrm>
-            <a:off x="502920" y="146304"/>
-            <a:ext cx="8961120" cy="457200"/>
-          </a:xfrm>
-          <a:prstGeom prst="rect">
-            <a:avLst/>
-          </a:prstGeom>
-          <a:noFill/>
-        </p:spPr>
-        <p:txBody>
-          <a:bodyPr wrap="none">
-            <a:spAutoFit/>
-          </a:bodyPr>
-          <a:lstStyle/>
-          <a:p>
-            <a:pPr>
-              <a:defRPr sz="2400" b="1">
-                <a:solidFill>
-                  <a:srgbClr val="FFFFFF"/>
-                </a:solidFill>
-              </a:defRPr>
-            </a:pPr>
-            <a:r>
-              <a:t>References</a:t>
-            </a:r>
-          </a:p>
-        </p:txBody>
-      </p:sp>
-      <p:sp>
-        <p:nvSpPr>
-          <p:cNvPr id="5" name="TextBox 4"/>
-          <p:cNvSpPr txBox="1"/>
-          <p:nvPr/>
-        </p:nvSpPr>
-        <p:spPr>
-          <a:xfrm>
-            <a:off x="10332720" y="182880"/>
-            <a:ext cx="1645920" cy="320040"/>
-          </a:xfrm>
-          <a:prstGeom prst="rect">
-            <a:avLst/>
-          </a:prstGeom>
-          <a:noFill/>
-        </p:spPr>
-        <p:txBody>
-          <a:bodyPr wrap="none">
-            <a:spAutoFit/>
-          </a:bodyPr>
-          <a:lstStyle/>
-          <a:p>
-            <a:pPr algn="r">
-              <a:defRPr sz="1000">
-                <a:solidFill>
-                  <a:srgbClr val="DCE9E2"/>
-                </a:solidFill>
-              </a:defRPr>
-            </a:pPr>
-            <a:r>
-              <a:t>Olam Agri | Research Brief</a:t>
-            </a:r>
-          </a:p>
-        </p:txBody>
-      </p:sp>
-      <p:sp>
-        <p:nvSpPr>
-          <p:cNvPr id="6" name="TextBox 5"/>
-          <p:cNvSpPr txBox="1"/>
-          <p:nvPr/>
-        </p:nvSpPr>
-        <p:spPr>
-          <a:xfrm>
-            <a:off x="640080" y="987552"/>
-            <a:ext cx="10972800" cy="502920"/>
-          </a:xfrm>
-          <a:prstGeom prst="rect">
-            <a:avLst/>
-          </a:prstGeom>
-          <a:noFill/>
-        </p:spPr>
-        <p:txBody>
-          <a:bodyPr wrap="none">
-            <a:spAutoFit/>
-          </a:bodyPr>
-          <a:lstStyle/>
-          <a:p>
-            <a:pPr>
-              <a:defRPr sz="1600">
-                <a:solidFill>
-                  <a:srgbClr val="586E61"/>
-                </a:solidFill>
-              </a:defRPr>
-            </a:pPr>
-            <a:r>
-              <a:t>Primary documentation used in this technical brief.</a:t>
-            </a:r>
-          </a:p>
-        </p:txBody>
-      </p:sp>
-      <p:sp>
-        <p:nvSpPr>
-          <p:cNvPr id="7" name="Rounded Rectangle 6"/>
-          <p:cNvSpPr/>
-          <p:nvPr/>
-        </p:nvSpPr>
-        <p:spPr>
-          <a:xfrm>
-            <a:off x="548640" y="1508760"/>
-            <a:ext cx="11064240" cy="4892040"/>
-          </a:xfrm>
-          <a:prstGeom prst="roundRect">
-            <a:avLst/>
-          </a:prstGeom>
-          <a:solidFill>
-            <a:srgbClr val="FFFFFF"/>
-          </a:solidFill>
-          <a:ln>
-            <a:solidFill>
-              <a:srgbClr val="D8E1DA"/>
-            </a:solidFill>
-          </a:ln>
-        </p:spPr>
-        <p:style>
-          <a:lnRef idx="1">
-            <a:schemeClr val="accent1"/>
-          </a:lnRef>
-          <a:fillRef idx="3">
-            <a:schemeClr val="accent1"/>
-          </a:fillRef>
-          <a:effectRef idx="2">
-            <a:schemeClr val="accent1"/>
-          </a:effectRef>
-          <a:fontRef idx="minor">
-            <a:schemeClr val="lt1"/>
-          </a:fontRef>
-        </p:style>
-        <p:txBody>
-          <a:bodyPr rtlCol="0" anchor="ctr"/>
-          <a:lstStyle/>
-          <a:p>
-            <a:pPr algn="ctr"/>
-          </a:p>
-        </p:txBody>
-      </p:sp>
-      <p:sp>
-        <p:nvSpPr>
-          <p:cNvPr id="8" name="TextBox 7"/>
-          <p:cNvSpPr txBox="1"/>
-          <p:nvPr/>
-        </p:nvSpPr>
-        <p:spPr>
-          <a:xfrm>
-            <a:off x="914400" y="1828800"/>
-            <a:ext cx="10332720" cy="4297680"/>
-          </a:xfrm>
-          <a:prstGeom prst="rect">
-            <a:avLst/>
-          </a:prstGeom>
-          <a:noFill/>
-        </p:spPr>
-        <p:txBody>
-          <a:bodyPr wrap="square">
-            <a:spAutoFit/>
-          </a:bodyPr>
-          <a:lstStyle/>
-          <a:p>
-            <a:pPr>
-              <a:spcAft>
-                <a:spcPts val="1000"/>
-              </a:spcAft>
-              <a:defRPr sz="2200">
-                <a:solidFill>
-                  <a:srgbClr val="23372A"/>
-                </a:solidFill>
-              </a:defRPr>
-            </a:pPr>
-            <a:r>
-              <a:t>Meilisearch: FAQ, Known Limitations, Configuration Reference</a:t>
-            </a:r>
-          </a:p>
-          <a:p>
-            <a:pPr>
-              <a:spcAft>
-                <a:spcPts val="1000"/>
-              </a:spcAft>
-              <a:defRPr sz="2200">
-                <a:solidFill>
-                  <a:srgbClr val="23372A"/>
-                </a:solidFill>
-              </a:defRPr>
-            </a:pPr>
-            <a:r>
-              <a:t>Meilisearch: RAM/Threading performance guidance, Docker and local install guides</a:t>
-            </a:r>
-          </a:p>
-          <a:p>
-            <a:pPr>
-              <a:spcAft>
-                <a:spcPts val="1000"/>
-              </a:spcAft>
-              <a:defRPr sz="2200">
-                <a:solidFill>
-                  <a:srgbClr val="23372A"/>
-                </a:solidFill>
-              </a:defRPr>
-            </a:pPr>
-            <a:r>
-              <a:t>Meilisearch: Security &amp; tenant tokens, Community vs Enterprise, sharding/replication overview</a:t>
+              <a:t>Clear architecture | practical risks | 12-week roadmap</a:t>
             </a:r>
           </a:p>
         </p:txBody>
@@ -3695,7 +3355,7 @@
             <a:avLst/>
           </a:prstGeom>
           <a:solidFill>
-            <a:srgbClr val="F6F8F4"/>
+            <a:srgbClr val="F7F9F6"/>
           </a:solidFill>
           <a:ln>
             <a:noFill/>
@@ -3732,13 +3392,13 @@
         <p:spPr>
           <a:xfrm>
             <a:off x="0" y="0"/>
-            <a:ext cx="12191695" cy="777240"/>
+            <a:ext cx="12191695" cy="749808"/>
           </a:xfrm>
           <a:prstGeom prst="rect">
             <a:avLst/>
           </a:prstGeom>
           <a:solidFill>
-            <a:srgbClr val="123524"/>
+            <a:srgbClr val="18402C"/>
           </a:solidFill>
           <a:ln>
             <a:noFill/>
@@ -3774,8 +3434,8 @@
         </p:nvSpPr>
         <p:spPr>
           <a:xfrm>
-            <a:off x="502920" y="146304"/>
-            <a:ext cx="8961120" cy="457200"/>
+            <a:off x="502920" y="128016"/>
+            <a:ext cx="9601200" cy="457200"/>
           </a:xfrm>
           <a:prstGeom prst="rect">
             <a:avLst/>
@@ -3796,7 +3456,7 @@
               </a:defRPr>
             </a:pPr>
             <a:r>
-              <a:t>Executive Position</a:t>
+              <a:t>What we are trying to solve</a:t>
             </a:r>
           </a:p>
         </p:txBody>
@@ -3809,8 +3469,8 @@
         </p:nvSpPr>
         <p:spPr>
           <a:xfrm>
-            <a:off x="10332720" y="182880"/>
-            <a:ext cx="1645920" cy="320040"/>
+            <a:off x="9875520" y="182880"/>
+            <a:ext cx="2103120" cy="320040"/>
           </a:xfrm>
           <a:prstGeom prst="rect">
             <a:avLst/>
@@ -3826,12 +3486,12 @@
             <a:pPr algn="r">
               <a:defRPr sz="1000">
                 <a:solidFill>
-                  <a:srgbClr val="DCE9E2"/>
+                  <a:srgbClr val="D7E3DD"/>
                 </a:solidFill>
               </a:defRPr>
             </a:pPr>
             <a:r>
-              <a:t>Olam Agri | Research Brief</a:t>
+              <a:t>Olam Agri</a:t>
             </a:r>
           </a:p>
         </p:txBody>
@@ -3844,8 +3504,8 @@
         </p:nvSpPr>
         <p:spPr>
           <a:xfrm>
-            <a:off x="640080" y="987552"/>
-            <a:ext cx="10972800" cy="502920"/>
+            <a:off x="685800" y="960120"/>
+            <a:ext cx="10972800" cy="548640"/>
           </a:xfrm>
           <a:prstGeom prst="rect">
             <a:avLst/>
@@ -3861,12 +3521,12 @@
             <a:pPr>
               <a:defRPr sz="1600">
                 <a:solidFill>
-                  <a:srgbClr val="586E61"/>
+                  <a:srgbClr val="50685C"/>
                 </a:solidFill>
               </a:defRPr>
             </a:pPr>
             <a:r>
-              <a:t>Meilisearch is viable for Olam Agri interactive retrieval if integrated as a governed search layer.</a:t>
+              <a:t>Goal: help users find the right data quickly.</a:t>
             </a:r>
           </a:p>
         </p:txBody>
@@ -3879,8 +3539,8 @@
         </p:nvSpPr>
         <p:spPr>
           <a:xfrm>
-            <a:off x="548640" y="1508760"/>
-            <a:ext cx="11064240" cy="4892040"/>
+            <a:off x="594360" y="1508760"/>
+            <a:ext cx="10972800" cy="4892040"/>
           </a:xfrm>
           <a:prstGeom prst="roundRect">
             <a:avLst/>
@@ -3890,7 +3550,7 @@
           </a:solidFill>
           <a:ln>
             <a:solidFill>
-              <a:srgbClr val="D8E1DA"/>
+              <a:srgbClr val="D6DFD9"/>
             </a:solidFill>
           </a:ln>
         </p:spPr>
@@ -3925,7 +3585,7 @@
         <p:spPr>
           <a:xfrm>
             <a:off x="914400" y="1828800"/>
-            <a:ext cx="10332720" cy="4297680"/>
+            <a:ext cx="10241280" cy="4389120"/>
           </a:xfrm>
           <a:prstGeom prst="rect">
             <a:avLst/>
@@ -3942,14 +3602,14 @@
               <a:spcAft>
                 <a:spcPts val="1000"/>
               </a:spcAft>
-              <a:defRPr sz="2200">
-                <a:solidFill>
-                  <a:srgbClr val="23372A"/>
+              <a:defRPr sz="2400">
+                <a:solidFill>
+                  <a:srgbClr val="1D3226"/>
                 </a:solidFill>
               </a:defRPr>
             </a:pPr>
             <a:r>
-              <a:t>Use middleware-centric ingestion rather than direct source-to-search writes</a:t>
+              <a:t>• Search across business data without slowing source systems</a:t>
             </a:r>
           </a:p>
           <a:p>
@@ -3957,14 +3617,14 @@
               <a:spcAft>
                 <a:spcPts val="1000"/>
               </a:spcAft>
-              <a:defRPr sz="2200">
-                <a:solidFill>
-                  <a:srgbClr val="23372A"/>
+              <a:defRPr sz="2400">
+                <a:solidFill>
+                  <a:srgbClr val="1D3226"/>
                 </a:solidFill>
               </a:defRPr>
             </a:pPr>
             <a:r>
-              <a:t>Treat indexing controls as production safeguards, not optional tuning</a:t>
+              <a:t>• Keep SAP as source of truth</a:t>
             </a:r>
           </a:p>
           <a:p>
@@ -3972,14 +3632,14 @@
               <a:spcAft>
                 <a:spcPts val="1000"/>
               </a:spcAft>
-              <a:defRPr sz="2200">
-                <a:solidFill>
-                  <a:srgbClr val="23372A"/>
+              <a:defRPr sz="2400">
+                <a:solidFill>
+                  <a:srgbClr val="1D3226"/>
                 </a:solidFill>
               </a:defRPr>
             </a:pPr>
             <a:r>
-              <a:t>Decide early whether HA/horizontal scale requires Enterprise Edition</a:t>
+              <a:t>• Give users fast and relevant results</a:t>
             </a:r>
           </a:p>
         </p:txBody>
@@ -4017,7 +3677,7 @@
             <a:avLst/>
           </a:prstGeom>
           <a:solidFill>
-            <a:srgbClr val="F6F8F4"/>
+            <a:srgbClr val="F7F9F6"/>
           </a:solidFill>
           <a:ln>
             <a:noFill/>
@@ -4054,13 +3714,13 @@
         <p:spPr>
           <a:xfrm>
             <a:off x="0" y="0"/>
-            <a:ext cx="12191695" cy="777240"/>
+            <a:ext cx="12191695" cy="749808"/>
           </a:xfrm>
           <a:prstGeom prst="rect">
             <a:avLst/>
           </a:prstGeom>
           <a:solidFill>
-            <a:srgbClr val="123524"/>
+            <a:srgbClr val="18402C"/>
           </a:solidFill>
           <a:ln>
             <a:noFill/>
@@ -4096,8 +3756,8 @@
         </p:nvSpPr>
         <p:spPr>
           <a:xfrm>
-            <a:off x="502920" y="146304"/>
-            <a:ext cx="8961120" cy="457200"/>
+            <a:off x="502920" y="128016"/>
+            <a:ext cx="9601200" cy="457200"/>
           </a:xfrm>
           <a:prstGeom prst="rect">
             <a:avLst/>
@@ -4118,7 +3778,7 @@
               </a:defRPr>
             </a:pPr>
             <a:r>
-              <a:t>Reference Architecture</a:t>
+              <a:t>How the system should work</a:t>
             </a:r>
           </a:p>
         </p:txBody>
@@ -4131,8 +3791,8 @@
         </p:nvSpPr>
         <p:spPr>
           <a:xfrm>
-            <a:off x="10332720" y="182880"/>
-            <a:ext cx="1645920" cy="320040"/>
+            <a:off x="9875520" y="182880"/>
+            <a:ext cx="2103120" cy="320040"/>
           </a:xfrm>
           <a:prstGeom prst="rect">
             <a:avLst/>
@@ -4148,12 +3808,12 @@
             <a:pPr algn="r">
               <a:defRPr sz="1000">
                 <a:solidFill>
-                  <a:srgbClr val="DCE9E2"/>
+                  <a:srgbClr val="D7E3DD"/>
                 </a:solidFill>
               </a:defRPr>
             </a:pPr>
             <a:r>
-              <a:t>Olam Agri | Research Brief</a:t>
+              <a:t>Olam Agri</a:t>
             </a:r>
           </a:p>
         </p:txBody>
@@ -4166,8 +3826,8 @@
         </p:nvSpPr>
         <p:spPr>
           <a:xfrm>
-            <a:off x="640080" y="987552"/>
-            <a:ext cx="10972800" cy="502920"/>
+            <a:off x="685800" y="960120"/>
+            <a:ext cx="10972800" cy="548640"/>
           </a:xfrm>
           <a:prstGeom prst="rect">
             <a:avLst/>
@@ -4183,12 +3843,12 @@
             <a:pPr>
               <a:defRPr sz="1600">
                 <a:solidFill>
-                  <a:srgbClr val="586E61"/>
+                  <a:srgbClr val="50685C"/>
                 </a:solidFill>
               </a:defRPr>
             </a:pPr>
             <a:r>
-              <a:t>Data should move through a transformation and orchestration layer before indexing.</a:t>
+              <a:t>Use one simple data flow.</a:t>
             </a:r>
           </a:p>
         </p:txBody>
@@ -4201,8 +3861,8 @@
         </p:nvSpPr>
         <p:spPr>
           <a:xfrm>
-            <a:off x="548640" y="1508760"/>
-            <a:ext cx="11064240" cy="4892040"/>
+            <a:off x="594360" y="1508760"/>
+            <a:ext cx="10972800" cy="4892040"/>
           </a:xfrm>
           <a:prstGeom prst="roundRect">
             <a:avLst/>
@@ -4212,7 +3872,7 @@
           </a:solidFill>
           <a:ln>
             <a:solidFill>
-              <a:srgbClr val="D8E1DA"/>
+              <a:srgbClr val="D6DFD9"/>
             </a:solidFill>
           </a:ln>
         </p:spPr>
@@ -4247,7 +3907,7 @@
         <p:spPr>
           <a:xfrm>
             <a:off x="914400" y="1828800"/>
-            <a:ext cx="10332720" cy="4297680"/>
+            <a:ext cx="10241280" cy="4389120"/>
           </a:xfrm>
           <a:prstGeom prst="rect">
             <a:avLst/>
@@ -4264,14 +3924,14 @@
               <a:spcAft>
                 <a:spcPts val="1000"/>
               </a:spcAft>
-              <a:defRPr sz="2200">
-                <a:solidFill>
-                  <a:srgbClr val="23372A"/>
+              <a:defRPr sz="2400">
+                <a:solidFill>
+                  <a:srgbClr val="1D3226"/>
                 </a:solidFill>
               </a:defRPr>
             </a:pPr>
             <a:r>
-              <a:t>Source systems (SAP and adjacent platforms) remain systems of record</a:t>
+              <a:t>• Step 1: Source systems hold official data</a:t>
             </a:r>
           </a:p>
           <a:p>
@@ -4279,14 +3939,14 @@
               <a:spcAft>
                 <a:spcPts val="1000"/>
               </a:spcAft>
-              <a:defRPr sz="2200">
-                <a:solidFill>
-                  <a:srgbClr val="23372A"/>
+              <a:defRPr sz="2400">
+                <a:solidFill>
+                  <a:srgbClr val="1D3226"/>
                 </a:solidFill>
               </a:defRPr>
             </a:pPr>
             <a:r>
-              <a:t>Middleware performs denormalization, enrichment, and idempotent update handling</a:t>
+              <a:t>• Step 2: Middleware cleans and reshapes data</a:t>
             </a:r>
           </a:p>
           <a:p>
@@ -4294,14 +3954,29 @@
               <a:spcAft>
                 <a:spcPts val="1000"/>
               </a:spcAft>
-              <a:defRPr sz="2200">
-                <a:solidFill>
-                  <a:srgbClr val="23372A"/>
+              <a:defRPr sz="2400">
+                <a:solidFill>
+                  <a:srgbClr val="1D3226"/>
                 </a:solidFill>
               </a:defRPr>
             </a:pPr>
             <a:r>
-              <a:t>Applications query Meilisearch for low-latency retrieval paths</a:t>
+              <a:t>• Step 3: Meilisearch stores search-ready documents</a:t>
+            </a:r>
+          </a:p>
+          <a:p>
+            <a:pPr>
+              <a:spcAft>
+                <a:spcPts val="1000"/>
+              </a:spcAft>
+              <a:defRPr sz="2400">
+                <a:solidFill>
+                  <a:srgbClr val="1D3226"/>
+                </a:solidFill>
+              </a:defRPr>
+            </a:pPr>
+            <a:r>
+              <a:t>• Step 4: Apps call Meilisearch for user search</a:t>
             </a:r>
           </a:p>
         </p:txBody>
@@ -4339,7 +4014,7 @@
             <a:avLst/>
           </a:prstGeom>
           <a:solidFill>
-            <a:srgbClr val="F6F8F4"/>
+            <a:srgbClr val="F7F9F6"/>
           </a:solidFill>
           <a:ln>
             <a:noFill/>
@@ -4376,13 +4051,13 @@
         <p:spPr>
           <a:xfrm>
             <a:off x="0" y="0"/>
-            <a:ext cx="12191695" cy="777240"/>
+            <a:ext cx="12191695" cy="749808"/>
           </a:xfrm>
           <a:prstGeom prst="rect">
             <a:avLst/>
           </a:prstGeom>
           <a:solidFill>
-            <a:srgbClr val="123524"/>
+            <a:srgbClr val="18402C"/>
           </a:solidFill>
           <a:ln>
             <a:noFill/>
@@ -4418,8 +4093,8 @@
         </p:nvSpPr>
         <p:spPr>
           <a:xfrm>
-            <a:off x="502920" y="146304"/>
-            <a:ext cx="8961120" cy="457200"/>
+            <a:off x="502920" y="128016"/>
+            <a:ext cx="9601200" cy="457200"/>
           </a:xfrm>
           <a:prstGeom prst="rect">
             <a:avLst/>
@@ -4440,7 +4115,7 @@
               </a:defRPr>
             </a:pPr>
             <a:r>
-              <a:t>Performance and Resource Envelope</a:t>
+              <a:t>Most important performance rule</a:t>
             </a:r>
           </a:p>
         </p:txBody>
@@ -4453,8 +4128,8 @@
         </p:nvSpPr>
         <p:spPr>
           <a:xfrm>
-            <a:off x="10332720" y="182880"/>
-            <a:ext cx="1645920" cy="320040"/>
+            <a:off x="9875520" y="182880"/>
+            <a:ext cx="2103120" cy="320040"/>
           </a:xfrm>
           <a:prstGeom prst="rect">
             <a:avLst/>
@@ -4470,12 +4145,12 @@
             <a:pPr algn="r">
               <a:defRPr sz="1000">
                 <a:solidFill>
-                  <a:srgbClr val="DCE9E2"/>
+                  <a:srgbClr val="D7E3DD"/>
                 </a:solidFill>
               </a:defRPr>
             </a:pPr>
             <a:r>
-              <a:t>Olam Agri | Research Brief</a:t>
+              <a:t>Olam Agri</a:t>
             </a:r>
           </a:p>
         </p:txBody>
@@ -4488,7 +4163,7 @@
         </p:nvSpPr>
         <p:spPr>
           <a:xfrm>
-            <a:off x="548640" y="1188720"/>
+            <a:off x="594360" y="1143000"/>
             <a:ext cx="5440680" cy="5440680"/>
           </a:xfrm>
           <a:prstGeom prst="roundRect">
@@ -4499,7 +4174,7 @@
           </a:solidFill>
           <a:ln>
             <a:solidFill>
-              <a:srgbClr val="D8E1DA"/>
+              <a:srgbClr val="D6DFD9"/>
             </a:solidFill>
           </a:ln>
         </p:spPr>
@@ -4533,7 +4208,7 @@
         </p:nvSpPr>
         <p:spPr>
           <a:xfrm>
-            <a:off x="6172200" y="1188720"/>
+            <a:off x="6172200" y="1143000"/>
             <a:ext cx="5440680" cy="5440680"/>
           </a:xfrm>
           <a:prstGeom prst="roundRect">
@@ -4544,7 +4219,7 @@
           </a:solidFill>
           <a:ln>
             <a:solidFill>
-              <a:srgbClr val="D8E1DA"/>
+              <a:srgbClr val="D6DFD9"/>
             </a:solidFill>
           </a:ln>
         </p:spPr>
@@ -4578,8 +4253,8 @@
         </p:nvSpPr>
         <p:spPr>
           <a:xfrm>
-            <a:off x="868680" y="1417320"/>
-            <a:ext cx="4846320" cy="457200"/>
+            <a:off x="868680" y="1371600"/>
+            <a:ext cx="4754880" cy="411480"/>
           </a:xfrm>
           <a:prstGeom prst="rect">
             <a:avLst/>
@@ -4593,14 +4268,14 @@
           <a:lstStyle/>
           <a:p>
             <a:pPr>
-              <a:defRPr sz="1900" b="1">
-                <a:solidFill>
-                  <a:srgbClr val="2C5E42"/>
+              <a:defRPr sz="2000" b="1">
+                <a:solidFill>
+                  <a:srgbClr val="18402C"/>
                 </a:solidFill>
               </a:defRPr>
             </a:pPr>
             <a:r>
-              <a:t>Observed behavior to design for</a:t>
+              <a:t>What can go wrong</a:t>
             </a:r>
           </a:p>
         </p:txBody>
@@ -4613,8 +4288,8 @@
         </p:nvSpPr>
         <p:spPr>
           <a:xfrm>
-            <a:off x="6492240" y="1417320"/>
-            <a:ext cx="4846320" cy="457200"/>
+            <a:off x="6446520" y="1371600"/>
+            <a:ext cx="4754880" cy="411480"/>
           </a:xfrm>
           <a:prstGeom prst="rect">
             <a:avLst/>
@@ -4628,14 +4303,14 @@
           <a:lstStyle/>
           <a:p>
             <a:pPr>
-              <a:defRPr sz="1900" b="1">
-                <a:solidFill>
-                  <a:srgbClr val="2C5E42"/>
+              <a:defRPr sz="2000" b="1">
+                <a:solidFill>
+                  <a:srgbClr val="18402C"/>
                 </a:solidFill>
               </a:defRPr>
             </a:pPr>
             <a:r>
-              <a:t>Operational controls</a:t>
+              <a:t>What to do</a:t>
             </a:r>
           </a:p>
         </p:txBody>
@@ -4648,8 +4323,8 @@
         </p:nvSpPr>
         <p:spPr>
           <a:xfrm>
-            <a:off x="868680" y="1920240"/>
-            <a:ext cx="4754880" cy="4389120"/>
+            <a:off x="868680" y="1828800"/>
+            <a:ext cx="4800600" cy="4297680"/>
           </a:xfrm>
           <a:prstGeom prst="rect">
             <a:avLst/>
@@ -4666,14 +4341,14 @@
               <a:spcAft>
                 <a:spcPts val="800"/>
               </a:spcAft>
-              <a:defRPr sz="1650">
-                <a:solidFill>
-                  <a:srgbClr val="283E31"/>
+              <a:defRPr sz="1700">
+                <a:solidFill>
+                  <a:srgbClr val="1D3226"/>
                 </a:solidFill>
               </a:defRPr>
             </a:pPr>
             <a:r>
-              <a:t>• Indexing is memory-intensive and multi-threaded</a:t>
+              <a:t>• Indexing uses high memory and CPU</a:t>
             </a:r>
           </a:p>
           <a:p>
@@ -4681,14 +4356,14 @@
               <a:spcAft>
                 <a:spcPts val="800"/>
               </a:spcAft>
-              <a:defRPr sz="1650">
-                <a:solidFill>
-                  <a:srgbClr val="283E31"/>
+              <a:defRPr sz="1700">
+                <a:solidFill>
+                  <a:srgbClr val="1D3226"/>
                 </a:solidFill>
               </a:defRPr>
             </a:pPr>
             <a:r>
-              <a:t>• Unbounded indexing can degrade query responsiveness</a:t>
+              <a:t>• Large update jobs can slow user search</a:t>
             </a:r>
           </a:p>
           <a:p>
@@ -4696,14 +4371,14 @@
               <a:spcAft>
                 <a:spcPts val="800"/>
               </a:spcAft>
-              <a:defRPr sz="1650">
-                <a:solidFill>
-                  <a:srgbClr val="283E31"/>
+              <a:defRPr sz="1700">
+                <a:solidFill>
+                  <a:srgbClr val="1D3226"/>
                 </a:solidFill>
               </a:defRPr>
             </a:pPr>
             <a:r>
-              <a:t>• Large payload spikes increase OOM and latency risk</a:t>
+              <a:t>• No limits can cause unstable response times</a:t>
             </a:r>
           </a:p>
         </p:txBody>
@@ -4716,8 +4391,8 @@
         </p:nvSpPr>
         <p:spPr>
           <a:xfrm>
-            <a:off x="6492240" y="1920240"/>
-            <a:ext cx="4754880" cy="4389120"/>
+            <a:off x="6446520" y="1828800"/>
+            <a:ext cx="4800600" cy="4297680"/>
           </a:xfrm>
           <a:prstGeom prst="rect">
             <a:avLst/>
@@ -4734,14 +4409,14 @@
               <a:spcAft>
                 <a:spcPts val="800"/>
               </a:spcAft>
-              <a:defRPr sz="1650">
-                <a:solidFill>
-                  <a:srgbClr val="283E31"/>
+              <a:defRPr sz="1700">
+                <a:solidFill>
+                  <a:srgbClr val="1D3226"/>
                 </a:solidFill>
               </a:defRPr>
             </a:pPr>
             <a:r>
-              <a:t>• Set max-indexing-memory below host capacity</a:t>
+              <a:t>• Set memory and thread limits for indexing</a:t>
             </a:r>
           </a:p>
           <a:p>
@@ -4749,14 +4424,14 @@
               <a:spcAft>
                 <a:spcPts val="800"/>
               </a:spcAft>
-              <a:defRPr sz="1650">
-                <a:solidFill>
-                  <a:srgbClr val="283E31"/>
+              <a:defRPr sz="1700">
+                <a:solidFill>
+                  <a:srgbClr val="1D3226"/>
                 </a:solidFill>
               </a:defRPr>
             </a:pPr>
             <a:r>
-              <a:t>• Constrain max-indexing-threads for query headroom</a:t>
+              <a:t>• Send smaller batches more often</a:t>
             </a:r>
           </a:p>
           <a:p>
@@ -4764,14 +4439,14 @@
               <a:spcAft>
                 <a:spcPts val="800"/>
               </a:spcAft>
-              <a:defRPr sz="1650">
-                <a:solidFill>
-                  <a:srgbClr val="283E31"/>
+              <a:defRPr sz="1700">
+                <a:solidFill>
+                  <a:srgbClr val="1D3226"/>
                 </a:solidFill>
               </a:defRPr>
             </a:pPr>
             <a:r>
-              <a:t>• Ingest via bounded batches and monitored windows</a:t>
+              <a:t>• Track indexing queue and search latency daily</a:t>
             </a:r>
           </a:p>
         </p:txBody>
@@ -4809,7 +4484,7 @@
             <a:avLst/>
           </a:prstGeom>
           <a:solidFill>
-            <a:srgbClr val="F6F8F4"/>
+            <a:srgbClr val="F7F9F6"/>
           </a:solidFill>
           <a:ln>
             <a:noFill/>
@@ -4846,13 +4521,13 @@
         <p:spPr>
           <a:xfrm>
             <a:off x="0" y="0"/>
-            <a:ext cx="12191695" cy="777240"/>
+            <a:ext cx="12191695" cy="749808"/>
           </a:xfrm>
           <a:prstGeom prst="rect">
             <a:avLst/>
           </a:prstGeom>
           <a:solidFill>
-            <a:srgbClr val="123524"/>
+            <a:srgbClr val="18402C"/>
           </a:solidFill>
           <a:ln>
             <a:noFill/>
@@ -4888,8 +4563,8 @@
         </p:nvSpPr>
         <p:spPr>
           <a:xfrm>
-            <a:off x="502920" y="146304"/>
-            <a:ext cx="8961120" cy="457200"/>
+            <a:off x="502920" y="128016"/>
+            <a:ext cx="9601200" cy="457200"/>
           </a:xfrm>
           <a:prstGeom prst="rect">
             <a:avLst/>
@@ -4910,7 +4585,7 @@
               </a:defRPr>
             </a:pPr>
             <a:r>
-              <a:t>Requirements for Production Readiness</a:t>
+              <a:t>Deployment options (easy view)</a:t>
             </a:r>
           </a:p>
         </p:txBody>
@@ -4923,8 +4598,8 @@
         </p:nvSpPr>
         <p:spPr>
           <a:xfrm>
-            <a:off x="10332720" y="182880"/>
-            <a:ext cx="1645920" cy="320040"/>
+            <a:off x="9875520" y="182880"/>
+            <a:ext cx="2103120" cy="320040"/>
           </a:xfrm>
           <a:prstGeom prst="rect">
             <a:avLst/>
@@ -4940,12 +4615,12 @@
             <a:pPr algn="r">
               <a:defRPr sz="1000">
                 <a:solidFill>
-                  <a:srgbClr val="DCE9E2"/>
+                  <a:srgbClr val="D7E3DD"/>
                 </a:solidFill>
               </a:defRPr>
             </a:pPr>
             <a:r>
-              <a:t>Olam Agri | Research Brief</a:t>
+              <a:t>Olam Agri</a:t>
             </a:r>
           </a:p>
         </p:txBody>
@@ -4958,7 +4633,7 @@
         </p:nvSpPr>
         <p:spPr>
           <a:xfrm>
-            <a:off x="548640" y="1188720"/>
+            <a:off x="594360" y="1143000"/>
             <a:ext cx="5440680" cy="5440680"/>
           </a:xfrm>
           <a:prstGeom prst="roundRect">
@@ -4969,7 +4644,7 @@
           </a:solidFill>
           <a:ln>
             <a:solidFill>
-              <a:srgbClr val="D8E1DA"/>
+              <a:srgbClr val="D6DFD9"/>
             </a:solidFill>
           </a:ln>
         </p:spPr>
@@ -5003,7 +4678,7 @@
         </p:nvSpPr>
         <p:spPr>
           <a:xfrm>
-            <a:off x="6172200" y="1188720"/>
+            <a:off x="6172200" y="1143000"/>
             <a:ext cx="5440680" cy="5440680"/>
           </a:xfrm>
           <a:prstGeom prst="roundRect">
@@ -5014,7 +4689,7 @@
           </a:solidFill>
           <a:ln>
             <a:solidFill>
-              <a:srgbClr val="D8E1DA"/>
+              <a:srgbClr val="D6DFD9"/>
             </a:solidFill>
           </a:ln>
         </p:spPr>
@@ -5048,8 +4723,8 @@
         </p:nvSpPr>
         <p:spPr>
           <a:xfrm>
-            <a:off x="868680" y="1417320"/>
-            <a:ext cx="4846320" cy="457200"/>
+            <a:off x="868680" y="1371600"/>
+            <a:ext cx="4754880" cy="411480"/>
           </a:xfrm>
           <a:prstGeom prst="rect">
             <a:avLst/>
@@ -5063,14 +4738,14 @@
           <a:lstStyle/>
           <a:p>
             <a:pPr>
-              <a:defRPr sz="1900" b="1">
-                <a:solidFill>
-                  <a:srgbClr val="2C5E42"/>
+              <a:defRPr sz="2000" b="1">
+                <a:solidFill>
+                  <a:srgbClr val="18402C"/>
                 </a:solidFill>
               </a:defRPr>
             </a:pPr>
             <a:r>
-              <a:t>Technical baseline</a:t>
+              <a:t>Community Edition</a:t>
             </a:r>
           </a:p>
         </p:txBody>
@@ -5083,8 +4758,8 @@
         </p:nvSpPr>
         <p:spPr>
           <a:xfrm>
-            <a:off x="6492240" y="1417320"/>
-            <a:ext cx="4846320" cy="457200"/>
+            <a:off x="6446520" y="1371600"/>
+            <a:ext cx="4754880" cy="411480"/>
           </a:xfrm>
           <a:prstGeom prst="rect">
             <a:avLst/>
@@ -5098,14 +4773,14 @@
           <a:lstStyle/>
           <a:p>
             <a:pPr>
-              <a:defRPr sz="1900" b="1">
-                <a:solidFill>
-                  <a:srgbClr val="2C5E42"/>
+              <a:defRPr sz="2000" b="1">
+                <a:solidFill>
+                  <a:srgbClr val="18402C"/>
                 </a:solidFill>
               </a:defRPr>
             </a:pPr>
             <a:r>
-              <a:t>Operating baseline</a:t>
+              <a:t>Enterprise / Cloud</a:t>
             </a:r>
           </a:p>
         </p:txBody>
@@ -5118,8 +4793,8 @@
         </p:nvSpPr>
         <p:spPr>
           <a:xfrm>
-            <a:off x="868680" y="1920240"/>
-            <a:ext cx="4754880" cy="4389120"/>
+            <a:off x="868680" y="1828800"/>
+            <a:ext cx="4800600" cy="4297680"/>
           </a:xfrm>
           <a:prstGeom prst="rect">
             <a:avLst/>
@@ -5136,14 +4811,14 @@
               <a:spcAft>
                 <a:spcPts val="800"/>
               </a:spcAft>
-              <a:defRPr sz="1650">
-                <a:solidFill>
-                  <a:srgbClr val="283E31"/>
+              <a:defRPr sz="1700">
+                <a:solidFill>
+                  <a:srgbClr val="1D3226"/>
                 </a:solidFill>
               </a:defRPr>
             </a:pPr>
             <a:r>
-              <a:t>• Production mode with strong master-key governance</a:t>
+              <a:t>• Best for first rollout</a:t>
             </a:r>
           </a:p>
           <a:p>
@@ -5151,14 +4826,14 @@
               <a:spcAft>
                 <a:spcPts val="800"/>
               </a:spcAft>
-              <a:defRPr sz="1650">
-                <a:solidFill>
-                  <a:srgbClr val="283E31"/>
+              <a:defRPr sz="1700">
+                <a:solidFill>
+                  <a:srgbClr val="1D3226"/>
                 </a:solidFill>
               </a:defRPr>
             </a:pPr>
             <a:r>
-              <a:t>• Persistent storage, backups, and upgrade strategy</a:t>
+              <a:t>• Simple to run on one instance</a:t>
             </a:r>
           </a:p>
           <a:p>
@@ -5166,14 +4841,14 @@
               <a:spcAft>
                 <a:spcPts val="800"/>
               </a:spcAft>
-              <a:defRPr sz="1650">
-                <a:solidFill>
-                  <a:srgbClr val="283E31"/>
+              <a:defRPr sz="1700">
+                <a:solidFill>
+                  <a:srgbClr val="1D3226"/>
                 </a:solidFill>
               </a:defRPr>
             </a:pPr>
             <a:r>
-              <a:t>• Explicit document contracts and primary-key discipline</a:t>
+              <a:t>• Good when scope is focused</a:t>
             </a:r>
           </a:p>
         </p:txBody>
@@ -5186,8 +4861,8 @@
         </p:nvSpPr>
         <p:spPr>
           <a:xfrm>
-            <a:off x="6492240" y="1920240"/>
-            <a:ext cx="4754880" cy="4389120"/>
+            <a:off x="6446520" y="1828800"/>
+            <a:ext cx="4800600" cy="4297680"/>
           </a:xfrm>
           <a:prstGeom prst="rect">
             <a:avLst/>
@@ -5204,14 +4879,14 @@
               <a:spcAft>
                 <a:spcPts val="800"/>
               </a:spcAft>
-              <a:defRPr sz="1650">
-                <a:solidFill>
-                  <a:srgbClr val="283E31"/>
+              <a:defRPr sz="1700">
+                <a:solidFill>
+                  <a:srgbClr val="1D3226"/>
                 </a:solidFill>
               </a:defRPr>
             </a:pPr>
             <a:r>
-              <a:t>• Runbooks for restore and reindex scenarios</a:t>
+              <a:t>• Use when high availability is required</a:t>
             </a:r>
           </a:p>
           <a:p>
@@ -5219,14 +4894,14 @@
               <a:spcAft>
                 <a:spcPts val="800"/>
               </a:spcAft>
-              <a:defRPr sz="1650">
-                <a:solidFill>
-                  <a:srgbClr val="283E31"/>
+              <a:defRPr sz="1700">
+                <a:solidFill>
+                  <a:srgbClr val="1D3226"/>
                 </a:solidFill>
               </a:defRPr>
             </a:pPr>
             <a:r>
-              <a:t>• SLO tracking for latency, freshness, and failures</a:t>
+              <a:t>• Better for larger scale over time</a:t>
             </a:r>
           </a:p>
           <a:p>
@@ -5234,14 +4909,14 @@
               <a:spcAft>
                 <a:spcPts val="800"/>
               </a:spcAft>
-              <a:defRPr sz="1650">
-                <a:solidFill>
-                  <a:srgbClr val="283E31"/>
+              <a:defRPr sz="1700">
+                <a:solidFill>
+                  <a:srgbClr val="1D3226"/>
                 </a:solidFill>
               </a:defRPr>
             </a:pPr>
             <a:r>
-              <a:t>• Domain ownership for searchable attributes</a:t>
+              <a:t>• Cloud is faster if you want less ops work</a:t>
             </a:r>
           </a:p>
         </p:txBody>
@@ -5279,7 +4954,7 @@
             <a:avLst/>
           </a:prstGeom>
           <a:solidFill>
-            <a:srgbClr val="F6F8F4"/>
+            <a:srgbClr val="F7F9F6"/>
           </a:solidFill>
           <a:ln>
             <a:noFill/>
@@ -5316,13 +4991,13 @@
         <p:spPr>
           <a:xfrm>
             <a:off x="0" y="0"/>
-            <a:ext cx="12191695" cy="777240"/>
+            <a:ext cx="12191695" cy="749808"/>
           </a:xfrm>
           <a:prstGeom prst="rect">
             <a:avLst/>
           </a:prstGeom>
           <a:solidFill>
-            <a:srgbClr val="123524"/>
+            <a:srgbClr val="18402C"/>
           </a:solidFill>
           <a:ln>
             <a:noFill/>
@@ -5358,8 +5033,8 @@
         </p:nvSpPr>
         <p:spPr>
           <a:xfrm>
-            <a:off x="502920" y="146304"/>
-            <a:ext cx="8961120" cy="457200"/>
+            <a:off x="502920" y="128016"/>
+            <a:ext cx="9601200" cy="457200"/>
           </a:xfrm>
           <a:prstGeom prst="rect">
             <a:avLst/>
@@ -5380,7 +5055,7 @@
               </a:defRPr>
             </a:pPr>
             <a:r>
-              <a:t>Self-Hosting Decision Matrix</a:t>
+              <a:t>Main risks and fixes</a:t>
             </a:r>
           </a:p>
         </p:txBody>
@@ -5393,8 +5068,8 @@
         </p:nvSpPr>
         <p:spPr>
           <a:xfrm>
-            <a:off x="10332720" y="182880"/>
-            <a:ext cx="1645920" cy="320040"/>
+            <a:off x="9875520" y="182880"/>
+            <a:ext cx="2103120" cy="320040"/>
           </a:xfrm>
           <a:prstGeom prst="rect">
             <a:avLst/>
@@ -5410,12 +5085,12 @@
             <a:pPr algn="r">
               <a:defRPr sz="1000">
                 <a:solidFill>
-                  <a:srgbClr val="DCE9E2"/>
+                  <a:srgbClr val="D7E3DD"/>
                 </a:solidFill>
               </a:defRPr>
             </a:pPr>
             <a:r>
-              <a:t>Olam Agri | Research Brief</a:t>
+              <a:t>Olam Agri</a:t>
             </a:r>
           </a:p>
         </p:txBody>
@@ -5428,7 +5103,7 @@
         </p:nvSpPr>
         <p:spPr>
           <a:xfrm>
-            <a:off x="548640" y="1188720"/>
+            <a:off x="594360" y="1143000"/>
             <a:ext cx="5440680" cy="5440680"/>
           </a:xfrm>
           <a:prstGeom prst="roundRect">
@@ -5439,7 +5114,7 @@
           </a:solidFill>
           <a:ln>
             <a:solidFill>
-              <a:srgbClr val="D8E1DA"/>
+              <a:srgbClr val="D6DFD9"/>
             </a:solidFill>
           </a:ln>
         </p:spPr>
@@ -5473,7 +5148,7 @@
         </p:nvSpPr>
         <p:spPr>
           <a:xfrm>
-            <a:off x="6172200" y="1188720"/>
+            <a:off x="6172200" y="1143000"/>
             <a:ext cx="5440680" cy="5440680"/>
           </a:xfrm>
           <a:prstGeom prst="roundRect">
@@ -5484,7 +5159,7 @@
           </a:solidFill>
           <a:ln>
             <a:solidFill>
-              <a:srgbClr val="D8E1DA"/>
+              <a:srgbClr val="D6DFD9"/>
             </a:solidFill>
           </a:ln>
         </p:spPr>
@@ -5518,8 +5193,8 @@
         </p:nvSpPr>
         <p:spPr>
           <a:xfrm>
-            <a:off x="868680" y="1417320"/>
-            <a:ext cx="4846320" cy="457200"/>
+            <a:off x="868680" y="1371600"/>
+            <a:ext cx="4754880" cy="411480"/>
           </a:xfrm>
           <a:prstGeom prst="rect">
             <a:avLst/>
@@ -5533,14 +5208,14 @@
           <a:lstStyle/>
           <a:p>
             <a:pPr>
-              <a:defRPr sz="1900" b="1">
-                <a:solidFill>
-                  <a:srgbClr val="2C5E42"/>
+              <a:defRPr sz="2000" b="1">
+                <a:solidFill>
+                  <a:srgbClr val="18402C"/>
                 </a:solidFill>
               </a:defRPr>
             </a:pPr>
             <a:r>
-              <a:t>Community Edition</a:t>
+              <a:t>Risks</a:t>
             </a:r>
           </a:p>
         </p:txBody>
@@ -5553,8 +5228,8 @@
         </p:nvSpPr>
         <p:spPr>
           <a:xfrm>
-            <a:off x="6492240" y="1417320"/>
-            <a:ext cx="4846320" cy="457200"/>
+            <a:off x="6446520" y="1371600"/>
+            <a:ext cx="4754880" cy="411480"/>
           </a:xfrm>
           <a:prstGeom prst="rect">
             <a:avLst/>
@@ -5568,14 +5243,14 @@
           <a:lstStyle/>
           <a:p>
             <a:pPr>
-              <a:defRPr sz="1900" b="1">
-                <a:solidFill>
-                  <a:srgbClr val="2C5E42"/>
+              <a:defRPr sz="2000" b="1">
+                <a:solidFill>
+                  <a:srgbClr val="18402C"/>
                 </a:solidFill>
               </a:defRPr>
             </a:pPr>
             <a:r>
-              <a:t>Enterprise Edition / Cloud</a:t>
+              <a:t>Fixes</a:t>
             </a:r>
           </a:p>
         </p:txBody>
@@ -5588,8 +5263,8 @@
         </p:nvSpPr>
         <p:spPr>
           <a:xfrm>
-            <a:off x="868680" y="1920240"/>
-            <a:ext cx="4754880" cy="4389120"/>
+            <a:off x="868680" y="1828800"/>
+            <a:ext cx="4800600" cy="4297680"/>
           </a:xfrm>
           <a:prstGeom prst="rect">
             <a:avLst/>
@@ -5606,14 +5281,14 @@
               <a:spcAft>
                 <a:spcPts val="800"/>
               </a:spcAft>
-              <a:defRPr sz="1650">
-                <a:solidFill>
-                  <a:srgbClr val="283E31"/>
+              <a:defRPr sz="1700">
+                <a:solidFill>
+                  <a:srgbClr val="1D3226"/>
                 </a:solidFill>
               </a:defRPr>
             </a:pPr>
             <a:r>
-              <a:t>• MIT-licensed and straightforward to deploy</a:t>
+              <a:t>• Complex mapping from SAP tables</a:t>
             </a:r>
           </a:p>
           <a:p>
@@ -5621,14 +5296,14 @@
               <a:spcAft>
                 <a:spcPts val="800"/>
               </a:spcAft>
-              <a:defRPr sz="1650">
-                <a:solidFill>
-                  <a:srgbClr val="283E31"/>
+              <a:defRPr sz="1700">
+                <a:solidFill>
+                  <a:srgbClr val="1D3226"/>
                 </a:solidFill>
               </a:defRPr>
             </a:pPr>
             <a:r>
-              <a:t>• Strong fit for single-instance, focused workloads</a:t>
+              <a:t>• Indexing can affect search speed</a:t>
             </a:r>
           </a:p>
           <a:p>
@@ -5636,14 +5311,14 @@
               <a:spcAft>
                 <a:spcPts val="800"/>
               </a:spcAft>
-              <a:defRPr sz="1650">
-                <a:solidFill>
-                  <a:srgbClr val="283E31"/>
+              <a:defRPr sz="1700">
+                <a:solidFill>
+                  <a:srgbClr val="1D3226"/>
                 </a:solidFill>
               </a:defRPr>
             </a:pPr>
             <a:r>
-              <a:t>• Not intended for distributed sharding/replication topologies</a:t>
+              <a:t>• Weak key handling can expose data</a:t>
             </a:r>
           </a:p>
         </p:txBody>
@@ -5656,8 +5331,8 @@
         </p:nvSpPr>
         <p:spPr>
           <a:xfrm>
-            <a:off x="6492240" y="1920240"/>
-            <a:ext cx="4754880" cy="4389120"/>
+            <a:off x="6446520" y="1828800"/>
+            <a:ext cx="4800600" cy="4297680"/>
           </a:xfrm>
           <a:prstGeom prst="rect">
             <a:avLst/>
@@ -5674,14 +5349,14 @@
               <a:spcAft>
                 <a:spcPts val="800"/>
               </a:spcAft>
-              <a:defRPr sz="1650">
-                <a:solidFill>
-                  <a:srgbClr val="283E31"/>
+              <a:defRPr sz="1700">
+                <a:solidFill>
+                  <a:srgbClr val="1D3226"/>
                 </a:solidFill>
               </a:defRPr>
             </a:pPr>
             <a:r>
-              <a:t>• Enterprise enables sharding and replication</a:t>
+              <a:t>• Start with one domain and stable schema</a:t>
             </a:r>
           </a:p>
           <a:p>
@@ -5689,14 +5364,14 @@
               <a:spcAft>
                 <a:spcPts val="800"/>
               </a:spcAft>
-              <a:defRPr sz="1650">
-                <a:solidFill>
-                  <a:srgbClr val="283E31"/>
+              <a:defRPr sz="1700">
+                <a:solidFill>
+                  <a:srgbClr val="1D3226"/>
                 </a:solidFill>
               </a:defRPr>
             </a:pPr>
             <a:r>
-              <a:t>• Cloud reduces ops burden and speeds rollout</a:t>
+              <a:t>• Use strict indexing limits and staged updates</a:t>
             </a:r>
           </a:p>
           <a:p>
@@ -5704,14 +5379,14 @@
               <a:spcAft>
                 <a:spcPts val="800"/>
               </a:spcAft>
-              <a:defRPr sz="1650">
-                <a:solidFill>
-                  <a:srgbClr val="283E31"/>
+              <a:defRPr sz="1700">
+                <a:solidFill>
+                  <a:srgbClr val="1D3226"/>
                 </a:solidFill>
               </a:defRPr>
             </a:pPr>
             <a:r>
-              <a:t>• Choose based on HA target, scale path, and control model</a:t>
+              <a:t>• Generate short-lived tokens in backend only</a:t>
             </a:r>
           </a:p>
         </p:txBody>
@@ -5749,7 +5424,7 @@
             <a:avLst/>
           </a:prstGeom>
           <a:solidFill>
-            <a:srgbClr val="F6F8F4"/>
+            <a:srgbClr val="F7F9F6"/>
           </a:solidFill>
           <a:ln>
             <a:noFill/>
@@ -5786,13 +5461,13 @@
         <p:spPr>
           <a:xfrm>
             <a:off x="0" y="0"/>
-            <a:ext cx="12191695" cy="777240"/>
+            <a:ext cx="12191695" cy="749808"/>
           </a:xfrm>
           <a:prstGeom prst="rect">
             <a:avLst/>
           </a:prstGeom>
           <a:solidFill>
-            <a:srgbClr val="123524"/>
+            <a:srgbClr val="18402C"/>
           </a:solidFill>
           <a:ln>
             <a:noFill/>
@@ -5828,8 +5503,8 @@
         </p:nvSpPr>
         <p:spPr>
           <a:xfrm>
-            <a:off x="502920" y="146304"/>
-            <a:ext cx="8961120" cy="457200"/>
+            <a:off x="502920" y="128016"/>
+            <a:ext cx="9601200" cy="457200"/>
           </a:xfrm>
           <a:prstGeom prst="rect">
             <a:avLst/>
@@ -5850,7 +5525,7 @@
               </a:defRPr>
             </a:pPr>
             <a:r>
-              <a:t>Principal Blockers</a:t>
+              <a:t>12-week rollout plan</a:t>
             </a:r>
           </a:p>
         </p:txBody>
@@ -5863,8 +5538,8 @@
         </p:nvSpPr>
         <p:spPr>
           <a:xfrm>
-            <a:off x="10332720" y="182880"/>
-            <a:ext cx="1645920" cy="320040"/>
+            <a:off x="9875520" y="182880"/>
+            <a:ext cx="2103120" cy="320040"/>
           </a:xfrm>
           <a:prstGeom prst="rect">
             <a:avLst/>
@@ -5880,12 +5555,12 @@
             <a:pPr algn="r">
               <a:defRPr sz="1000">
                 <a:solidFill>
-                  <a:srgbClr val="DCE9E2"/>
+                  <a:srgbClr val="D7E3DD"/>
                 </a:solidFill>
               </a:defRPr>
             </a:pPr>
             <a:r>
-              <a:t>Olam Agri | Research Brief</a:t>
+              <a:t>Olam Agri</a:t>
             </a:r>
           </a:p>
         </p:txBody>
@@ -5898,8 +5573,8 @@
         </p:nvSpPr>
         <p:spPr>
           <a:xfrm>
-            <a:off x="548640" y="1188720"/>
-            <a:ext cx="5440680" cy="5440680"/>
+            <a:off x="731520" y="1737360"/>
+            <a:ext cx="2697480" cy="3566160"/>
           </a:xfrm>
           <a:prstGeom prst="roundRect">
             <a:avLst/>
@@ -5909,7 +5584,7 @@
           </a:solidFill>
           <a:ln>
             <a:solidFill>
-              <a:srgbClr val="D8E1DA"/>
+              <a:srgbClr val="D6DFD9"/>
             </a:solidFill>
           </a:ln>
         </p:spPr>
@@ -5937,14 +5612,61 @@
       </p:sp>
       <p:sp>
         <p:nvSpPr>
-          <p:cNvPr id="7" name="Rounded Rectangle 6"/>
+          <p:cNvPr id="7" name="TextBox 6"/>
+          <p:cNvSpPr txBox="1"/>
+          <p:nvPr/>
+        </p:nvSpPr>
+        <p:spPr>
+          <a:xfrm>
+            <a:off x="914400" y="1965960"/>
+            <a:ext cx="2286000" cy="3108960"/>
+          </a:xfrm>
+          <a:prstGeom prst="rect">
+            <a:avLst/>
+          </a:prstGeom>
+          <a:noFill/>
+        </p:spPr>
+        <p:txBody>
+          <a:bodyPr wrap="none">
+            <a:spAutoFit/>
+          </a:bodyPr>
+          <a:lstStyle/>
+          <a:p>
+            <a:pPr>
+              <a:defRPr sz="1600" b="1">
+                <a:solidFill>
+                  <a:srgbClr val="18402C"/>
+                </a:solidFill>
+              </a:defRPr>
+            </a:pPr>
+            <a:r>
+              <a:t>Weeks 1-2</a:t>
+            </a:r>
+          </a:p>
+          <a:p>
+            <a:pPr>
+              <a:defRPr sz="1500">
+                <a:solidFill>
+                  <a:srgbClr val="1D3226"/>
+                </a:solidFill>
+              </a:defRPr>
+            </a:pPr>
+            <a:r>
+              <a:t>Choose use case and schema</a:t>
+            </a:r>
+          </a:p>
+        </p:txBody>
+      </p:sp>
+      <p:sp>
+        <p:nvSpPr>
+          <p:cNvPr id="8" name="Rounded Rectangle 7"/>
           <p:cNvSpPr/>
           <p:nvPr/>
         </p:nvSpPr>
         <p:spPr>
           <a:xfrm>
-            <a:off x="6172200" y="1188720"/>
-            <a:ext cx="5440680" cy="5440680"/>
+            <a:off x="3611880" y="1737360"/>
+            <a:ext cx="2697480" cy="3566160"/>
           </a:xfrm>
           <a:prstGeom prst="roundRect">
             <a:avLst/>
@@ -5954,7 +5676,7 @@
           </a:solidFill>
           <a:ln>
             <a:solidFill>
-              <a:srgbClr val="D8E1DA"/>
+              <a:srgbClr val="D6DFD9"/>
             </a:solidFill>
           </a:ln>
         </p:spPr>
@@ -5982,14 +5704,14 @@
       </p:sp>
       <p:sp>
         <p:nvSpPr>
-          <p:cNvPr id="8" name="TextBox 7"/>
+          <p:cNvPr id="9" name="TextBox 8"/>
           <p:cNvSpPr txBox="1"/>
           <p:nvPr/>
         </p:nvSpPr>
         <p:spPr>
           <a:xfrm>
-            <a:off x="868680" y="1417320"/>
-            <a:ext cx="4846320" cy="457200"/>
+            <a:off x="3794760" y="1965960"/>
+            <a:ext cx="2286000" cy="3108960"/>
           </a:xfrm>
           <a:prstGeom prst="rect">
             <a:avLst/>
@@ -6003,28 +5725,85 @@
           <a:lstStyle/>
           <a:p>
             <a:pPr>
-              <a:defRPr sz="1900" b="1">
-                <a:solidFill>
-                  <a:srgbClr val="2C5E42"/>
+              <a:defRPr sz="1600" b="1">
+                <a:solidFill>
+                  <a:srgbClr val="18402C"/>
                 </a:solidFill>
               </a:defRPr>
             </a:pPr>
             <a:r>
-              <a:t>Architecture and data risks</a:t>
-            </a:r>
-          </a:p>
-        </p:txBody>
-      </p:sp>
-      <p:sp>
-        <p:nvSpPr>
-          <p:cNvPr id="9" name="TextBox 8"/>
+              <a:t>Weeks 3-4</a:t>
+            </a:r>
+          </a:p>
+          <a:p>
+            <a:pPr>
+              <a:defRPr sz="1500">
+                <a:solidFill>
+                  <a:srgbClr val="1D3226"/>
+                </a:solidFill>
+              </a:defRPr>
+            </a:pPr>
+            <a:r>
+              <a:t>Build pilot index and secure access</a:t>
+            </a:r>
+          </a:p>
+        </p:txBody>
+      </p:sp>
+      <p:sp>
+        <p:nvSpPr>
+          <p:cNvPr id="10" name="Rounded Rectangle 9"/>
+          <p:cNvSpPr/>
+          <p:nvPr/>
+        </p:nvSpPr>
+        <p:spPr>
+          <a:xfrm>
+            <a:off x="6492240" y="1737360"/>
+            <a:ext cx="2697480" cy="3566160"/>
+          </a:xfrm>
+          <a:prstGeom prst="roundRect">
+            <a:avLst/>
+          </a:prstGeom>
+          <a:solidFill>
+            <a:srgbClr val="FFFFFF"/>
+          </a:solidFill>
+          <a:ln>
+            <a:solidFill>
+              <a:srgbClr val="D6DFD9"/>
+            </a:solidFill>
+          </a:ln>
+        </p:spPr>
+        <p:style>
+          <a:lnRef idx="1">
+            <a:schemeClr val="accent1"/>
+          </a:lnRef>
+          <a:fillRef idx="3">
+            <a:schemeClr val="accent1"/>
+          </a:fillRef>
+          <a:effectRef idx="2">
+            <a:schemeClr val="accent1"/>
+          </a:effectRef>
+          <a:fontRef idx="minor">
+            <a:schemeClr val="lt1"/>
+          </a:fontRef>
+        </p:style>
+        <p:txBody>
+          <a:bodyPr rtlCol="0" anchor="ctr"/>
+          <a:lstStyle/>
+          <a:p>
+            <a:pPr algn="ctr"/>
+          </a:p>
+        </p:txBody>
+      </p:sp>
+      <p:sp>
+        <p:nvSpPr>
+          <p:cNvPr id="11" name="TextBox 10"/>
           <p:cNvSpPr txBox="1"/>
           <p:nvPr/>
         </p:nvSpPr>
         <p:spPr>
           <a:xfrm>
-            <a:off x="6492240" y="1417320"/>
-            <a:ext cx="4846320" cy="457200"/>
+            <a:off x="6675120" y="1965960"/>
+            <a:ext cx="2286000" cy="3108960"/>
           </a:xfrm>
           <a:prstGeom prst="rect">
             <a:avLst/>
@@ -6038,28 +5817,85 @@
           <a:lstStyle/>
           <a:p>
             <a:pPr>
-              <a:defRPr sz="1900" b="1">
-                <a:solidFill>
-                  <a:srgbClr val="2C5E42"/>
+              <a:defRPr sz="1600" b="1">
+                <a:solidFill>
+                  <a:srgbClr val="18402C"/>
                 </a:solidFill>
               </a:defRPr>
             </a:pPr>
             <a:r>
-              <a:t>Governance and operations risks</a:t>
-            </a:r>
-          </a:p>
-        </p:txBody>
-      </p:sp>
-      <p:sp>
-        <p:nvSpPr>
-          <p:cNvPr id="10" name="TextBox 9"/>
+              <a:t>Weeks 5-8</a:t>
+            </a:r>
+          </a:p>
+          <a:p>
+            <a:pPr>
+              <a:defRPr sz="1500">
+                <a:solidFill>
+                  <a:srgbClr val="1D3226"/>
+                </a:solidFill>
+              </a:defRPr>
+            </a:pPr>
+            <a:r>
+              <a:t>Automate updates and tune relevance</a:t>
+            </a:r>
+          </a:p>
+        </p:txBody>
+      </p:sp>
+      <p:sp>
+        <p:nvSpPr>
+          <p:cNvPr id="12" name="Rounded Rectangle 11"/>
+          <p:cNvSpPr/>
+          <p:nvPr/>
+        </p:nvSpPr>
+        <p:spPr>
+          <a:xfrm>
+            <a:off x="9372600" y="1737360"/>
+            <a:ext cx="2697480" cy="3566160"/>
+          </a:xfrm>
+          <a:prstGeom prst="roundRect">
+            <a:avLst/>
+          </a:prstGeom>
+          <a:solidFill>
+            <a:srgbClr val="FFFFFF"/>
+          </a:solidFill>
+          <a:ln>
+            <a:solidFill>
+              <a:srgbClr val="D6DFD9"/>
+            </a:solidFill>
+          </a:ln>
+        </p:spPr>
+        <p:style>
+          <a:lnRef idx="1">
+            <a:schemeClr val="accent1"/>
+          </a:lnRef>
+          <a:fillRef idx="3">
+            <a:schemeClr val="accent1"/>
+          </a:fillRef>
+          <a:effectRef idx="2">
+            <a:schemeClr val="accent1"/>
+          </a:effectRef>
+          <a:fontRef idx="minor">
+            <a:schemeClr val="lt1"/>
+          </a:fontRef>
+        </p:style>
+        <p:txBody>
+          <a:bodyPr rtlCol="0" anchor="ctr"/>
+          <a:lstStyle/>
+          <a:p>
+            <a:pPr algn="ctr"/>
+          </a:p>
+        </p:txBody>
+      </p:sp>
+      <p:sp>
+        <p:nvSpPr>
+          <p:cNvPr id="13" name="TextBox 12"/>
           <p:cNvSpPr txBox="1"/>
           <p:nvPr/>
         </p:nvSpPr>
         <p:spPr>
           <a:xfrm>
-            <a:off x="868680" y="1920240"/>
-            <a:ext cx="4754880" cy="4389120"/>
+            <a:off x="9555480" y="1965960"/>
+            <a:ext cx="2286000" cy="3108960"/>
           </a:xfrm>
           <a:prstGeom prst="rect">
             <a:avLst/>
@@ -6073,115 +5909,26 @@
           <a:lstStyle/>
           <a:p>
             <a:pPr>
-              <a:spcAft>
-                <a:spcPts val="800"/>
-              </a:spcAft>
-              <a:defRPr sz="1650">
-                <a:solidFill>
-                  <a:srgbClr val="283E31"/>
+              <a:defRPr sz="1600" b="1">
+                <a:solidFill>
+                  <a:srgbClr val="18402C"/>
                 </a:solidFill>
               </a:defRPr>
             </a:pPr>
             <a:r>
-              <a:t>• Relational-to-search modeling effort is substantial</a:t>
+              <a:t>Weeks 9-12</a:t>
             </a:r>
           </a:p>
           <a:p>
             <a:pPr>
-              <a:spcAft>
-                <a:spcPts val="800"/>
-              </a:spcAft>
-              <a:defRPr sz="1650">
-                <a:solidFill>
-                  <a:srgbClr val="283E31"/>
+              <a:defRPr sz="1500">
+                <a:solidFill>
+                  <a:srgbClr val="1D3226"/>
                 </a:solidFill>
               </a:defRPr>
             </a:pPr>
             <a:r>
-              <a:t>• Real-time sync reliability requires robust orchestration</a:t>
-            </a:r>
-          </a:p>
-          <a:p>
-            <a:pPr>
-              <a:spcAft>
-                <a:spcPts val="800"/>
-              </a:spcAft>
-              <a:defRPr sz="1650">
-                <a:solidFill>
-                  <a:srgbClr val="283E31"/>
-                </a:solidFill>
-              </a:defRPr>
-            </a:pPr>
-            <a:r>
-              <a:t>• Community Edition scaling limits must be acknowledged</a:t>
-            </a:r>
-          </a:p>
-        </p:txBody>
-      </p:sp>
-      <p:sp>
-        <p:nvSpPr>
-          <p:cNvPr id="11" name="TextBox 10"/>
-          <p:cNvSpPr txBox="1"/>
-          <p:nvPr/>
-        </p:nvSpPr>
-        <p:spPr>
-          <a:xfrm>
-            <a:off x="6492240" y="1920240"/>
-            <a:ext cx="4754880" cy="4389120"/>
-          </a:xfrm>
-          <a:prstGeom prst="rect">
-            <a:avLst/>
-          </a:prstGeom>
-          <a:noFill/>
-        </p:spPr>
-        <p:txBody>
-          <a:bodyPr wrap="none">
-            <a:spAutoFit/>
-          </a:bodyPr>
-          <a:lstStyle/>
-          <a:p>
-            <a:pPr>
-              <a:spcAft>
-                <a:spcPts val="800"/>
-              </a:spcAft>
-              <a:defRPr sz="1650">
-                <a:solidFill>
-                  <a:srgbClr val="283E31"/>
-                </a:solidFill>
-              </a:defRPr>
-            </a:pPr>
-            <a:r>
-              <a:t>• Frontend key misuse can break data isolation</a:t>
-            </a:r>
-          </a:p>
-          <a:p>
-            <a:pPr>
-              <a:spcAft>
-                <a:spcPts val="800"/>
-              </a:spcAft>
-              <a:defRPr sz="1650">
-                <a:solidFill>
-                  <a:srgbClr val="283E31"/>
-                </a:solidFill>
-              </a:defRPr>
-            </a:pPr>
-            <a:r>
-              <a:t>• Weak backup/restore discipline elevates outage impact</a:t>
-            </a:r>
-          </a:p>
-          <a:p>
-            <a:pPr>
-              <a:spcAft>
-                <a:spcPts val="800"/>
-              </a:spcAft>
-              <a:defRPr sz="1650">
-                <a:solidFill>
-                  <a:srgbClr val="283E31"/>
-                </a:solidFill>
-              </a:defRPr>
-            </a:pPr>
-            <a:r>
-              <a:t>• Late edition switching can cause avoidable rework</a:t>
+              <a:t>Load test and release in stages</a:t>
             </a:r>
           </a:p>
         </p:txBody>
@@ -6219,7 +5966,7 @@
             <a:avLst/>
           </a:prstGeom>
           <a:solidFill>
-            <a:srgbClr val="F6F8F4"/>
+            <a:srgbClr val="F7F9F6"/>
           </a:solidFill>
           <a:ln>
             <a:noFill/>
@@ -6256,13 +6003,13 @@
         <p:spPr>
           <a:xfrm>
             <a:off x="0" y="0"/>
-            <a:ext cx="12191695" cy="777240"/>
+            <a:ext cx="12191695" cy="749808"/>
           </a:xfrm>
           <a:prstGeom prst="rect">
             <a:avLst/>
           </a:prstGeom>
           <a:solidFill>
-            <a:srgbClr val="123524"/>
+            <a:srgbClr val="18402C"/>
           </a:solidFill>
           <a:ln>
             <a:noFill/>
@@ -6298,8 +6045,8 @@
         </p:nvSpPr>
         <p:spPr>
           <a:xfrm>
-            <a:off x="502920" y="146304"/>
-            <a:ext cx="8961120" cy="457200"/>
+            <a:off x="502920" y="128016"/>
+            <a:ext cx="9601200" cy="457200"/>
           </a:xfrm>
           <a:prstGeom prst="rect">
             <a:avLst/>
@@ -6320,7 +6067,7 @@
               </a:defRPr>
             </a:pPr>
             <a:r>
-              <a:t>Implementation Roadmap (12 Weeks)</a:t>
+              <a:t>Final recommendation</a:t>
             </a:r>
           </a:p>
         </p:txBody>
@@ -6333,8 +6080,8 @@
         </p:nvSpPr>
         <p:spPr>
           <a:xfrm>
-            <a:off x="10332720" y="182880"/>
-            <a:ext cx="1645920" cy="320040"/>
+            <a:off x="9875520" y="182880"/>
+            <a:ext cx="2103120" cy="320040"/>
           </a:xfrm>
           <a:prstGeom prst="rect">
             <a:avLst/>
@@ -6350,26 +6097,61 @@
             <a:pPr algn="r">
               <a:defRPr sz="1000">
                 <a:solidFill>
-                  <a:srgbClr val="DCE9E2"/>
+                  <a:srgbClr val="D7E3DD"/>
                 </a:solidFill>
               </a:defRPr>
             </a:pPr>
             <a:r>
-              <a:t>Olam Agri | Research Brief</a:t>
-            </a:r>
-          </a:p>
-        </p:txBody>
-      </p:sp>
-      <p:sp>
-        <p:nvSpPr>
-          <p:cNvPr id="6" name="Rounded Rectangle 5"/>
+              <a:t>Olam Agri</a:t>
+            </a:r>
+          </a:p>
+        </p:txBody>
+      </p:sp>
+      <p:sp>
+        <p:nvSpPr>
+          <p:cNvPr id="6" name="TextBox 5"/>
+          <p:cNvSpPr txBox="1"/>
+          <p:nvPr/>
+        </p:nvSpPr>
+        <p:spPr>
+          <a:xfrm>
+            <a:off x="685800" y="960120"/>
+            <a:ext cx="10972800" cy="548640"/>
+          </a:xfrm>
+          <a:prstGeom prst="rect">
+            <a:avLst/>
+          </a:prstGeom>
+          <a:noFill/>
+        </p:spPr>
+        <p:txBody>
+          <a:bodyPr wrap="none">
+            <a:spAutoFit/>
+          </a:bodyPr>
+          <a:lstStyle/>
+          <a:p>
+            <a:pPr>
+              <a:defRPr sz="1600">
+                <a:solidFill>
+                  <a:srgbClr val="50685C"/>
+                </a:solidFill>
+              </a:defRPr>
+            </a:pPr>
+            <a:r>
+              <a:t>Start small, control performance, then scale.</a:t>
+            </a:r>
+          </a:p>
+        </p:txBody>
+      </p:sp>
+      <p:sp>
+        <p:nvSpPr>
+          <p:cNvPr id="7" name="Rounded Rectangle 6"/>
           <p:cNvSpPr/>
           <p:nvPr/>
         </p:nvSpPr>
         <p:spPr>
           <a:xfrm>
-            <a:off x="731520" y="1600200"/>
-            <a:ext cx="2743200" cy="4297680"/>
+            <a:off x="594360" y="1508760"/>
+            <a:ext cx="10972800" cy="4892040"/>
           </a:xfrm>
           <a:prstGeom prst="roundRect">
             <a:avLst/>
@@ -6379,7 +6161,7 @@
           </a:solidFill>
           <a:ln>
             <a:solidFill>
-              <a:srgbClr val="D4E0D8"/>
+              <a:srgbClr val="D6DFD9"/>
             </a:solidFill>
           </a:ln>
         </p:spPr>
@@ -6407,14 +6189,14 @@
       </p:sp>
       <p:sp>
         <p:nvSpPr>
-          <p:cNvPr id="7" name="TextBox 6"/>
+          <p:cNvPr id="8" name="TextBox 7"/>
           <p:cNvSpPr txBox="1"/>
           <p:nvPr/>
         </p:nvSpPr>
         <p:spPr>
           <a:xfrm>
-            <a:off x="914400" y="1783080"/>
-            <a:ext cx="2377440" cy="3840480"/>
+            <a:off x="914400" y="1828800"/>
+            <a:ext cx="10241280" cy="4389120"/>
           </a:xfrm>
           <a:prstGeom prst="rect">
             <a:avLst/>
@@ -6428,362 +6210,47 @@
           <a:lstStyle/>
           <a:p>
             <a:pPr>
-              <a:defRPr sz="1600" b="1">
-                <a:solidFill>
-                  <a:srgbClr val="2C5E42"/>
+              <a:spcAft>
+                <a:spcPts val="1000"/>
+              </a:spcAft>
+              <a:defRPr sz="2400">
+                <a:solidFill>
+                  <a:srgbClr val="1D3226"/>
                 </a:solidFill>
               </a:defRPr>
             </a:pPr>
             <a:r>
-              <a:t>Weeks 1–2</a:t>
+              <a:t>• Go live with one high-value search use case</a:t>
             </a:r>
           </a:p>
           <a:p>
             <a:pPr>
               <a:spcAft>
-                <a:spcPts val="800"/>
+                <a:spcPts val="1000"/>
               </a:spcAft>
-              <a:defRPr sz="1800" b="1">
-                <a:solidFill>
-                  <a:srgbClr val="203529"/>
+              <a:defRPr sz="2400">
+                <a:solidFill>
+                  <a:srgbClr val="1D3226"/>
                 </a:solidFill>
               </a:defRPr>
             </a:pPr>
             <a:r>
-              <a:t>Scope and Decision Gate</a:t>
-            </a:r>
-          </a:p>
-          <a:p>
-            <a:pPr>
-              <a:defRPr sz="1450">
-                <a:solidFill>
-                  <a:srgbClr val="465A4E"/>
-                </a:solidFill>
-              </a:defRPr>
-            </a:pPr>
-            <a:r>
-              <a:t>Select domain, define SLOs, choose CE/EE/Cloud</a:t>
-            </a:r>
-          </a:p>
-        </p:txBody>
-      </p:sp>
-      <p:sp>
-        <p:nvSpPr>
-          <p:cNvPr id="8" name="Rounded Rectangle 7"/>
-          <p:cNvSpPr/>
-          <p:nvPr/>
-        </p:nvSpPr>
-        <p:spPr>
-          <a:xfrm>
-            <a:off x="3611880" y="1600200"/>
-            <a:ext cx="2743200" cy="4297680"/>
-          </a:xfrm>
-          <a:prstGeom prst="roundRect">
-            <a:avLst/>
-          </a:prstGeom>
-          <a:solidFill>
-            <a:srgbClr val="FFFFFF"/>
-          </a:solidFill>
-          <a:ln>
-            <a:solidFill>
-              <a:srgbClr val="D4E0D8"/>
-            </a:solidFill>
-          </a:ln>
-        </p:spPr>
-        <p:style>
-          <a:lnRef idx="1">
-            <a:schemeClr val="accent1"/>
-          </a:lnRef>
-          <a:fillRef idx="3">
-            <a:schemeClr val="accent1"/>
-          </a:fillRef>
-          <a:effectRef idx="2">
-            <a:schemeClr val="accent1"/>
-          </a:effectRef>
-          <a:fontRef idx="minor">
-            <a:schemeClr val="lt1"/>
-          </a:fontRef>
-        </p:style>
-        <p:txBody>
-          <a:bodyPr rtlCol="0" anchor="ctr"/>
-          <a:lstStyle/>
-          <a:p>
-            <a:pPr algn="ctr"/>
-          </a:p>
-        </p:txBody>
-      </p:sp>
-      <p:sp>
-        <p:nvSpPr>
-          <p:cNvPr id="9" name="TextBox 8"/>
-          <p:cNvSpPr txBox="1"/>
-          <p:nvPr/>
-        </p:nvSpPr>
-        <p:spPr>
-          <a:xfrm>
-            <a:off x="3794760" y="1783080"/>
-            <a:ext cx="2377440" cy="3840480"/>
-          </a:xfrm>
-          <a:prstGeom prst="rect">
-            <a:avLst/>
-          </a:prstGeom>
-          <a:noFill/>
-        </p:spPr>
-        <p:txBody>
-          <a:bodyPr wrap="square">
-            <a:spAutoFit/>
-          </a:bodyPr>
-          <a:lstStyle/>
-          <a:p>
-            <a:pPr>
-              <a:defRPr sz="1600" b="1">
-                <a:solidFill>
-                  <a:srgbClr val="2C5E42"/>
-                </a:solidFill>
-              </a:defRPr>
-            </a:pPr>
-            <a:r>
-              <a:t>Weeks 3–4</a:t>
+              <a:t>• Keep architecture simple and measurable</a:t>
             </a:r>
           </a:p>
           <a:p>
             <a:pPr>
               <a:spcAft>
-                <a:spcPts val="800"/>
+                <a:spcPts val="1000"/>
               </a:spcAft>
-              <a:defRPr sz="1800" b="1">
-                <a:solidFill>
-                  <a:srgbClr val="203529"/>
+              <a:defRPr sz="2400">
+                <a:solidFill>
+                  <a:srgbClr val="1D3226"/>
                 </a:solidFill>
               </a:defRPr>
             </a:pPr>
             <a:r>
-              <a:t>Pilot Build</a:t>
-            </a:r>
-          </a:p>
-          <a:p>
-            <a:pPr>
-              <a:defRPr sz="1450">
-                <a:solidFill>
-                  <a:srgbClr val="465A4E"/>
-                </a:solidFill>
-              </a:defRPr>
-            </a:pPr>
-            <a:r>
-              <a:t>Deliver first index, access model, and baseline tuning</a:t>
-            </a:r>
-          </a:p>
-        </p:txBody>
-      </p:sp>
-      <p:sp>
-        <p:nvSpPr>
-          <p:cNvPr id="10" name="Rounded Rectangle 9"/>
-          <p:cNvSpPr/>
-          <p:nvPr/>
-        </p:nvSpPr>
-        <p:spPr>
-          <a:xfrm>
-            <a:off x="6492240" y="1600200"/>
-            <a:ext cx="2743200" cy="4297680"/>
-          </a:xfrm>
-          <a:prstGeom prst="roundRect">
-            <a:avLst/>
-          </a:prstGeom>
-          <a:solidFill>
-            <a:srgbClr val="FFFFFF"/>
-          </a:solidFill>
-          <a:ln>
-            <a:solidFill>
-              <a:srgbClr val="D4E0D8"/>
-            </a:solidFill>
-          </a:ln>
-        </p:spPr>
-        <p:style>
-          <a:lnRef idx="1">
-            <a:schemeClr val="accent1"/>
-          </a:lnRef>
-          <a:fillRef idx="3">
-            <a:schemeClr val="accent1"/>
-          </a:fillRef>
-          <a:effectRef idx="2">
-            <a:schemeClr val="accent1"/>
-          </a:effectRef>
-          <a:fontRef idx="minor">
-            <a:schemeClr val="lt1"/>
-          </a:fontRef>
-        </p:style>
-        <p:txBody>
-          <a:bodyPr rtlCol="0" anchor="ctr"/>
-          <a:lstStyle/>
-          <a:p>
-            <a:pPr algn="ctr"/>
-          </a:p>
-        </p:txBody>
-      </p:sp>
-      <p:sp>
-        <p:nvSpPr>
-          <p:cNvPr id="11" name="TextBox 10"/>
-          <p:cNvSpPr txBox="1"/>
-          <p:nvPr/>
-        </p:nvSpPr>
-        <p:spPr>
-          <a:xfrm>
-            <a:off x="6675120" y="1783080"/>
-            <a:ext cx="2377440" cy="3840480"/>
-          </a:xfrm>
-          <a:prstGeom prst="rect">
-            <a:avLst/>
-          </a:prstGeom>
-          <a:noFill/>
-        </p:spPr>
-        <p:txBody>
-          <a:bodyPr wrap="square">
-            <a:spAutoFit/>
-          </a:bodyPr>
-          <a:lstStyle/>
-          <a:p>
-            <a:pPr>
-              <a:defRPr sz="1600" b="1">
-                <a:solidFill>
-                  <a:srgbClr val="2C5E42"/>
-                </a:solidFill>
-              </a:defRPr>
-            </a:pPr>
-            <a:r>
-              <a:t>Weeks 5–8</a:t>
-            </a:r>
-          </a:p>
-          <a:p>
-            <a:pPr>
-              <a:spcAft>
-                <a:spcPts val="800"/>
-              </a:spcAft>
-              <a:defRPr sz="1800" b="1">
-                <a:solidFill>
-                  <a:srgbClr val="203529"/>
-                </a:solidFill>
-              </a:defRPr>
-            </a:pPr>
-            <a:r>
-              <a:t>Pipeline Hardening</a:t>
-            </a:r>
-          </a:p>
-          <a:p>
-            <a:pPr>
-              <a:defRPr sz="1450">
-                <a:solidFill>
-                  <a:srgbClr val="465A4E"/>
-                </a:solidFill>
-              </a:defRPr>
-            </a:pPr>
-            <a:r>
-              <a:t>CDC/incremental sync, retries, relevance refinement</a:t>
-            </a:r>
-          </a:p>
-        </p:txBody>
-      </p:sp>
-      <p:sp>
-        <p:nvSpPr>
-          <p:cNvPr id="12" name="Rounded Rectangle 11"/>
-          <p:cNvSpPr/>
-          <p:nvPr/>
-        </p:nvSpPr>
-        <p:spPr>
-          <a:xfrm>
-            <a:off x="9372600" y="1600200"/>
-            <a:ext cx="2743200" cy="4297680"/>
-          </a:xfrm>
-          <a:prstGeom prst="roundRect">
-            <a:avLst/>
-          </a:prstGeom>
-          <a:solidFill>
-            <a:srgbClr val="FFFFFF"/>
-          </a:solidFill>
-          <a:ln>
-            <a:solidFill>
-              <a:srgbClr val="D4E0D8"/>
-            </a:solidFill>
-          </a:ln>
-        </p:spPr>
-        <p:style>
-          <a:lnRef idx="1">
-            <a:schemeClr val="accent1"/>
-          </a:lnRef>
-          <a:fillRef idx="3">
-            <a:schemeClr val="accent1"/>
-          </a:fillRef>
-          <a:effectRef idx="2">
-            <a:schemeClr val="accent1"/>
-          </a:effectRef>
-          <a:fontRef idx="minor">
-            <a:schemeClr val="lt1"/>
-          </a:fontRef>
-        </p:style>
-        <p:txBody>
-          <a:bodyPr rtlCol="0" anchor="ctr"/>
-          <a:lstStyle/>
-          <a:p>
-            <a:pPr algn="ctr"/>
-          </a:p>
-        </p:txBody>
-      </p:sp>
-      <p:sp>
-        <p:nvSpPr>
-          <p:cNvPr id="13" name="TextBox 12"/>
-          <p:cNvSpPr txBox="1"/>
-          <p:nvPr/>
-        </p:nvSpPr>
-        <p:spPr>
-          <a:xfrm>
-            <a:off x="9555480" y="1783080"/>
-            <a:ext cx="2377440" cy="3840480"/>
-          </a:xfrm>
-          <a:prstGeom prst="rect">
-            <a:avLst/>
-          </a:prstGeom>
-          <a:noFill/>
-        </p:spPr>
-        <p:txBody>
-          <a:bodyPr wrap="square">
-            <a:spAutoFit/>
-          </a:bodyPr>
-          <a:lstStyle/>
-          <a:p>
-            <a:pPr>
-              <a:defRPr sz="1600" b="1">
-                <a:solidFill>
-                  <a:srgbClr val="2C5E42"/>
-                </a:solidFill>
-              </a:defRPr>
-            </a:pPr>
-            <a:r>
-              <a:t>Weeks 9–12</a:t>
-            </a:r>
-          </a:p>
-          <a:p>
-            <a:pPr>
-              <a:spcAft>
-                <a:spcPts val="800"/>
-              </a:spcAft>
-              <a:defRPr sz="1800" b="1">
-                <a:solidFill>
-                  <a:srgbClr val="203529"/>
-                </a:solidFill>
-              </a:defRPr>
-            </a:pPr>
-            <a:r>
-              <a:t>Production Readiness</a:t>
-            </a:r>
-          </a:p>
-          <a:p>
-            <a:pPr>
-              <a:defRPr sz="1450">
-                <a:solidFill>
-                  <a:srgbClr val="465A4E"/>
-                </a:solidFill>
-              </a:defRPr>
-            </a:pPr>
-            <a:r>
-              <a:t>Load tests, backup/restore drills, staged rollout</a:t>
+              <a:t>• Expand only after stability and quality are proven</a:t>
             </a:r>
           </a:p>
         </p:txBody>
@@ -6821,7 +6288,7 @@
             <a:avLst/>
           </a:prstGeom>
           <a:solidFill>
-            <a:srgbClr val="F6F8F4"/>
+            <a:srgbClr val="F7F9F6"/>
           </a:solidFill>
           <a:ln>
             <a:noFill/>
@@ -6858,13 +6325,13 @@
         <p:spPr>
           <a:xfrm>
             <a:off x="0" y="0"/>
-            <a:ext cx="12191695" cy="777240"/>
+            <a:ext cx="12191695" cy="749808"/>
           </a:xfrm>
           <a:prstGeom prst="rect">
             <a:avLst/>
           </a:prstGeom>
           <a:solidFill>
-            <a:srgbClr val="123524"/>
+            <a:srgbClr val="18402C"/>
           </a:solidFill>
           <a:ln>
             <a:noFill/>
@@ -6900,8 +6367,8 @@
         </p:nvSpPr>
         <p:spPr>
           <a:xfrm>
-            <a:off x="502920" y="146304"/>
-            <a:ext cx="8961120" cy="457200"/>
+            <a:off x="502920" y="128016"/>
+            <a:ext cx="9601200" cy="457200"/>
           </a:xfrm>
           <a:prstGeom prst="rect">
             <a:avLst/>
@@ -6922,7 +6389,7 @@
               </a:defRPr>
             </a:pPr>
             <a:r>
-              <a:t>Recommended Path Forward</a:t>
+              <a:t>References</a:t>
             </a:r>
           </a:p>
         </p:txBody>
@@ -6935,8 +6402,8 @@
         </p:nvSpPr>
         <p:spPr>
           <a:xfrm>
-            <a:off x="10332720" y="182880"/>
-            <a:ext cx="1645920" cy="320040"/>
+            <a:off x="9875520" y="182880"/>
+            <a:ext cx="2103120" cy="320040"/>
           </a:xfrm>
           <a:prstGeom prst="rect">
             <a:avLst/>
@@ -6952,12 +6419,12 @@
             <a:pPr algn="r">
               <a:defRPr sz="1000">
                 <a:solidFill>
-                  <a:srgbClr val="DCE9E2"/>
+                  <a:srgbClr val="D7E3DD"/>
                 </a:solidFill>
               </a:defRPr>
             </a:pPr>
             <a:r>
-              <a:t>Olam Agri | Research Brief</a:t>
+              <a:t>Olam Agri</a:t>
             </a:r>
           </a:p>
         </p:txBody>
@@ -6970,8 +6437,8 @@
         </p:nvSpPr>
         <p:spPr>
           <a:xfrm>
-            <a:off x="640080" y="987552"/>
-            <a:ext cx="10972800" cy="502920"/>
+            <a:off x="685800" y="960120"/>
+            <a:ext cx="10972800" cy="548640"/>
           </a:xfrm>
           <a:prstGeom prst="rect">
             <a:avLst/>
@@ -6987,12 +6454,12 @@
             <a:pPr>
               <a:defRPr sz="1600">
                 <a:solidFill>
-                  <a:srgbClr val="586E61"/>
+                  <a:srgbClr val="50685C"/>
                 </a:solidFill>
               </a:defRPr>
             </a:pPr>
             <a:r>
-              <a:t>Start narrow, harden early, and scale with explicit gates.</a:t>
+              <a:t>Primary sources used</a:t>
             </a:r>
           </a:p>
         </p:txBody>
@@ -7005,8 +6472,8 @@
         </p:nvSpPr>
         <p:spPr>
           <a:xfrm>
-            <a:off x="548640" y="1508760"/>
-            <a:ext cx="11064240" cy="4892040"/>
+            <a:off x="594360" y="1508760"/>
+            <a:ext cx="10972800" cy="4892040"/>
           </a:xfrm>
           <a:prstGeom prst="roundRect">
             <a:avLst/>
@@ -7016,7 +6483,7 @@
           </a:solidFill>
           <a:ln>
             <a:solidFill>
-              <a:srgbClr val="D8E1DA"/>
+              <a:srgbClr val="D6DFD9"/>
             </a:solidFill>
           </a:ln>
         </p:spPr>
@@ -7051,7 +6518,7 @@
         <p:spPr>
           <a:xfrm>
             <a:off x="914400" y="1828800"/>
-            <a:ext cx="10332720" cy="4297680"/>
+            <a:ext cx="10241280" cy="4389120"/>
           </a:xfrm>
           <a:prstGeom prst="rect">
             <a:avLst/>
@@ -7068,14 +6535,14 @@
               <a:spcAft>
                 <a:spcPts val="1000"/>
               </a:spcAft>
-              <a:defRPr sz="2200">
-                <a:solidFill>
-                  <a:srgbClr val="23372A"/>
+              <a:defRPr sz="2400">
+                <a:solidFill>
+                  <a:srgbClr val="1D3226"/>
                 </a:solidFill>
               </a:defRPr>
             </a:pPr>
             <a:r>
-              <a:t>Begin with one high-value domain and measurable SLOs</a:t>
+              <a:t>• Meilisearch Documentation: FAQ and Configuration</a:t>
             </a:r>
           </a:p>
           <a:p>
@@ -7083,14 +6550,14 @@
               <a:spcAft>
                 <a:spcPts val="1000"/>
               </a:spcAft>
-              <a:defRPr sz="2200">
-                <a:solidFill>
-                  <a:srgbClr val="23372A"/>
+              <a:defRPr sz="2400">
+                <a:solidFill>
+                  <a:srgbClr val="1D3226"/>
                 </a:solidFill>
               </a:defRPr>
             </a:pPr>
             <a:r>
-              <a:t>Institutionalize ingestion controls before widening scope</a:t>
+              <a:t>• Meilisearch Documentation: Security and tenant tokens</a:t>
             </a:r>
           </a:p>
           <a:p>
@@ -7098,14 +6565,29 @@
               <a:spcAft>
                 <a:spcPts val="1000"/>
               </a:spcAft>
-              <a:defRPr sz="2200">
-                <a:solidFill>
-                  <a:srgbClr val="23372A"/>
+              <a:defRPr sz="2400">
+                <a:solidFill>
+                  <a:srgbClr val="1D3226"/>
                 </a:solidFill>
               </a:defRPr>
             </a:pPr>
             <a:r>
-              <a:t>Use edition decision gates tied to capacity and HA thresholds</a:t>
+              <a:t>• Meilisearch Documentation: Community vs Enterprise</a:t>
+            </a:r>
+          </a:p>
+          <a:p>
+            <a:pPr>
+              <a:spcAft>
+                <a:spcPts val="1000"/>
+              </a:spcAft>
+              <a:defRPr sz="2400">
+                <a:solidFill>
+                  <a:srgbClr val="1D3226"/>
+                </a:solidFill>
+              </a:defRPr>
+            </a:pPr>
+            <a:r>
+              <a:t>• Meilisearch Documentation: Indexing performance guidance</a:t>
             </a:r>
           </a:p>
         </p:txBody>

</xml_diff>

<commit_message>
refine: rebuild pdf and pptx as direct plain-language Q&A for meilisearch rollout
Agent-Logs-Url: https://github.com/DARREN-2000/temporary/sessions/f9fb5e82-04ea-4700-8875-82355bf8c7d7

Co-authored-by: DARREN-2000 <59622013+DARREN-2000@users.noreply.github.com>
</commit_message>
<xml_diff>
--- a/Meilisearch_Olam_Agri_Presentation.pptx
+++ b/Meilisearch_Olam_Agri_Presentation.pptx
@@ -13,7 +13,6 @@
     <p:sldId id="261" r:id="rId12"/>
     <p:sldId id="262" r:id="rId13"/>
     <p:sldId id="263" r:id="rId14"/>
-    <p:sldId id="264" r:id="rId15"/>
   </p:sldIdLst>
   <p:sldSz cx="12191695" cy="6858000" type="screen4x3"/>
   <p:notesSz cx="6858000" cy="9144000"/>
@@ -3148,7 +3147,7 @@
         <p:spPr>
           <a:xfrm>
             <a:off x="0" y="0"/>
-            <a:ext cx="12191695" cy="749808"/>
+            <a:ext cx="12191695" cy="777240"/>
           </a:xfrm>
           <a:prstGeom prst="rect">
             <a:avLst/>
@@ -3191,7 +3190,7 @@
         <p:spPr>
           <a:xfrm>
             <a:off x="502920" y="128016"/>
-            <a:ext cx="9601200" cy="457200"/>
+            <a:ext cx="10972800" cy="457200"/>
           </a:xfrm>
           <a:prstGeom prst="rect">
             <a:avLst/>
@@ -3212,21 +3211,66 @@
               </a:defRPr>
             </a:pPr>
             <a:r>
-              <a:t>Meilisearch Plan for Olam Agri</a:t>
-            </a:r>
-          </a:p>
-        </p:txBody>
-      </p:sp>
-      <p:sp>
-        <p:nvSpPr>
-          <p:cNvPr id="5" name="TextBox 4"/>
+              <a:t>Meilisearch for Olam Agri</a:t>
+            </a:r>
+          </a:p>
+        </p:txBody>
+      </p:sp>
+      <p:sp>
+        <p:nvSpPr>
+          <p:cNvPr id="5" name="Rounded Rectangle 4"/>
+          <p:cNvSpPr/>
+          <p:nvPr/>
+        </p:nvSpPr>
+        <p:spPr>
+          <a:xfrm>
+            <a:off x="640080" y="1188720"/>
+            <a:ext cx="10972800" cy="5303520"/>
+          </a:xfrm>
+          <a:prstGeom prst="roundRect">
+            <a:avLst/>
+          </a:prstGeom>
+          <a:solidFill>
+            <a:srgbClr val="FFFFFF"/>
+          </a:solidFill>
+          <a:ln>
+            <a:solidFill>
+              <a:srgbClr val="D6DFD9"/>
+            </a:solidFill>
+          </a:ln>
+        </p:spPr>
+        <p:style>
+          <a:lnRef idx="1">
+            <a:schemeClr val="accent1"/>
+          </a:lnRef>
+          <a:fillRef idx="3">
+            <a:schemeClr val="accent1"/>
+          </a:fillRef>
+          <a:effectRef idx="2">
+            <a:schemeClr val="accent1"/>
+          </a:effectRef>
+          <a:fontRef idx="minor">
+            <a:schemeClr val="lt1"/>
+          </a:fontRef>
+        </p:style>
+        <p:txBody>
+          <a:bodyPr rtlCol="0" anchor="ctr"/>
+          <a:lstStyle/>
+          <a:p>
+            <a:pPr algn="ctr"/>
+          </a:p>
+        </p:txBody>
+      </p:sp>
+      <p:sp>
+        <p:nvSpPr>
+          <p:cNvPr id="6" name="TextBox 5"/>
           <p:cNvSpPr txBox="1"/>
           <p:nvPr/>
         </p:nvSpPr>
         <p:spPr>
           <a:xfrm>
-            <a:off x="9875520" y="182880"/>
-            <a:ext cx="2103120" cy="320040"/>
+            <a:off x="914400" y="1508760"/>
+            <a:ext cx="10241280" cy="640080"/>
           </a:xfrm>
           <a:prstGeom prst="rect">
             <a:avLst/>
@@ -3239,29 +3283,29 @@
           </a:bodyPr>
           <a:lstStyle/>
           <a:p>
-            <a:pPr algn="r">
-              <a:defRPr sz="1000">
-                <a:solidFill>
-                  <a:srgbClr val="D7E3DD"/>
+            <a:pPr>
+              <a:defRPr sz="1800" b="1">
+                <a:solidFill>
+                  <a:srgbClr val="18402C"/>
                 </a:solidFill>
               </a:defRPr>
             </a:pPr>
             <a:r>
-              <a:t>Olam Agri</a:t>
-            </a:r>
-          </a:p>
-        </p:txBody>
-      </p:sp>
-      <p:sp>
-        <p:nvSpPr>
-          <p:cNvPr id="6" name="TextBox 5"/>
+              <a:t>Simple answers to your exact questions</a:t>
+            </a:r>
+          </a:p>
+        </p:txBody>
+      </p:sp>
+      <p:sp>
+        <p:nvSpPr>
+          <p:cNvPr id="7" name="TextBox 6"/>
           <p:cNvSpPr txBox="1"/>
           <p:nvPr/>
         </p:nvSpPr>
         <p:spPr>
           <a:xfrm>
-            <a:off x="685800" y="1828800"/>
-            <a:ext cx="10789920" cy="1371600"/>
+            <a:off x="914400" y="2148840"/>
+            <a:ext cx="10149840" cy="4023360"/>
           </a:xfrm>
           <a:prstGeom prst="rect">
             <a:avLst/>
@@ -3269,55 +3313,83 @@
           <a:noFill/>
         </p:spPr>
         <p:txBody>
-          <a:bodyPr wrap="none">
+          <a:bodyPr wrap="square">
             <a:spAutoFit/>
           </a:bodyPr>
           <a:lstStyle/>
           <a:p>
             <a:pPr>
-              <a:defRPr sz="3600" b="1">
+              <a:spcAft>
+                <a:spcPts val="1000"/>
+              </a:spcAft>
+              <a:defRPr sz="2400">
                 <a:solidFill>
                   <a:srgbClr val="1D3226"/>
                 </a:solidFill>
               </a:defRPr>
             </a:pPr>
             <a:r>
-              <a:t>Simple rollout plan for fast and reliable search</a:t>
-            </a:r>
-          </a:p>
-        </p:txBody>
-      </p:sp>
-      <p:sp>
-        <p:nvSpPr>
-          <p:cNvPr id="7" name="TextBox 6"/>
-          <p:cNvSpPr txBox="1"/>
-          <p:nvPr/>
-        </p:nvSpPr>
-        <p:spPr>
-          <a:xfrm>
-            <a:off x="685800" y="3931920"/>
-            <a:ext cx="7772400" cy="914400"/>
-          </a:xfrm>
-          <a:prstGeom prst="rect">
-            <a:avLst/>
-          </a:prstGeom>
-          <a:noFill/>
-        </p:spPr>
-        <p:txBody>
-          <a:bodyPr wrap="none">
-            <a:spAutoFit/>
-          </a:bodyPr>
-          <a:lstStyle/>
+              <a:t>• Will performance go down?</a:t>
+            </a:r>
+          </a:p>
           <a:p>
             <a:pPr>
-              <a:defRPr sz="2000">
-                <a:solidFill>
-                  <a:srgbClr val="50685C"/>
+              <a:spcAft>
+                <a:spcPts val="1000"/>
+              </a:spcAft>
+              <a:defRPr sz="2400">
+                <a:solidFill>
+                  <a:srgbClr val="1D3226"/>
                 </a:solidFill>
               </a:defRPr>
             </a:pPr>
             <a:r>
-              <a:t>Clear architecture | practical risks | 12-week roadmap</a:t>
+              <a:t>• How to integrate with Olam Agri?</a:t>
+            </a:r>
+          </a:p>
+          <a:p>
+            <a:pPr>
+              <a:spcAft>
+                <a:spcPts val="1000"/>
+              </a:spcAft>
+              <a:defRPr sz="2400">
+                <a:solidFill>
+                  <a:srgbClr val="1D3226"/>
+                </a:solidFill>
+              </a:defRPr>
+            </a:pPr>
+            <a:r>
+              <a:t>• What are the requirements?</a:t>
+            </a:r>
+          </a:p>
+          <a:p>
+            <a:pPr>
+              <a:spcAft>
+                <a:spcPts val="1000"/>
+              </a:spcAft>
+              <a:defRPr sz="2400">
+                <a:solidFill>
+                  <a:srgbClr val="1D3226"/>
+                </a:solidFill>
+              </a:defRPr>
+            </a:pPr>
+            <a:r>
+              <a:t>• What are self-host options?</a:t>
+            </a:r>
+          </a:p>
+          <a:p>
+            <a:pPr>
+              <a:spcAft>
+                <a:spcPts val="1000"/>
+              </a:spcAft>
+              <a:defRPr sz="2400">
+                <a:solidFill>
+                  <a:srgbClr val="1D3226"/>
+                </a:solidFill>
+              </a:defRPr>
+            </a:pPr>
+            <a:r>
+              <a:t>• What are the blockers?</a:t>
             </a:r>
           </a:p>
         </p:txBody>
@@ -3392,7 +3464,7 @@
         <p:spPr>
           <a:xfrm>
             <a:off x="0" y="0"/>
-            <a:ext cx="12191695" cy="749808"/>
+            <a:ext cx="12191695" cy="777240"/>
           </a:xfrm>
           <a:prstGeom prst="rect">
             <a:avLst/>
@@ -3435,7 +3507,7 @@
         <p:spPr>
           <a:xfrm>
             <a:off x="502920" y="128016"/>
-            <a:ext cx="9601200" cy="457200"/>
+            <a:ext cx="10972800" cy="457200"/>
           </a:xfrm>
           <a:prstGeom prst="rect">
             <a:avLst/>
@@ -3456,91 +3528,21 @@
               </a:defRPr>
             </a:pPr>
             <a:r>
-              <a:t>What we are trying to solve</a:t>
-            </a:r>
-          </a:p>
-        </p:txBody>
-      </p:sp>
-      <p:sp>
-        <p:nvSpPr>
-          <p:cNvPr id="5" name="TextBox 4"/>
-          <p:cNvSpPr txBox="1"/>
-          <p:nvPr/>
-        </p:nvSpPr>
-        <p:spPr>
-          <a:xfrm>
-            <a:off x="9875520" y="182880"/>
-            <a:ext cx="2103120" cy="320040"/>
-          </a:xfrm>
-          <a:prstGeom prst="rect">
-            <a:avLst/>
-          </a:prstGeom>
-          <a:noFill/>
-        </p:spPr>
-        <p:txBody>
-          <a:bodyPr wrap="none">
-            <a:spAutoFit/>
-          </a:bodyPr>
-          <a:lstStyle/>
-          <a:p>
-            <a:pPr algn="r">
-              <a:defRPr sz="1000">
-                <a:solidFill>
-                  <a:srgbClr val="D7E3DD"/>
-                </a:solidFill>
-              </a:defRPr>
-            </a:pPr>
-            <a:r>
-              <a:t>Olam Agri</a:t>
-            </a:r>
-          </a:p>
-        </p:txBody>
-      </p:sp>
-      <p:sp>
-        <p:nvSpPr>
-          <p:cNvPr id="6" name="TextBox 5"/>
-          <p:cNvSpPr txBox="1"/>
-          <p:nvPr/>
-        </p:nvSpPr>
-        <p:spPr>
-          <a:xfrm>
-            <a:off x="685800" y="960120"/>
-            <a:ext cx="10972800" cy="548640"/>
-          </a:xfrm>
-          <a:prstGeom prst="rect">
-            <a:avLst/>
-          </a:prstGeom>
-          <a:noFill/>
-        </p:spPr>
-        <p:txBody>
-          <a:bodyPr wrap="none">
-            <a:spAutoFit/>
-          </a:bodyPr>
-          <a:lstStyle/>
-          <a:p>
-            <a:pPr>
-              <a:defRPr sz="1600">
-                <a:solidFill>
-                  <a:srgbClr val="50685C"/>
-                </a:solidFill>
-              </a:defRPr>
-            </a:pPr>
-            <a:r>
-              <a:t>Goal: help users find the right data quickly.</a:t>
-            </a:r>
-          </a:p>
-        </p:txBody>
-      </p:sp>
-      <p:sp>
-        <p:nvSpPr>
-          <p:cNvPr id="7" name="Rounded Rectangle 6"/>
+              <a:t>1) Will performance go down?</a:t>
+            </a:r>
+          </a:p>
+        </p:txBody>
+      </p:sp>
+      <p:sp>
+        <p:nvSpPr>
+          <p:cNvPr id="5" name="Rounded Rectangle 4"/>
           <p:cNvSpPr/>
           <p:nvPr/>
         </p:nvSpPr>
         <p:spPr>
           <a:xfrm>
-            <a:off x="594360" y="1508760"/>
-            <a:ext cx="10972800" cy="4892040"/>
+            <a:off x="640080" y="1188720"/>
+            <a:ext cx="10972800" cy="5303520"/>
           </a:xfrm>
           <a:prstGeom prst="roundRect">
             <a:avLst/>
@@ -3578,14 +3580,14 @@
       </p:sp>
       <p:sp>
         <p:nvSpPr>
-          <p:cNvPr id="8" name="TextBox 7"/>
+          <p:cNvPr id="6" name="TextBox 5"/>
           <p:cNvSpPr txBox="1"/>
           <p:nvPr/>
         </p:nvSpPr>
         <p:spPr>
           <a:xfrm>
-            <a:off x="914400" y="1828800"/>
-            <a:ext cx="10241280" cy="4389120"/>
+            <a:off x="914400" y="1508760"/>
+            <a:ext cx="10241280" cy="640080"/>
           </a:xfrm>
           <a:prstGeom prst="rect">
             <a:avLst/>
@@ -3593,6 +3595,41 @@
           <a:noFill/>
         </p:spPr>
         <p:txBody>
+          <a:bodyPr wrap="none">
+            <a:spAutoFit/>
+          </a:bodyPr>
+          <a:lstStyle/>
+          <a:p>
+            <a:pPr>
+              <a:defRPr sz="1800" b="1">
+                <a:solidFill>
+                  <a:srgbClr val="18402C"/>
+                </a:solidFill>
+              </a:defRPr>
+            </a:pPr>
+            <a:r>
+              <a:t>Short answer: only if indexing is not controlled.</a:t>
+            </a:r>
+          </a:p>
+        </p:txBody>
+      </p:sp>
+      <p:sp>
+        <p:nvSpPr>
+          <p:cNvPr id="7" name="TextBox 6"/>
+          <p:cNvSpPr txBox="1"/>
+          <p:nvPr/>
+        </p:nvSpPr>
+        <p:spPr>
+          <a:xfrm>
+            <a:off x="914400" y="2148840"/>
+            <a:ext cx="10149840" cy="4023360"/>
+          </a:xfrm>
+          <a:prstGeom prst="rect">
+            <a:avLst/>
+          </a:prstGeom>
+          <a:noFill/>
+        </p:spPr>
+        <p:txBody>
           <a:bodyPr wrap="square">
             <a:spAutoFit/>
           </a:bodyPr>
@@ -3602,14 +3639,14 @@
               <a:spcAft>
                 <a:spcPts val="1000"/>
               </a:spcAft>
-              <a:defRPr sz="2400">
+              <a:defRPr sz="2200">
                 <a:solidFill>
                   <a:srgbClr val="1D3226"/>
                 </a:solidFill>
               </a:defRPr>
             </a:pPr>
             <a:r>
-              <a:t>• Search across business data without slowing source systems</a:t>
+              <a:t>• Search can stay fast with indexing limits.</a:t>
             </a:r>
           </a:p>
           <a:p>
@@ -3617,14 +3654,14 @@
               <a:spcAft>
                 <a:spcPts val="1000"/>
               </a:spcAft>
-              <a:defRPr sz="2400">
+              <a:defRPr sz="2200">
                 <a:solidFill>
                   <a:srgbClr val="1D3226"/>
                 </a:solidFill>
               </a:defRPr>
             </a:pPr>
             <a:r>
-              <a:t>• Keep SAP as source of truth</a:t>
+              <a:t>• Run indexing in smaller batches.</a:t>
             </a:r>
           </a:p>
           <a:p>
@@ -3632,14 +3669,14 @@
               <a:spcAft>
                 <a:spcPts val="1000"/>
               </a:spcAft>
-              <a:defRPr sz="2400">
+              <a:defRPr sz="2200">
                 <a:solidFill>
                   <a:srgbClr val="1D3226"/>
                 </a:solidFill>
               </a:defRPr>
             </a:pPr>
             <a:r>
-              <a:t>• Give users fast and relevant results</a:t>
+              <a:t>• Track response time, CPU, and queue every day.</a:t>
             </a:r>
           </a:p>
         </p:txBody>
@@ -3714,7 +3751,7 @@
         <p:spPr>
           <a:xfrm>
             <a:off x="0" y="0"/>
-            <a:ext cx="12191695" cy="749808"/>
+            <a:ext cx="12191695" cy="777240"/>
           </a:xfrm>
           <a:prstGeom prst="rect">
             <a:avLst/>
@@ -3757,7 +3794,7 @@
         <p:spPr>
           <a:xfrm>
             <a:off x="502920" y="128016"/>
-            <a:ext cx="9601200" cy="457200"/>
+            <a:ext cx="10972800" cy="457200"/>
           </a:xfrm>
           <a:prstGeom prst="rect">
             <a:avLst/>
@@ -3778,91 +3815,21 @@
               </a:defRPr>
             </a:pPr>
             <a:r>
-              <a:t>How the system should work</a:t>
-            </a:r>
-          </a:p>
-        </p:txBody>
-      </p:sp>
-      <p:sp>
-        <p:nvSpPr>
-          <p:cNvPr id="5" name="TextBox 4"/>
-          <p:cNvSpPr txBox="1"/>
-          <p:nvPr/>
-        </p:nvSpPr>
-        <p:spPr>
-          <a:xfrm>
-            <a:off x="9875520" y="182880"/>
-            <a:ext cx="2103120" cy="320040"/>
-          </a:xfrm>
-          <a:prstGeom prst="rect">
-            <a:avLst/>
-          </a:prstGeom>
-          <a:noFill/>
-        </p:spPr>
-        <p:txBody>
-          <a:bodyPr wrap="none">
-            <a:spAutoFit/>
-          </a:bodyPr>
-          <a:lstStyle/>
-          <a:p>
-            <a:pPr algn="r">
-              <a:defRPr sz="1000">
-                <a:solidFill>
-                  <a:srgbClr val="D7E3DD"/>
-                </a:solidFill>
-              </a:defRPr>
-            </a:pPr>
-            <a:r>
-              <a:t>Olam Agri</a:t>
-            </a:r>
-          </a:p>
-        </p:txBody>
-      </p:sp>
-      <p:sp>
-        <p:nvSpPr>
-          <p:cNvPr id="6" name="TextBox 5"/>
-          <p:cNvSpPr txBox="1"/>
-          <p:nvPr/>
-        </p:nvSpPr>
-        <p:spPr>
-          <a:xfrm>
-            <a:off x="685800" y="960120"/>
-            <a:ext cx="10972800" cy="548640"/>
-          </a:xfrm>
-          <a:prstGeom prst="rect">
-            <a:avLst/>
-          </a:prstGeom>
-          <a:noFill/>
-        </p:spPr>
-        <p:txBody>
-          <a:bodyPr wrap="none">
-            <a:spAutoFit/>
-          </a:bodyPr>
-          <a:lstStyle/>
-          <a:p>
-            <a:pPr>
-              <a:defRPr sz="1600">
-                <a:solidFill>
-                  <a:srgbClr val="50685C"/>
-                </a:solidFill>
-              </a:defRPr>
-            </a:pPr>
-            <a:r>
-              <a:t>Use one simple data flow.</a:t>
-            </a:r>
-          </a:p>
-        </p:txBody>
-      </p:sp>
-      <p:sp>
-        <p:nvSpPr>
-          <p:cNvPr id="7" name="Rounded Rectangle 6"/>
+              <a:t>2) How to integrate with Olam Agri?</a:t>
+            </a:r>
+          </a:p>
+        </p:txBody>
+      </p:sp>
+      <p:sp>
+        <p:nvSpPr>
+          <p:cNvPr id="5" name="Rounded Rectangle 4"/>
           <p:cNvSpPr/>
           <p:nvPr/>
         </p:nvSpPr>
         <p:spPr>
           <a:xfrm>
-            <a:off x="594360" y="1508760"/>
-            <a:ext cx="10972800" cy="4892040"/>
+            <a:off x="640080" y="1188720"/>
+            <a:ext cx="10972800" cy="5303520"/>
           </a:xfrm>
           <a:prstGeom prst="roundRect">
             <a:avLst/>
@@ -3900,14 +3867,14 @@
       </p:sp>
       <p:sp>
         <p:nvSpPr>
-          <p:cNvPr id="8" name="TextBox 7"/>
+          <p:cNvPr id="6" name="TextBox 5"/>
           <p:cNvSpPr txBox="1"/>
           <p:nvPr/>
         </p:nvSpPr>
         <p:spPr>
           <a:xfrm>
-            <a:off x="914400" y="1828800"/>
-            <a:ext cx="10241280" cy="4389120"/>
+            <a:off x="914400" y="1508760"/>
+            <a:ext cx="10241280" cy="640080"/>
           </a:xfrm>
           <a:prstGeom prst="rect">
             <a:avLst/>
@@ -3915,6 +3882,41 @@
           <a:noFill/>
         </p:spPr>
         <p:txBody>
+          <a:bodyPr wrap="none">
+            <a:spAutoFit/>
+          </a:bodyPr>
+          <a:lstStyle/>
+          <a:p>
+            <a:pPr>
+              <a:defRPr sz="1800" b="1">
+                <a:solidFill>
+                  <a:srgbClr val="18402C"/>
+                </a:solidFill>
+              </a:defRPr>
+            </a:pPr>
+            <a:r>
+              <a:t>Use one clear flow</a:t>
+            </a:r>
+          </a:p>
+        </p:txBody>
+      </p:sp>
+      <p:sp>
+        <p:nvSpPr>
+          <p:cNvPr id="7" name="TextBox 6"/>
+          <p:cNvSpPr txBox="1"/>
+          <p:nvPr/>
+        </p:nvSpPr>
+        <p:spPr>
+          <a:xfrm>
+            <a:off x="914400" y="2148840"/>
+            <a:ext cx="10149840" cy="4023360"/>
+          </a:xfrm>
+          <a:prstGeom prst="rect">
+            <a:avLst/>
+          </a:prstGeom>
+          <a:noFill/>
+        </p:spPr>
+        <p:txBody>
           <a:bodyPr wrap="square">
             <a:spAutoFit/>
           </a:bodyPr>
@@ -3924,14 +3926,14 @@
               <a:spcAft>
                 <a:spcPts val="1000"/>
               </a:spcAft>
-              <a:defRPr sz="2400">
+              <a:defRPr sz="2200">
                 <a:solidFill>
                   <a:srgbClr val="1D3226"/>
                 </a:solidFill>
               </a:defRPr>
             </a:pPr>
             <a:r>
-              <a:t>• Step 1: Source systems hold official data</a:t>
+              <a:t>• Source systems keep official data.</a:t>
             </a:r>
           </a:p>
           <a:p>
@@ -3939,14 +3941,14 @@
               <a:spcAft>
                 <a:spcPts val="1000"/>
               </a:spcAft>
-              <a:defRPr sz="2400">
+              <a:defRPr sz="2200">
                 <a:solidFill>
                   <a:srgbClr val="1D3226"/>
                 </a:solidFill>
               </a:defRPr>
             </a:pPr>
             <a:r>
-              <a:t>• Step 2: Middleware cleans and reshapes data</a:t>
+              <a:t>• Middleware cleans and maps data.</a:t>
             </a:r>
           </a:p>
           <a:p>
@@ -3954,14 +3956,14 @@
               <a:spcAft>
                 <a:spcPts val="1000"/>
               </a:spcAft>
-              <a:defRPr sz="2400">
+              <a:defRPr sz="2200">
                 <a:solidFill>
                   <a:srgbClr val="1D3226"/>
                 </a:solidFill>
               </a:defRPr>
             </a:pPr>
             <a:r>
-              <a:t>• Step 3: Meilisearch stores search-ready documents</a:t>
+              <a:t>• Meilisearch stores search-ready documents.</a:t>
             </a:r>
           </a:p>
           <a:p>
@@ -3969,14 +3971,14 @@
               <a:spcAft>
                 <a:spcPts val="1000"/>
               </a:spcAft>
-              <a:defRPr sz="2400">
+              <a:defRPr sz="2200">
                 <a:solidFill>
                   <a:srgbClr val="1D3226"/>
                 </a:solidFill>
               </a:defRPr>
             </a:pPr>
             <a:r>
-              <a:t>• Step 4: Apps call Meilisearch for user search</a:t>
+              <a:t>• Frontend calls search API and shows results.</a:t>
             </a:r>
           </a:p>
         </p:txBody>
@@ -4051,7 +4053,7 @@
         <p:spPr>
           <a:xfrm>
             <a:off x="0" y="0"/>
-            <a:ext cx="12191695" cy="749808"/>
+            <a:ext cx="12191695" cy="777240"/>
           </a:xfrm>
           <a:prstGeom prst="rect">
             <a:avLst/>
@@ -4094,7 +4096,7 @@
         <p:spPr>
           <a:xfrm>
             <a:off x="502920" y="128016"/>
-            <a:ext cx="9601200" cy="457200"/>
+            <a:ext cx="10972800" cy="457200"/>
           </a:xfrm>
           <a:prstGeom prst="rect">
             <a:avLst/>
@@ -4115,56 +4117,21 @@
               </a:defRPr>
             </a:pPr>
             <a:r>
-              <a:t>Most important performance rule</a:t>
-            </a:r>
-          </a:p>
-        </p:txBody>
-      </p:sp>
-      <p:sp>
-        <p:nvSpPr>
-          <p:cNvPr id="5" name="TextBox 4"/>
-          <p:cNvSpPr txBox="1"/>
-          <p:nvPr/>
-        </p:nvSpPr>
-        <p:spPr>
-          <a:xfrm>
-            <a:off x="9875520" y="182880"/>
-            <a:ext cx="2103120" cy="320040"/>
-          </a:xfrm>
-          <a:prstGeom prst="rect">
-            <a:avLst/>
-          </a:prstGeom>
-          <a:noFill/>
-        </p:spPr>
-        <p:txBody>
-          <a:bodyPr wrap="none">
-            <a:spAutoFit/>
-          </a:bodyPr>
-          <a:lstStyle/>
-          <a:p>
-            <a:pPr algn="r">
-              <a:defRPr sz="1000">
-                <a:solidFill>
-                  <a:srgbClr val="D7E3DD"/>
-                </a:solidFill>
-              </a:defRPr>
-            </a:pPr>
-            <a:r>
-              <a:t>Olam Agri</a:t>
-            </a:r>
-          </a:p>
-        </p:txBody>
-      </p:sp>
-      <p:sp>
-        <p:nvSpPr>
-          <p:cNvPr id="6" name="Rounded Rectangle 5"/>
+              <a:t>3) What are the requirements?</a:t>
+            </a:r>
+          </a:p>
+        </p:txBody>
+      </p:sp>
+      <p:sp>
+        <p:nvSpPr>
+          <p:cNvPr id="5" name="Rounded Rectangle 4"/>
           <p:cNvSpPr/>
           <p:nvPr/>
         </p:nvSpPr>
         <p:spPr>
           <a:xfrm>
-            <a:off x="594360" y="1143000"/>
-            <a:ext cx="5440680" cy="5440680"/>
+            <a:off x="640080" y="1188720"/>
+            <a:ext cx="10972800" cy="5303520"/>
           </a:xfrm>
           <a:prstGeom prst="roundRect">
             <a:avLst/>
@@ -4202,59 +4169,14 @@
       </p:sp>
       <p:sp>
         <p:nvSpPr>
-          <p:cNvPr id="7" name="Rounded Rectangle 6"/>
-          <p:cNvSpPr/>
-          <p:nvPr/>
-        </p:nvSpPr>
-        <p:spPr>
-          <a:xfrm>
-            <a:off x="6172200" y="1143000"/>
-            <a:ext cx="5440680" cy="5440680"/>
-          </a:xfrm>
-          <a:prstGeom prst="roundRect">
-            <a:avLst/>
-          </a:prstGeom>
-          <a:solidFill>
-            <a:srgbClr val="FFFFFF"/>
-          </a:solidFill>
-          <a:ln>
-            <a:solidFill>
-              <a:srgbClr val="D6DFD9"/>
-            </a:solidFill>
-          </a:ln>
-        </p:spPr>
-        <p:style>
-          <a:lnRef idx="1">
-            <a:schemeClr val="accent1"/>
-          </a:lnRef>
-          <a:fillRef idx="3">
-            <a:schemeClr val="accent1"/>
-          </a:fillRef>
-          <a:effectRef idx="2">
-            <a:schemeClr val="accent1"/>
-          </a:effectRef>
-          <a:fontRef idx="minor">
-            <a:schemeClr val="lt1"/>
-          </a:fontRef>
-        </p:style>
-        <p:txBody>
-          <a:bodyPr rtlCol="0" anchor="ctr"/>
-          <a:lstStyle/>
-          <a:p>
-            <a:pPr algn="ctr"/>
-          </a:p>
-        </p:txBody>
-      </p:sp>
-      <p:sp>
-        <p:nvSpPr>
-          <p:cNvPr id="8" name="TextBox 7"/>
+          <p:cNvPr id="6" name="TextBox 5"/>
           <p:cNvSpPr txBox="1"/>
           <p:nvPr/>
         </p:nvSpPr>
         <p:spPr>
           <a:xfrm>
-            <a:off x="868680" y="1371600"/>
-            <a:ext cx="4754880" cy="411480"/>
+            <a:off x="914400" y="1508760"/>
+            <a:ext cx="10241280" cy="640080"/>
           </a:xfrm>
           <a:prstGeom prst="rect">
             <a:avLst/>
@@ -4268,28 +4190,28 @@
           <a:lstStyle/>
           <a:p>
             <a:pPr>
-              <a:defRPr sz="2000" b="1">
+              <a:defRPr sz="1800" b="1">
                 <a:solidFill>
                   <a:srgbClr val="18402C"/>
                 </a:solidFill>
               </a:defRPr>
             </a:pPr>
             <a:r>
-              <a:t>What can go wrong</a:t>
-            </a:r>
-          </a:p>
-        </p:txBody>
-      </p:sp>
-      <p:sp>
-        <p:nvSpPr>
-          <p:cNvPr id="9" name="TextBox 8"/>
+              <a:t>Minimum requirements for a safe rollout</a:t>
+            </a:r>
+          </a:p>
+        </p:txBody>
+      </p:sp>
+      <p:sp>
+        <p:nvSpPr>
+          <p:cNvPr id="7" name="TextBox 6"/>
           <p:cNvSpPr txBox="1"/>
           <p:nvPr/>
         </p:nvSpPr>
         <p:spPr>
           <a:xfrm>
-            <a:off x="6446520" y="1371600"/>
-            <a:ext cx="4754880" cy="411480"/>
+            <a:off x="914400" y="2148840"/>
+            <a:ext cx="10149840" cy="4023360"/>
           </a:xfrm>
           <a:prstGeom prst="rect">
             <a:avLst/>
@@ -4297,156 +4219,83 @@
           <a:noFill/>
         </p:spPr>
         <p:txBody>
-          <a:bodyPr wrap="none">
+          <a:bodyPr wrap="square">
             <a:spAutoFit/>
           </a:bodyPr>
           <a:lstStyle/>
           <a:p>
             <a:pPr>
-              <a:defRPr sz="2000" b="1">
-                <a:solidFill>
-                  <a:srgbClr val="18402C"/>
+              <a:spcAft>
+                <a:spcPts val="1000"/>
+              </a:spcAft>
+              <a:defRPr sz="2200">
+                <a:solidFill>
+                  <a:srgbClr val="1D3226"/>
                 </a:solidFill>
               </a:defRPr>
             </a:pPr>
             <a:r>
-              <a:t>What to do</a:t>
-            </a:r>
-          </a:p>
-        </p:txBody>
-      </p:sp>
-      <p:sp>
-        <p:nvSpPr>
-          <p:cNvPr id="10" name="TextBox 9"/>
-          <p:cNvSpPr txBox="1"/>
-          <p:nvPr/>
-        </p:nvSpPr>
-        <p:spPr>
-          <a:xfrm>
-            <a:off x="868680" y="1828800"/>
-            <a:ext cx="4800600" cy="4297680"/>
-          </a:xfrm>
-          <a:prstGeom prst="rect">
-            <a:avLst/>
-          </a:prstGeom>
-          <a:noFill/>
-        </p:spPr>
-        <p:txBody>
-          <a:bodyPr wrap="none">
-            <a:spAutoFit/>
-          </a:bodyPr>
-          <a:lstStyle/>
+              <a:t>• Business owner for each index.</a:t>
+            </a:r>
+          </a:p>
           <a:p>
             <a:pPr>
               <a:spcAft>
-                <a:spcPts val="800"/>
+                <a:spcPts val="1000"/>
               </a:spcAft>
-              <a:defRPr sz="1700">
+              <a:defRPr sz="2200">
                 <a:solidFill>
                   <a:srgbClr val="1D3226"/>
                 </a:solidFill>
               </a:defRPr>
             </a:pPr>
             <a:r>
-              <a:t>• Indexing uses high memory and CPU</a:t>
+              <a:t>• Middleware service for data mapping.</a:t>
             </a:r>
           </a:p>
           <a:p>
             <a:pPr>
               <a:spcAft>
-                <a:spcPts val="800"/>
+                <a:spcPts val="1000"/>
               </a:spcAft>
-              <a:defRPr sz="1700">
+              <a:defRPr sz="2200">
                 <a:solidFill>
                   <a:srgbClr val="1D3226"/>
                 </a:solidFill>
               </a:defRPr>
             </a:pPr>
             <a:r>
-              <a:t>• Large update jobs can slow user search</a:t>
+              <a:t>• Backend-only API key handling.</a:t>
             </a:r>
           </a:p>
           <a:p>
             <a:pPr>
               <a:spcAft>
-                <a:spcPts val="800"/>
+                <a:spcPts val="1000"/>
               </a:spcAft>
-              <a:defRPr sz="1700">
+              <a:defRPr sz="2200">
                 <a:solidFill>
                   <a:srgbClr val="1D3226"/>
                 </a:solidFill>
               </a:defRPr>
             </a:pPr>
             <a:r>
-              <a:t>• No limits can cause unstable response times</a:t>
-            </a:r>
-          </a:p>
-        </p:txBody>
-      </p:sp>
-      <p:sp>
-        <p:nvSpPr>
-          <p:cNvPr id="11" name="TextBox 10"/>
-          <p:cNvSpPr txBox="1"/>
-          <p:nvPr/>
-        </p:nvSpPr>
-        <p:spPr>
-          <a:xfrm>
-            <a:off x="6446520" y="1828800"/>
-            <a:ext cx="4800600" cy="4297680"/>
-          </a:xfrm>
-          <a:prstGeom prst="rect">
-            <a:avLst/>
-          </a:prstGeom>
-          <a:noFill/>
-        </p:spPr>
-        <p:txBody>
-          <a:bodyPr wrap="none">
-            <a:spAutoFit/>
-          </a:bodyPr>
-          <a:lstStyle/>
+              <a:t>• Monitoring and alerting dashboard.</a:t>
+            </a:r>
+          </a:p>
           <a:p>
             <a:pPr>
               <a:spcAft>
-                <a:spcPts val="800"/>
+                <a:spcPts val="1000"/>
               </a:spcAft>
-              <a:defRPr sz="1700">
+              <a:defRPr sz="2200">
                 <a:solidFill>
                   <a:srgbClr val="1D3226"/>
                 </a:solidFill>
               </a:defRPr>
             </a:pPr>
             <a:r>
-              <a:t>• Set memory and thread limits for indexing</a:t>
-            </a:r>
-          </a:p>
-          <a:p>
-            <a:pPr>
-              <a:spcAft>
-                <a:spcPts val="800"/>
-              </a:spcAft>
-              <a:defRPr sz="1700">
-                <a:solidFill>
-                  <a:srgbClr val="1D3226"/>
-                </a:solidFill>
-              </a:defRPr>
-            </a:pPr>
-            <a:r>
-              <a:t>• Send smaller batches more often</a:t>
-            </a:r>
-          </a:p>
-          <a:p>
-            <a:pPr>
-              <a:spcAft>
-                <a:spcPts val="800"/>
-              </a:spcAft>
-              <a:defRPr sz="1700">
-                <a:solidFill>
-                  <a:srgbClr val="1D3226"/>
-                </a:solidFill>
-              </a:defRPr>
-            </a:pPr>
-            <a:r>
-              <a:t>• Track indexing queue and search latency daily</a:t>
+              <a:t>• Backup and restore drill before go-live.</a:t>
             </a:r>
           </a:p>
         </p:txBody>
@@ -4521,7 +4370,7 @@
         <p:spPr>
           <a:xfrm>
             <a:off x="0" y="0"/>
-            <a:ext cx="12191695" cy="749808"/>
+            <a:ext cx="12191695" cy="777240"/>
           </a:xfrm>
           <a:prstGeom prst="rect">
             <a:avLst/>
@@ -4564,7 +4413,7 @@
         <p:spPr>
           <a:xfrm>
             <a:off x="502920" y="128016"/>
-            <a:ext cx="9601200" cy="457200"/>
+            <a:ext cx="10972800" cy="457200"/>
           </a:xfrm>
           <a:prstGeom prst="rect">
             <a:avLst/>
@@ -4585,56 +4434,21 @@
               </a:defRPr>
             </a:pPr>
             <a:r>
-              <a:t>Deployment options (easy view)</a:t>
-            </a:r>
-          </a:p>
-        </p:txBody>
-      </p:sp>
-      <p:sp>
-        <p:nvSpPr>
-          <p:cNvPr id="5" name="TextBox 4"/>
-          <p:cNvSpPr txBox="1"/>
-          <p:nvPr/>
-        </p:nvSpPr>
-        <p:spPr>
-          <a:xfrm>
-            <a:off x="9875520" y="182880"/>
-            <a:ext cx="2103120" cy="320040"/>
-          </a:xfrm>
-          <a:prstGeom prst="rect">
-            <a:avLst/>
-          </a:prstGeom>
-          <a:noFill/>
-        </p:spPr>
-        <p:txBody>
-          <a:bodyPr wrap="none">
-            <a:spAutoFit/>
-          </a:bodyPr>
-          <a:lstStyle/>
-          <a:p>
-            <a:pPr algn="r">
-              <a:defRPr sz="1000">
-                <a:solidFill>
-                  <a:srgbClr val="D7E3DD"/>
-                </a:solidFill>
-              </a:defRPr>
-            </a:pPr>
-            <a:r>
-              <a:t>Olam Agri</a:t>
-            </a:r>
-          </a:p>
-        </p:txBody>
-      </p:sp>
-      <p:sp>
-        <p:nvSpPr>
-          <p:cNvPr id="6" name="Rounded Rectangle 5"/>
+              <a:t>4) Self-host options</a:t>
+            </a:r>
+          </a:p>
+        </p:txBody>
+      </p:sp>
+      <p:sp>
+        <p:nvSpPr>
+          <p:cNvPr id="5" name="Rounded Rectangle 4"/>
           <p:cNvSpPr/>
           <p:nvPr/>
         </p:nvSpPr>
         <p:spPr>
           <a:xfrm>
-            <a:off x="594360" y="1143000"/>
-            <a:ext cx="5440680" cy="5440680"/>
+            <a:off x="640080" y="1188720"/>
+            <a:ext cx="10972800" cy="5303520"/>
           </a:xfrm>
           <a:prstGeom prst="roundRect">
             <a:avLst/>
@@ -4672,59 +4486,14 @@
       </p:sp>
       <p:sp>
         <p:nvSpPr>
-          <p:cNvPr id="7" name="Rounded Rectangle 6"/>
-          <p:cNvSpPr/>
-          <p:nvPr/>
-        </p:nvSpPr>
-        <p:spPr>
-          <a:xfrm>
-            <a:off x="6172200" y="1143000"/>
-            <a:ext cx="5440680" cy="5440680"/>
-          </a:xfrm>
-          <a:prstGeom prst="roundRect">
-            <a:avLst/>
-          </a:prstGeom>
-          <a:solidFill>
-            <a:srgbClr val="FFFFFF"/>
-          </a:solidFill>
-          <a:ln>
-            <a:solidFill>
-              <a:srgbClr val="D6DFD9"/>
-            </a:solidFill>
-          </a:ln>
-        </p:spPr>
-        <p:style>
-          <a:lnRef idx="1">
-            <a:schemeClr val="accent1"/>
-          </a:lnRef>
-          <a:fillRef idx="3">
-            <a:schemeClr val="accent1"/>
-          </a:fillRef>
-          <a:effectRef idx="2">
-            <a:schemeClr val="accent1"/>
-          </a:effectRef>
-          <a:fontRef idx="minor">
-            <a:schemeClr val="lt1"/>
-          </a:fontRef>
-        </p:style>
-        <p:txBody>
-          <a:bodyPr rtlCol="0" anchor="ctr"/>
-          <a:lstStyle/>
-          <a:p>
-            <a:pPr algn="ctr"/>
-          </a:p>
-        </p:txBody>
-      </p:sp>
-      <p:sp>
-        <p:nvSpPr>
-          <p:cNvPr id="8" name="TextBox 7"/>
+          <p:cNvPr id="6" name="TextBox 5"/>
           <p:cNvSpPr txBox="1"/>
           <p:nvPr/>
         </p:nvSpPr>
         <p:spPr>
           <a:xfrm>
-            <a:off x="868680" y="1371600"/>
-            <a:ext cx="4754880" cy="411480"/>
+            <a:off x="914400" y="1508760"/>
+            <a:ext cx="10241280" cy="640080"/>
           </a:xfrm>
           <a:prstGeom prst="rect">
             <a:avLst/>
@@ -4738,28 +4507,28 @@
           <a:lstStyle/>
           <a:p>
             <a:pPr>
-              <a:defRPr sz="2000" b="1">
+              <a:defRPr sz="1800" b="1">
                 <a:solidFill>
                   <a:srgbClr val="18402C"/>
                 </a:solidFill>
               </a:defRPr>
             </a:pPr>
             <a:r>
-              <a:t>Community Edition</a:t>
-            </a:r>
-          </a:p>
-        </p:txBody>
-      </p:sp>
-      <p:sp>
-        <p:nvSpPr>
-          <p:cNvPr id="9" name="TextBox 8"/>
+              <a:t>Pick based on scale and ops capacity</a:t>
+            </a:r>
+          </a:p>
+        </p:txBody>
+      </p:sp>
+      <p:sp>
+        <p:nvSpPr>
+          <p:cNvPr id="7" name="TextBox 6"/>
           <p:cNvSpPr txBox="1"/>
           <p:nvPr/>
         </p:nvSpPr>
         <p:spPr>
           <a:xfrm>
-            <a:off x="6446520" y="1371600"/>
-            <a:ext cx="4754880" cy="411480"/>
+            <a:off x="914400" y="2148840"/>
+            <a:ext cx="10149840" cy="4023360"/>
           </a:xfrm>
           <a:prstGeom prst="rect">
             <a:avLst/>
@@ -4767,156 +4536,53 @@
           <a:noFill/>
         </p:spPr>
         <p:txBody>
-          <a:bodyPr wrap="none">
+          <a:bodyPr wrap="square">
             <a:spAutoFit/>
           </a:bodyPr>
           <a:lstStyle/>
           <a:p>
             <a:pPr>
-              <a:defRPr sz="2000" b="1">
-                <a:solidFill>
-                  <a:srgbClr val="18402C"/>
+              <a:spcAft>
+                <a:spcPts val="1000"/>
+              </a:spcAft>
+              <a:defRPr sz="2200">
+                <a:solidFill>
+                  <a:srgbClr val="1D3226"/>
                 </a:solidFill>
               </a:defRPr>
             </a:pPr>
             <a:r>
-              <a:t>Enterprise / Cloud</a:t>
-            </a:r>
-          </a:p>
-        </p:txBody>
-      </p:sp>
-      <p:sp>
-        <p:nvSpPr>
-          <p:cNvPr id="10" name="TextBox 9"/>
-          <p:cNvSpPr txBox="1"/>
-          <p:nvPr/>
-        </p:nvSpPr>
-        <p:spPr>
-          <a:xfrm>
-            <a:off x="868680" y="1828800"/>
-            <a:ext cx="4800600" cy="4297680"/>
-          </a:xfrm>
-          <a:prstGeom prst="rect">
-            <a:avLst/>
-          </a:prstGeom>
-          <a:noFill/>
-        </p:spPr>
-        <p:txBody>
-          <a:bodyPr wrap="none">
-            <a:spAutoFit/>
-          </a:bodyPr>
-          <a:lstStyle/>
+              <a:t>• Single VM/container: best for pilot.</a:t>
+            </a:r>
+          </a:p>
           <a:p>
             <a:pPr>
               <a:spcAft>
-                <a:spcPts val="800"/>
+                <a:spcPts val="1000"/>
               </a:spcAft>
-              <a:defRPr sz="1700">
+              <a:defRPr sz="2200">
                 <a:solidFill>
                   <a:srgbClr val="1D3226"/>
                 </a:solidFill>
               </a:defRPr>
             </a:pPr>
             <a:r>
-              <a:t>• Best for first rollout</a:t>
+              <a:t>• HA cluster: best for strict uptime needs.</a:t>
             </a:r>
           </a:p>
           <a:p>
             <a:pPr>
               <a:spcAft>
-                <a:spcPts val="800"/>
+                <a:spcPts val="1000"/>
               </a:spcAft>
-              <a:defRPr sz="1700">
+              <a:defRPr sz="2200">
                 <a:solidFill>
                   <a:srgbClr val="1D3226"/>
                 </a:solidFill>
               </a:defRPr>
             </a:pPr>
             <a:r>
-              <a:t>• Simple to run on one instance</a:t>
-            </a:r>
-          </a:p>
-          <a:p>
-            <a:pPr>
-              <a:spcAft>
-                <a:spcPts val="800"/>
-              </a:spcAft>
-              <a:defRPr sz="1700">
-                <a:solidFill>
-                  <a:srgbClr val="1D3226"/>
-                </a:solidFill>
-              </a:defRPr>
-            </a:pPr>
-            <a:r>
-              <a:t>• Good when scope is focused</a:t>
-            </a:r>
-          </a:p>
-        </p:txBody>
-      </p:sp>
-      <p:sp>
-        <p:nvSpPr>
-          <p:cNvPr id="11" name="TextBox 10"/>
-          <p:cNvSpPr txBox="1"/>
-          <p:nvPr/>
-        </p:nvSpPr>
-        <p:spPr>
-          <a:xfrm>
-            <a:off x="6446520" y="1828800"/>
-            <a:ext cx="4800600" cy="4297680"/>
-          </a:xfrm>
-          <a:prstGeom prst="rect">
-            <a:avLst/>
-          </a:prstGeom>
-          <a:noFill/>
-        </p:spPr>
-        <p:txBody>
-          <a:bodyPr wrap="none">
-            <a:spAutoFit/>
-          </a:bodyPr>
-          <a:lstStyle/>
-          <a:p>
-            <a:pPr>
-              <a:spcAft>
-                <a:spcPts val="800"/>
-              </a:spcAft>
-              <a:defRPr sz="1700">
-                <a:solidFill>
-                  <a:srgbClr val="1D3226"/>
-                </a:solidFill>
-              </a:defRPr>
-            </a:pPr>
-            <a:r>
-              <a:t>• Use when high availability is required</a:t>
-            </a:r>
-          </a:p>
-          <a:p>
-            <a:pPr>
-              <a:spcAft>
-                <a:spcPts val="800"/>
-              </a:spcAft>
-              <a:defRPr sz="1700">
-                <a:solidFill>
-                  <a:srgbClr val="1D3226"/>
-                </a:solidFill>
-              </a:defRPr>
-            </a:pPr>
-            <a:r>
-              <a:t>• Better for larger scale over time</a:t>
-            </a:r>
-          </a:p>
-          <a:p>
-            <a:pPr>
-              <a:spcAft>
-                <a:spcPts val="800"/>
-              </a:spcAft>
-              <a:defRPr sz="1700">
-                <a:solidFill>
-                  <a:srgbClr val="1D3226"/>
-                </a:solidFill>
-              </a:defRPr>
-            </a:pPr>
-            <a:r>
-              <a:t>• Cloud is faster if you want less ops work</a:t>
+              <a:t>• Managed cloud: best for less ops effort.</a:t>
             </a:r>
           </a:p>
         </p:txBody>
@@ -4991,7 +4657,7 @@
         <p:spPr>
           <a:xfrm>
             <a:off x="0" y="0"/>
-            <a:ext cx="12191695" cy="749808"/>
+            <a:ext cx="12191695" cy="777240"/>
           </a:xfrm>
           <a:prstGeom prst="rect">
             <a:avLst/>
@@ -5034,7 +4700,7 @@
         <p:spPr>
           <a:xfrm>
             <a:off x="502920" y="128016"/>
-            <a:ext cx="9601200" cy="457200"/>
+            <a:ext cx="10972800" cy="457200"/>
           </a:xfrm>
           <a:prstGeom prst="rect">
             <a:avLst/>
@@ -5055,56 +4721,21 @@
               </a:defRPr>
             </a:pPr>
             <a:r>
-              <a:t>Main risks and fixes</a:t>
-            </a:r>
-          </a:p>
-        </p:txBody>
-      </p:sp>
-      <p:sp>
-        <p:nvSpPr>
-          <p:cNvPr id="5" name="TextBox 4"/>
-          <p:cNvSpPr txBox="1"/>
-          <p:nvPr/>
-        </p:nvSpPr>
-        <p:spPr>
-          <a:xfrm>
-            <a:off x="9875520" y="182880"/>
-            <a:ext cx="2103120" cy="320040"/>
-          </a:xfrm>
-          <a:prstGeom prst="rect">
-            <a:avLst/>
-          </a:prstGeom>
-          <a:noFill/>
-        </p:spPr>
-        <p:txBody>
-          <a:bodyPr wrap="none">
-            <a:spAutoFit/>
-          </a:bodyPr>
-          <a:lstStyle/>
-          <a:p>
-            <a:pPr algn="r">
-              <a:defRPr sz="1000">
-                <a:solidFill>
-                  <a:srgbClr val="D7E3DD"/>
-                </a:solidFill>
-              </a:defRPr>
-            </a:pPr>
-            <a:r>
-              <a:t>Olam Agri</a:t>
-            </a:r>
-          </a:p>
-        </p:txBody>
-      </p:sp>
-      <p:sp>
-        <p:nvSpPr>
-          <p:cNvPr id="6" name="Rounded Rectangle 5"/>
+              <a:t>5) How to integrate (steps)</a:t>
+            </a:r>
+          </a:p>
+        </p:txBody>
+      </p:sp>
+      <p:sp>
+        <p:nvSpPr>
+          <p:cNvPr id="5" name="Rounded Rectangle 4"/>
           <p:cNvSpPr/>
           <p:nvPr/>
         </p:nvSpPr>
         <p:spPr>
           <a:xfrm>
-            <a:off x="594360" y="1143000"/>
-            <a:ext cx="5440680" cy="5440680"/>
+            <a:off x="640080" y="1188720"/>
+            <a:ext cx="10972800" cy="5303520"/>
           </a:xfrm>
           <a:prstGeom prst="roundRect">
             <a:avLst/>
@@ -5142,59 +4773,14 @@
       </p:sp>
       <p:sp>
         <p:nvSpPr>
-          <p:cNvPr id="7" name="Rounded Rectangle 6"/>
-          <p:cNvSpPr/>
-          <p:nvPr/>
-        </p:nvSpPr>
-        <p:spPr>
-          <a:xfrm>
-            <a:off x="6172200" y="1143000"/>
-            <a:ext cx="5440680" cy="5440680"/>
-          </a:xfrm>
-          <a:prstGeom prst="roundRect">
-            <a:avLst/>
-          </a:prstGeom>
-          <a:solidFill>
-            <a:srgbClr val="FFFFFF"/>
-          </a:solidFill>
-          <a:ln>
-            <a:solidFill>
-              <a:srgbClr val="D6DFD9"/>
-            </a:solidFill>
-          </a:ln>
-        </p:spPr>
-        <p:style>
-          <a:lnRef idx="1">
-            <a:schemeClr val="accent1"/>
-          </a:lnRef>
-          <a:fillRef idx="3">
-            <a:schemeClr val="accent1"/>
-          </a:fillRef>
-          <a:effectRef idx="2">
-            <a:schemeClr val="accent1"/>
-          </a:effectRef>
-          <a:fontRef idx="minor">
-            <a:schemeClr val="lt1"/>
-          </a:fontRef>
-        </p:style>
-        <p:txBody>
-          <a:bodyPr rtlCol="0" anchor="ctr"/>
-          <a:lstStyle/>
-          <a:p>
-            <a:pPr algn="ctr"/>
-          </a:p>
-        </p:txBody>
-      </p:sp>
-      <p:sp>
-        <p:nvSpPr>
-          <p:cNvPr id="8" name="TextBox 7"/>
+          <p:cNvPr id="6" name="TextBox 5"/>
           <p:cNvSpPr txBox="1"/>
           <p:nvPr/>
         </p:nvSpPr>
         <p:spPr>
           <a:xfrm>
-            <a:off x="868680" y="1371600"/>
-            <a:ext cx="4754880" cy="411480"/>
+            <a:off x="914400" y="1508760"/>
+            <a:ext cx="10241280" cy="640080"/>
           </a:xfrm>
           <a:prstGeom prst="rect">
             <a:avLst/>
@@ -5208,28 +4794,28 @@
           <a:lstStyle/>
           <a:p>
             <a:pPr>
-              <a:defRPr sz="2000" b="1">
+              <a:defRPr sz="1800" b="1">
                 <a:solidFill>
                   <a:srgbClr val="18402C"/>
                 </a:solidFill>
               </a:defRPr>
             </a:pPr>
             <a:r>
-              <a:t>Risks</a:t>
-            </a:r>
-          </a:p>
-        </p:txBody>
-      </p:sp>
-      <p:sp>
-        <p:nvSpPr>
-          <p:cNvPr id="9" name="TextBox 8"/>
+              <a:t>12-week simple rollout plan</a:t>
+            </a:r>
+          </a:p>
+        </p:txBody>
+      </p:sp>
+      <p:sp>
+        <p:nvSpPr>
+          <p:cNvPr id="7" name="TextBox 6"/>
           <p:cNvSpPr txBox="1"/>
           <p:nvPr/>
         </p:nvSpPr>
         <p:spPr>
           <a:xfrm>
-            <a:off x="6446520" y="1371600"/>
-            <a:ext cx="4754880" cy="411480"/>
+            <a:off x="914400" y="2148840"/>
+            <a:ext cx="10149840" cy="4023360"/>
           </a:xfrm>
           <a:prstGeom prst="rect">
             <a:avLst/>
@@ -5237,156 +4823,83 @@
           <a:noFill/>
         </p:spPr>
         <p:txBody>
-          <a:bodyPr wrap="none">
+          <a:bodyPr wrap="square">
             <a:spAutoFit/>
           </a:bodyPr>
           <a:lstStyle/>
           <a:p>
             <a:pPr>
-              <a:defRPr sz="2000" b="1">
-                <a:solidFill>
-                  <a:srgbClr val="18402C"/>
+              <a:spcAft>
+                <a:spcPts val="1000"/>
+              </a:spcAft>
+              <a:defRPr sz="2200">
+                <a:solidFill>
+                  <a:srgbClr val="1D3226"/>
                 </a:solidFill>
               </a:defRPr>
             </a:pPr>
             <a:r>
-              <a:t>Fixes</a:t>
-            </a:r>
-          </a:p>
-        </p:txBody>
-      </p:sp>
-      <p:sp>
-        <p:nvSpPr>
-          <p:cNvPr id="10" name="TextBox 9"/>
-          <p:cNvSpPr txBox="1"/>
-          <p:nvPr/>
-        </p:nvSpPr>
-        <p:spPr>
-          <a:xfrm>
-            <a:off x="868680" y="1828800"/>
-            <a:ext cx="4800600" cy="4297680"/>
-          </a:xfrm>
-          <a:prstGeom prst="rect">
-            <a:avLst/>
-          </a:prstGeom>
-          <a:noFill/>
-        </p:spPr>
-        <p:txBody>
-          <a:bodyPr wrap="none">
-            <a:spAutoFit/>
-          </a:bodyPr>
-          <a:lstStyle/>
+              <a:t>• Weeks 1-2: define use case and index fields.</a:t>
+            </a:r>
+          </a:p>
           <a:p>
             <a:pPr>
               <a:spcAft>
-                <a:spcPts val="800"/>
+                <a:spcPts val="1000"/>
               </a:spcAft>
-              <a:defRPr sz="1700">
+              <a:defRPr sz="2200">
                 <a:solidFill>
                   <a:srgbClr val="1D3226"/>
                 </a:solidFill>
               </a:defRPr>
             </a:pPr>
             <a:r>
-              <a:t>• Complex mapping from SAP tables</a:t>
+              <a:t>• Weeks 3-4: build mapping and first sync.</a:t>
             </a:r>
           </a:p>
           <a:p>
             <a:pPr>
               <a:spcAft>
-                <a:spcPts val="800"/>
+                <a:spcPts val="1000"/>
               </a:spcAft>
-              <a:defRPr sz="1700">
+              <a:defRPr sz="2200">
                 <a:solidFill>
                   <a:srgbClr val="1D3226"/>
                 </a:solidFill>
               </a:defRPr>
             </a:pPr>
             <a:r>
-              <a:t>• Indexing can affect search speed</a:t>
+              <a:t>• Weeks 5-6: connect frontend and secure access.</a:t>
             </a:r>
           </a:p>
           <a:p>
             <a:pPr>
               <a:spcAft>
-                <a:spcPts val="800"/>
+                <a:spcPts val="1000"/>
               </a:spcAft>
-              <a:defRPr sz="1700">
+              <a:defRPr sz="2200">
                 <a:solidFill>
                   <a:srgbClr val="1D3226"/>
                 </a:solidFill>
               </a:defRPr>
             </a:pPr>
             <a:r>
-              <a:t>• Weak key handling can expose data</a:t>
-            </a:r>
-          </a:p>
-        </p:txBody>
-      </p:sp>
-      <p:sp>
-        <p:nvSpPr>
-          <p:cNvPr id="11" name="TextBox 10"/>
-          <p:cNvSpPr txBox="1"/>
-          <p:nvPr/>
-        </p:nvSpPr>
-        <p:spPr>
-          <a:xfrm>
-            <a:off x="6446520" y="1828800"/>
-            <a:ext cx="4800600" cy="4297680"/>
-          </a:xfrm>
-          <a:prstGeom prst="rect">
-            <a:avLst/>
-          </a:prstGeom>
-          <a:noFill/>
-        </p:spPr>
-        <p:txBody>
-          <a:bodyPr wrap="none">
-            <a:spAutoFit/>
-          </a:bodyPr>
-          <a:lstStyle/>
+              <a:t>• Weeks 7-8: load test and tune relevance.</a:t>
+            </a:r>
+          </a:p>
           <a:p>
             <a:pPr>
               <a:spcAft>
-                <a:spcPts val="800"/>
+                <a:spcPts val="1000"/>
               </a:spcAft>
-              <a:defRPr sz="1700">
+              <a:defRPr sz="2200">
                 <a:solidFill>
                   <a:srgbClr val="1D3226"/>
                 </a:solidFill>
               </a:defRPr>
             </a:pPr>
             <a:r>
-              <a:t>• Start with one domain and stable schema</a:t>
-            </a:r>
-          </a:p>
-          <a:p>
-            <a:pPr>
-              <a:spcAft>
-                <a:spcPts val="800"/>
-              </a:spcAft>
-              <a:defRPr sz="1700">
-                <a:solidFill>
-                  <a:srgbClr val="1D3226"/>
-                </a:solidFill>
-              </a:defRPr>
-            </a:pPr>
-            <a:r>
-              <a:t>• Use strict indexing limits and staged updates</a:t>
-            </a:r>
-          </a:p>
-          <a:p>
-            <a:pPr>
-              <a:spcAft>
-                <a:spcPts val="800"/>
-              </a:spcAft>
-              <a:defRPr sz="1700">
-                <a:solidFill>
-                  <a:srgbClr val="1D3226"/>
-                </a:solidFill>
-              </a:defRPr>
-            </a:pPr>
-            <a:r>
-              <a:t>• Generate short-lived tokens in backend only</a:t>
+              <a:t>• Weeks 9-12: release in controlled stages.</a:t>
             </a:r>
           </a:p>
         </p:txBody>
@@ -5461,7 +4974,7 @@
         <p:spPr>
           <a:xfrm>
             <a:off x="0" y="0"/>
-            <a:ext cx="12191695" cy="749808"/>
+            <a:ext cx="12191695" cy="777240"/>
           </a:xfrm>
           <a:prstGeom prst="rect">
             <a:avLst/>
@@ -5504,7 +5017,7 @@
         <p:spPr>
           <a:xfrm>
             <a:off x="502920" y="128016"/>
-            <a:ext cx="9601200" cy="457200"/>
+            <a:ext cx="10972800" cy="457200"/>
           </a:xfrm>
           <a:prstGeom prst="rect">
             <a:avLst/>
@@ -5525,56 +5038,21 @@
               </a:defRPr>
             </a:pPr>
             <a:r>
-              <a:t>12-week rollout plan</a:t>
-            </a:r>
-          </a:p>
-        </p:txBody>
-      </p:sp>
-      <p:sp>
-        <p:nvSpPr>
-          <p:cNvPr id="5" name="TextBox 4"/>
-          <p:cNvSpPr txBox="1"/>
-          <p:nvPr/>
-        </p:nvSpPr>
-        <p:spPr>
-          <a:xfrm>
-            <a:off x="9875520" y="182880"/>
-            <a:ext cx="2103120" cy="320040"/>
-          </a:xfrm>
-          <a:prstGeom prst="rect">
-            <a:avLst/>
-          </a:prstGeom>
-          <a:noFill/>
-        </p:spPr>
-        <p:txBody>
-          <a:bodyPr wrap="none">
-            <a:spAutoFit/>
-          </a:bodyPr>
-          <a:lstStyle/>
-          <a:p>
-            <a:pPr algn="r">
-              <a:defRPr sz="1000">
-                <a:solidFill>
-                  <a:srgbClr val="D7E3DD"/>
-                </a:solidFill>
-              </a:defRPr>
-            </a:pPr>
-            <a:r>
-              <a:t>Olam Agri</a:t>
-            </a:r>
-          </a:p>
-        </p:txBody>
-      </p:sp>
-      <p:sp>
-        <p:nvSpPr>
-          <p:cNvPr id="6" name="Rounded Rectangle 5"/>
+              <a:t>6) What are the blockers?</a:t>
+            </a:r>
+          </a:p>
+        </p:txBody>
+      </p:sp>
+      <p:sp>
+        <p:nvSpPr>
+          <p:cNvPr id="5" name="Rounded Rectangle 4"/>
           <p:cNvSpPr/>
           <p:nvPr/>
         </p:nvSpPr>
         <p:spPr>
           <a:xfrm>
-            <a:off x="731520" y="1737360"/>
-            <a:ext cx="2697480" cy="3566160"/>
+            <a:off x="640080" y="1188720"/>
+            <a:ext cx="10972800" cy="5303520"/>
           </a:xfrm>
           <a:prstGeom prst="roundRect">
             <a:avLst/>
@@ -5612,14 +5090,14 @@
       </p:sp>
       <p:sp>
         <p:nvSpPr>
-          <p:cNvPr id="7" name="TextBox 6"/>
+          <p:cNvPr id="6" name="TextBox 5"/>
           <p:cNvSpPr txBox="1"/>
           <p:nvPr/>
         </p:nvSpPr>
         <p:spPr>
           <a:xfrm>
-            <a:off x="914400" y="1965960"/>
-            <a:ext cx="2286000" cy="3108960"/>
+            <a:off x="914400" y="1508760"/>
+            <a:ext cx="10241280" cy="640080"/>
           </a:xfrm>
           <a:prstGeom prst="rect">
             <a:avLst/>
@@ -5633,85 +5111,28 @@
           <a:lstStyle/>
           <a:p>
             <a:pPr>
-              <a:defRPr sz="1600" b="1">
+              <a:defRPr sz="1800" b="1">
                 <a:solidFill>
                   <a:srgbClr val="18402C"/>
                 </a:solidFill>
               </a:defRPr>
             </a:pPr>
             <a:r>
-              <a:t>Weeks 1-2</a:t>
-            </a:r>
-          </a:p>
-          <a:p>
-            <a:pPr>
-              <a:defRPr sz="1500">
-                <a:solidFill>
-                  <a:srgbClr val="1D3226"/>
-                </a:solidFill>
-              </a:defRPr>
-            </a:pPr>
-            <a:r>
-              <a:t>Choose use case and schema</a:t>
-            </a:r>
-          </a:p>
-        </p:txBody>
-      </p:sp>
-      <p:sp>
-        <p:nvSpPr>
-          <p:cNvPr id="8" name="Rounded Rectangle 7"/>
-          <p:cNvSpPr/>
-          <p:nvPr/>
-        </p:nvSpPr>
-        <p:spPr>
-          <a:xfrm>
-            <a:off x="3611880" y="1737360"/>
-            <a:ext cx="2697480" cy="3566160"/>
-          </a:xfrm>
-          <a:prstGeom prst="roundRect">
-            <a:avLst/>
-          </a:prstGeom>
-          <a:solidFill>
-            <a:srgbClr val="FFFFFF"/>
-          </a:solidFill>
-          <a:ln>
-            <a:solidFill>
-              <a:srgbClr val="D6DFD9"/>
-            </a:solidFill>
-          </a:ln>
-        </p:spPr>
-        <p:style>
-          <a:lnRef idx="1">
-            <a:schemeClr val="accent1"/>
-          </a:lnRef>
-          <a:fillRef idx="3">
-            <a:schemeClr val="accent1"/>
-          </a:fillRef>
-          <a:effectRef idx="2">
-            <a:schemeClr val="accent1"/>
-          </a:effectRef>
-          <a:fontRef idx="minor">
-            <a:schemeClr val="lt1"/>
-          </a:fontRef>
-        </p:style>
-        <p:txBody>
-          <a:bodyPr rtlCol="0" anchor="ctr"/>
-          <a:lstStyle/>
-          <a:p>
-            <a:pPr algn="ctr"/>
-          </a:p>
-        </p:txBody>
-      </p:sp>
-      <p:sp>
-        <p:nvSpPr>
-          <p:cNvPr id="9" name="TextBox 8"/>
+              <a:t>Main blockers to solve early</a:t>
+            </a:r>
+          </a:p>
+        </p:txBody>
+      </p:sp>
+      <p:sp>
+        <p:nvSpPr>
+          <p:cNvPr id="7" name="TextBox 6"/>
           <p:cNvSpPr txBox="1"/>
           <p:nvPr/>
         </p:nvSpPr>
         <p:spPr>
           <a:xfrm>
-            <a:off x="3794760" y="1965960"/>
-            <a:ext cx="2286000" cy="3108960"/>
+            <a:off x="914400" y="2148840"/>
+            <a:ext cx="10149840" cy="4023360"/>
           </a:xfrm>
           <a:prstGeom prst="rect">
             <a:avLst/>
@@ -5719,216 +5140,83 @@
           <a:noFill/>
         </p:spPr>
         <p:txBody>
-          <a:bodyPr wrap="none">
+          <a:bodyPr wrap="square">
             <a:spAutoFit/>
           </a:bodyPr>
           <a:lstStyle/>
           <a:p>
             <a:pPr>
-              <a:defRPr sz="1600" b="1">
-                <a:solidFill>
-                  <a:srgbClr val="18402C"/>
+              <a:spcAft>
+                <a:spcPts val="1000"/>
+              </a:spcAft>
+              <a:defRPr sz="2200">
+                <a:solidFill>
+                  <a:srgbClr val="1D3226"/>
                 </a:solidFill>
               </a:defRPr>
             </a:pPr>
             <a:r>
-              <a:t>Weeks 3-4</a:t>
+              <a:t>• No clear data ownership.</a:t>
             </a:r>
           </a:p>
           <a:p>
             <a:pPr>
-              <a:defRPr sz="1500">
+              <a:spcAft>
+                <a:spcPts val="1000"/>
+              </a:spcAft>
+              <a:defRPr sz="2200">
                 <a:solidFill>
                   <a:srgbClr val="1D3226"/>
                 </a:solidFill>
               </a:defRPr>
             </a:pPr>
             <a:r>
-              <a:t>Build pilot index and secure access</a:t>
-            </a:r>
-          </a:p>
-        </p:txBody>
-      </p:sp>
-      <p:sp>
-        <p:nvSpPr>
-          <p:cNvPr id="10" name="Rounded Rectangle 9"/>
-          <p:cNvSpPr/>
-          <p:nvPr/>
-        </p:nvSpPr>
-        <p:spPr>
-          <a:xfrm>
-            <a:off x="6492240" y="1737360"/>
-            <a:ext cx="2697480" cy="3566160"/>
-          </a:xfrm>
-          <a:prstGeom prst="roundRect">
-            <a:avLst/>
-          </a:prstGeom>
-          <a:solidFill>
-            <a:srgbClr val="FFFFFF"/>
-          </a:solidFill>
-          <a:ln>
-            <a:solidFill>
-              <a:srgbClr val="D6DFD9"/>
-            </a:solidFill>
-          </a:ln>
-        </p:spPr>
-        <p:style>
-          <a:lnRef idx="1">
-            <a:schemeClr val="accent1"/>
-          </a:lnRef>
-          <a:fillRef idx="3">
-            <a:schemeClr val="accent1"/>
-          </a:fillRef>
-          <a:effectRef idx="2">
-            <a:schemeClr val="accent1"/>
-          </a:effectRef>
-          <a:fontRef idx="minor">
-            <a:schemeClr val="lt1"/>
-          </a:fontRef>
-        </p:style>
-        <p:txBody>
-          <a:bodyPr rtlCol="0" anchor="ctr"/>
-          <a:lstStyle/>
-          <a:p>
-            <a:pPr algn="ctr"/>
-          </a:p>
-        </p:txBody>
-      </p:sp>
-      <p:sp>
-        <p:nvSpPr>
-          <p:cNvPr id="11" name="TextBox 10"/>
-          <p:cNvSpPr txBox="1"/>
-          <p:nvPr/>
-        </p:nvSpPr>
-        <p:spPr>
-          <a:xfrm>
-            <a:off x="6675120" y="1965960"/>
-            <a:ext cx="2286000" cy="3108960"/>
-          </a:xfrm>
-          <a:prstGeom prst="rect">
-            <a:avLst/>
-          </a:prstGeom>
-          <a:noFill/>
-        </p:spPr>
-        <p:txBody>
-          <a:bodyPr wrap="none">
-            <a:spAutoFit/>
-          </a:bodyPr>
-          <a:lstStyle/>
+              <a:t>• Hard SAP-to-search field mapping.</a:t>
+            </a:r>
+          </a:p>
           <a:p>
             <a:pPr>
-              <a:defRPr sz="1600" b="1">
-                <a:solidFill>
-                  <a:srgbClr val="18402C"/>
+              <a:spcAft>
+                <a:spcPts val="1000"/>
+              </a:spcAft>
+              <a:defRPr sz="2200">
+                <a:solidFill>
+                  <a:srgbClr val="1D3226"/>
                 </a:solidFill>
               </a:defRPr>
             </a:pPr>
             <a:r>
-              <a:t>Weeks 5-8</a:t>
+              <a:t>• No agreed performance SLA.</a:t>
             </a:r>
           </a:p>
           <a:p>
             <a:pPr>
-              <a:defRPr sz="1500">
+              <a:spcAft>
+                <a:spcPts val="1000"/>
+              </a:spcAft>
+              <a:defRPr sz="2200">
                 <a:solidFill>
                   <a:srgbClr val="1D3226"/>
                 </a:solidFill>
               </a:defRPr>
             </a:pPr>
             <a:r>
-              <a:t>Automate updates and tune relevance</a:t>
-            </a:r>
-          </a:p>
-        </p:txBody>
-      </p:sp>
-      <p:sp>
-        <p:nvSpPr>
-          <p:cNvPr id="12" name="Rounded Rectangle 11"/>
-          <p:cNvSpPr/>
-          <p:nvPr/>
-        </p:nvSpPr>
-        <p:spPr>
-          <a:xfrm>
-            <a:off x="9372600" y="1737360"/>
-            <a:ext cx="2697480" cy="3566160"/>
-          </a:xfrm>
-          <a:prstGeom prst="roundRect">
-            <a:avLst/>
-          </a:prstGeom>
-          <a:solidFill>
-            <a:srgbClr val="FFFFFF"/>
-          </a:solidFill>
-          <a:ln>
-            <a:solidFill>
-              <a:srgbClr val="D6DFD9"/>
-            </a:solidFill>
-          </a:ln>
-        </p:spPr>
-        <p:style>
-          <a:lnRef idx="1">
-            <a:schemeClr val="accent1"/>
-          </a:lnRef>
-          <a:fillRef idx="3">
-            <a:schemeClr val="accent1"/>
-          </a:fillRef>
-          <a:effectRef idx="2">
-            <a:schemeClr val="accent1"/>
-          </a:effectRef>
-          <a:fontRef idx="minor">
-            <a:schemeClr val="lt1"/>
-          </a:fontRef>
-        </p:style>
-        <p:txBody>
-          <a:bodyPr rtlCol="0" anchor="ctr"/>
-          <a:lstStyle/>
-          <a:p>
-            <a:pPr algn="ctr"/>
-          </a:p>
-        </p:txBody>
-      </p:sp>
-      <p:sp>
-        <p:nvSpPr>
-          <p:cNvPr id="13" name="TextBox 12"/>
-          <p:cNvSpPr txBox="1"/>
-          <p:nvPr/>
-        </p:nvSpPr>
-        <p:spPr>
-          <a:xfrm>
-            <a:off x="9555480" y="1965960"/>
-            <a:ext cx="2286000" cy="3108960"/>
-          </a:xfrm>
-          <a:prstGeom prst="rect">
-            <a:avLst/>
-          </a:prstGeom>
-          <a:noFill/>
-        </p:spPr>
-        <p:txBody>
-          <a:bodyPr wrap="none">
-            <a:spAutoFit/>
-          </a:bodyPr>
-          <a:lstStyle/>
+              <a:t>• Missing monitoring and restore test.</a:t>
+            </a:r>
+          </a:p>
           <a:p>
             <a:pPr>
-              <a:defRPr sz="1600" b="1">
-                <a:solidFill>
-                  <a:srgbClr val="18402C"/>
+              <a:spcAft>
+                <a:spcPts val="1000"/>
+              </a:spcAft>
+              <a:defRPr sz="2200">
+                <a:solidFill>
+                  <a:srgbClr val="1D3226"/>
                 </a:solidFill>
               </a:defRPr>
             </a:pPr>
             <a:r>
-              <a:t>Weeks 9-12</a:t>
-            </a:r>
-          </a:p>
-          <a:p>
-            <a:pPr>
-              <a:defRPr sz="1500">
-                <a:solidFill>
-                  <a:srgbClr val="1D3226"/>
-                </a:solidFill>
-              </a:defRPr>
-            </a:pPr>
-            <a:r>
-              <a:t>Load test and release in stages</a:t>
+              <a:t>• Security risk from exposed keys.</a:t>
             </a:r>
           </a:p>
         </p:txBody>
@@ -6003,7 +5291,7 @@
         <p:spPr>
           <a:xfrm>
             <a:off x="0" y="0"/>
-            <a:ext cx="12191695" cy="749808"/>
+            <a:ext cx="12191695" cy="777240"/>
           </a:xfrm>
           <a:prstGeom prst="rect">
             <a:avLst/>
@@ -6046,7 +5334,7 @@
         <p:spPr>
           <a:xfrm>
             <a:off x="502920" y="128016"/>
-            <a:ext cx="9601200" cy="457200"/>
+            <a:ext cx="10972800" cy="457200"/>
           </a:xfrm>
           <a:prstGeom prst="rect">
             <a:avLst/>
@@ -6074,84 +5362,14 @@
       </p:sp>
       <p:sp>
         <p:nvSpPr>
-          <p:cNvPr id="5" name="TextBox 4"/>
-          <p:cNvSpPr txBox="1"/>
-          <p:nvPr/>
-        </p:nvSpPr>
-        <p:spPr>
-          <a:xfrm>
-            <a:off x="9875520" y="182880"/>
-            <a:ext cx="2103120" cy="320040"/>
-          </a:xfrm>
-          <a:prstGeom prst="rect">
-            <a:avLst/>
-          </a:prstGeom>
-          <a:noFill/>
-        </p:spPr>
-        <p:txBody>
-          <a:bodyPr wrap="none">
-            <a:spAutoFit/>
-          </a:bodyPr>
-          <a:lstStyle/>
-          <a:p>
-            <a:pPr algn="r">
-              <a:defRPr sz="1000">
-                <a:solidFill>
-                  <a:srgbClr val="D7E3DD"/>
-                </a:solidFill>
-              </a:defRPr>
-            </a:pPr>
-            <a:r>
-              <a:t>Olam Agri</a:t>
-            </a:r>
-          </a:p>
-        </p:txBody>
-      </p:sp>
-      <p:sp>
-        <p:nvSpPr>
-          <p:cNvPr id="6" name="TextBox 5"/>
-          <p:cNvSpPr txBox="1"/>
-          <p:nvPr/>
-        </p:nvSpPr>
-        <p:spPr>
-          <a:xfrm>
-            <a:off x="685800" y="960120"/>
-            <a:ext cx="10972800" cy="548640"/>
-          </a:xfrm>
-          <a:prstGeom prst="rect">
-            <a:avLst/>
-          </a:prstGeom>
-          <a:noFill/>
-        </p:spPr>
-        <p:txBody>
-          <a:bodyPr wrap="none">
-            <a:spAutoFit/>
-          </a:bodyPr>
-          <a:lstStyle/>
-          <a:p>
-            <a:pPr>
-              <a:defRPr sz="1600">
-                <a:solidFill>
-                  <a:srgbClr val="50685C"/>
-                </a:solidFill>
-              </a:defRPr>
-            </a:pPr>
-            <a:r>
-              <a:t>Start small, control performance, then scale.</a:t>
-            </a:r>
-          </a:p>
-        </p:txBody>
-      </p:sp>
-      <p:sp>
-        <p:nvSpPr>
-          <p:cNvPr id="7" name="Rounded Rectangle 6"/>
+          <p:cNvPr id="5" name="Rounded Rectangle 4"/>
           <p:cNvSpPr/>
           <p:nvPr/>
         </p:nvSpPr>
         <p:spPr>
           <a:xfrm>
-            <a:off x="594360" y="1508760"/>
-            <a:ext cx="10972800" cy="4892040"/>
+            <a:off x="640080" y="1188720"/>
+            <a:ext cx="10972800" cy="5303520"/>
           </a:xfrm>
           <a:prstGeom prst="roundRect">
             <a:avLst/>
@@ -6189,14 +5407,14 @@
       </p:sp>
       <p:sp>
         <p:nvSpPr>
-          <p:cNvPr id="8" name="TextBox 7"/>
+          <p:cNvPr id="6" name="TextBox 5"/>
           <p:cNvSpPr txBox="1"/>
           <p:nvPr/>
         </p:nvSpPr>
         <p:spPr>
           <a:xfrm>
-            <a:off x="914400" y="1828800"/>
-            <a:ext cx="10241280" cy="4389120"/>
+            <a:off x="914400" y="1508760"/>
+            <a:ext cx="10241280" cy="640080"/>
           </a:xfrm>
           <a:prstGeom prst="rect">
             <a:avLst/>
@@ -6204,6 +5422,41 @@
           <a:noFill/>
         </p:spPr>
         <p:txBody>
+          <a:bodyPr wrap="none">
+            <a:spAutoFit/>
+          </a:bodyPr>
+          <a:lstStyle/>
+          <a:p>
+            <a:pPr>
+              <a:defRPr sz="1800" b="1">
+                <a:solidFill>
+                  <a:srgbClr val="18402C"/>
+                </a:solidFill>
+              </a:defRPr>
+            </a:pPr>
+            <a:r>
+              <a:t>What to do now</a:t>
+            </a:r>
+          </a:p>
+        </p:txBody>
+      </p:sp>
+      <p:sp>
+        <p:nvSpPr>
+          <p:cNvPr id="7" name="TextBox 6"/>
+          <p:cNvSpPr txBox="1"/>
+          <p:nvPr/>
+        </p:nvSpPr>
+        <p:spPr>
+          <a:xfrm>
+            <a:off x="914400" y="2148840"/>
+            <a:ext cx="10149840" cy="4023360"/>
+          </a:xfrm>
+          <a:prstGeom prst="rect">
+            <a:avLst/>
+          </a:prstGeom>
+          <a:noFill/>
+        </p:spPr>
+        <p:txBody>
           <a:bodyPr wrap="square">
             <a:spAutoFit/>
           </a:bodyPr>
@@ -6213,14 +5466,14 @@
               <a:spcAft>
                 <a:spcPts val="1000"/>
               </a:spcAft>
-              <a:defRPr sz="2400">
+              <a:defRPr sz="2300">
                 <a:solidFill>
                   <a:srgbClr val="1D3226"/>
                 </a:solidFill>
               </a:defRPr>
             </a:pPr>
             <a:r>
-              <a:t>• Go live with one high-value search use case</a:t>
+              <a:t>• Start with one business domain.</a:t>
             </a:r>
           </a:p>
           <a:p>
@@ -6228,14 +5481,14 @@
               <a:spcAft>
                 <a:spcPts val="1000"/>
               </a:spcAft>
-              <a:defRPr sz="2400">
+              <a:defRPr sz="2300">
                 <a:solidFill>
                   <a:srgbClr val="1D3226"/>
                 </a:solidFill>
               </a:defRPr>
             </a:pPr>
             <a:r>
-              <a:t>• Keep architecture simple and measurable</a:t>
+              <a:t>• Keep architecture simple.</a:t>
             </a:r>
           </a:p>
           <a:p>
@@ -6243,351 +5496,29 @@
               <a:spcAft>
                 <a:spcPts val="1000"/>
               </a:spcAft>
-              <a:defRPr sz="2400">
+              <a:defRPr sz="2300">
                 <a:solidFill>
                   <a:srgbClr val="1D3226"/>
                 </a:solidFill>
               </a:defRPr>
             </a:pPr>
             <a:r>
-              <a:t>• Expand only after stability and quality are proven</a:t>
-            </a:r>
-          </a:p>
-        </p:txBody>
-      </p:sp>
-    </p:spTree>
-  </p:cSld>
-  <p:clrMapOvr>
-    <a:masterClrMapping/>
-  </p:clrMapOvr>
-</p:sld>
-</file>
-
-<file path=ppt/slides/slide9.xml><?xml version="1.0" encoding="utf-8"?>
-<p:sld xmlns:a="http://schemas.openxmlformats.org/drawingml/2006/main" xmlns:p="http://schemas.openxmlformats.org/presentationml/2006/main" xmlns:r="http://schemas.openxmlformats.org/officeDocument/2006/relationships">
-  <p:cSld>
-    <p:spTree>
-      <p:nvGrpSpPr>
-        <p:cNvPr id="1" name=""/>
-        <p:cNvGrpSpPr/>
-        <p:nvPr/>
-      </p:nvGrpSpPr>
-      <p:grpSpPr/>
-      <p:sp>
-        <p:nvSpPr>
-          <p:cNvPr id="2" name="Rectangle 1"/>
-          <p:cNvSpPr/>
-          <p:nvPr/>
-        </p:nvSpPr>
-        <p:spPr>
-          <a:xfrm>
-            <a:off x="0" y="0"/>
-            <a:ext cx="12191695" cy="6858000"/>
-          </a:xfrm>
-          <a:prstGeom prst="rect">
-            <a:avLst/>
-          </a:prstGeom>
-          <a:solidFill>
-            <a:srgbClr val="F7F9F6"/>
-          </a:solidFill>
-          <a:ln>
-            <a:noFill/>
-          </a:ln>
-        </p:spPr>
-        <p:style>
-          <a:lnRef idx="1">
-            <a:schemeClr val="accent1"/>
-          </a:lnRef>
-          <a:fillRef idx="3">
-            <a:schemeClr val="accent1"/>
-          </a:fillRef>
-          <a:effectRef idx="2">
-            <a:schemeClr val="accent1"/>
-          </a:effectRef>
-          <a:fontRef idx="minor">
-            <a:schemeClr val="lt1"/>
-          </a:fontRef>
-        </p:style>
-        <p:txBody>
-          <a:bodyPr rtlCol="0" anchor="ctr"/>
-          <a:lstStyle/>
-          <a:p>
-            <a:pPr algn="ctr"/>
-          </a:p>
-        </p:txBody>
-      </p:sp>
-      <p:sp>
-        <p:nvSpPr>
-          <p:cNvPr id="3" name="Rectangle 2"/>
-          <p:cNvSpPr/>
-          <p:nvPr/>
-        </p:nvSpPr>
-        <p:spPr>
-          <a:xfrm>
-            <a:off x="0" y="0"/>
-            <a:ext cx="12191695" cy="749808"/>
-          </a:xfrm>
-          <a:prstGeom prst="rect">
-            <a:avLst/>
-          </a:prstGeom>
-          <a:solidFill>
-            <a:srgbClr val="18402C"/>
-          </a:solidFill>
-          <a:ln>
-            <a:noFill/>
-          </a:ln>
-        </p:spPr>
-        <p:style>
-          <a:lnRef idx="1">
-            <a:schemeClr val="accent1"/>
-          </a:lnRef>
-          <a:fillRef idx="3">
-            <a:schemeClr val="accent1"/>
-          </a:fillRef>
-          <a:effectRef idx="2">
-            <a:schemeClr val="accent1"/>
-          </a:effectRef>
-          <a:fontRef idx="minor">
-            <a:schemeClr val="lt1"/>
-          </a:fontRef>
-        </p:style>
-        <p:txBody>
-          <a:bodyPr rtlCol="0" anchor="ctr"/>
-          <a:lstStyle/>
-          <a:p>
-            <a:pPr algn="ctr"/>
-          </a:p>
-        </p:txBody>
-      </p:sp>
-      <p:sp>
-        <p:nvSpPr>
-          <p:cNvPr id="4" name="TextBox 3"/>
-          <p:cNvSpPr txBox="1"/>
-          <p:nvPr/>
-        </p:nvSpPr>
-        <p:spPr>
-          <a:xfrm>
-            <a:off x="502920" y="128016"/>
-            <a:ext cx="9601200" cy="457200"/>
-          </a:xfrm>
-          <a:prstGeom prst="rect">
-            <a:avLst/>
-          </a:prstGeom>
-          <a:noFill/>
-        </p:spPr>
-        <p:txBody>
-          <a:bodyPr wrap="none">
-            <a:spAutoFit/>
-          </a:bodyPr>
-          <a:lstStyle/>
-          <a:p>
-            <a:pPr>
-              <a:defRPr sz="2400" b="1">
-                <a:solidFill>
-                  <a:srgbClr val="FFFFFF"/>
-                </a:solidFill>
-              </a:defRPr>
-            </a:pPr>
-            <a:r>
-              <a:t>References</a:t>
-            </a:r>
-          </a:p>
-        </p:txBody>
-      </p:sp>
-      <p:sp>
-        <p:nvSpPr>
-          <p:cNvPr id="5" name="TextBox 4"/>
-          <p:cNvSpPr txBox="1"/>
-          <p:nvPr/>
-        </p:nvSpPr>
-        <p:spPr>
-          <a:xfrm>
-            <a:off x="9875520" y="182880"/>
-            <a:ext cx="2103120" cy="320040"/>
-          </a:xfrm>
-          <a:prstGeom prst="rect">
-            <a:avLst/>
-          </a:prstGeom>
-          <a:noFill/>
-        </p:spPr>
-        <p:txBody>
-          <a:bodyPr wrap="none">
-            <a:spAutoFit/>
-          </a:bodyPr>
-          <a:lstStyle/>
-          <a:p>
-            <a:pPr algn="r">
-              <a:defRPr sz="1000">
-                <a:solidFill>
-                  <a:srgbClr val="D7E3DD"/>
-                </a:solidFill>
-              </a:defRPr>
-            </a:pPr>
-            <a:r>
-              <a:t>Olam Agri</a:t>
-            </a:r>
-          </a:p>
-        </p:txBody>
-      </p:sp>
-      <p:sp>
-        <p:nvSpPr>
-          <p:cNvPr id="6" name="TextBox 5"/>
-          <p:cNvSpPr txBox="1"/>
-          <p:nvPr/>
-        </p:nvSpPr>
-        <p:spPr>
-          <a:xfrm>
-            <a:off x="685800" y="960120"/>
-            <a:ext cx="10972800" cy="548640"/>
-          </a:xfrm>
-          <a:prstGeom prst="rect">
-            <a:avLst/>
-          </a:prstGeom>
-          <a:noFill/>
-        </p:spPr>
-        <p:txBody>
-          <a:bodyPr wrap="none">
-            <a:spAutoFit/>
-          </a:bodyPr>
-          <a:lstStyle/>
-          <a:p>
-            <a:pPr>
-              <a:defRPr sz="1600">
-                <a:solidFill>
-                  <a:srgbClr val="50685C"/>
-                </a:solidFill>
-              </a:defRPr>
-            </a:pPr>
-            <a:r>
-              <a:t>Primary sources used</a:t>
-            </a:r>
-          </a:p>
-        </p:txBody>
-      </p:sp>
-      <p:sp>
-        <p:nvSpPr>
-          <p:cNvPr id="7" name="Rounded Rectangle 6"/>
-          <p:cNvSpPr/>
-          <p:nvPr/>
-        </p:nvSpPr>
-        <p:spPr>
-          <a:xfrm>
-            <a:off x="594360" y="1508760"/>
-            <a:ext cx="10972800" cy="4892040"/>
-          </a:xfrm>
-          <a:prstGeom prst="roundRect">
-            <a:avLst/>
-          </a:prstGeom>
-          <a:solidFill>
-            <a:srgbClr val="FFFFFF"/>
-          </a:solidFill>
-          <a:ln>
-            <a:solidFill>
-              <a:srgbClr val="D6DFD9"/>
-            </a:solidFill>
-          </a:ln>
-        </p:spPr>
-        <p:style>
-          <a:lnRef idx="1">
-            <a:schemeClr val="accent1"/>
-          </a:lnRef>
-          <a:fillRef idx="3">
-            <a:schemeClr val="accent1"/>
-          </a:fillRef>
-          <a:effectRef idx="2">
-            <a:schemeClr val="accent1"/>
-          </a:effectRef>
-          <a:fontRef idx="minor">
-            <a:schemeClr val="lt1"/>
-          </a:fontRef>
-        </p:style>
-        <p:txBody>
-          <a:bodyPr rtlCol="0" anchor="ctr"/>
-          <a:lstStyle/>
-          <a:p>
-            <a:pPr algn="ctr"/>
-          </a:p>
-        </p:txBody>
-      </p:sp>
-      <p:sp>
-        <p:nvSpPr>
-          <p:cNvPr id="8" name="TextBox 7"/>
-          <p:cNvSpPr txBox="1"/>
-          <p:nvPr/>
-        </p:nvSpPr>
-        <p:spPr>
-          <a:xfrm>
-            <a:off x="914400" y="1828800"/>
-            <a:ext cx="10241280" cy="4389120"/>
-          </a:xfrm>
-          <a:prstGeom prst="rect">
-            <a:avLst/>
-          </a:prstGeom>
-          <a:noFill/>
-        </p:spPr>
-        <p:txBody>
-          <a:bodyPr wrap="square">
-            <a:spAutoFit/>
-          </a:bodyPr>
-          <a:lstStyle/>
+              <a:t>• Set performance and security controls from day one.</a:t>
+            </a:r>
+          </a:p>
           <a:p>
             <a:pPr>
               <a:spcAft>
                 <a:spcPts val="1000"/>
               </a:spcAft>
-              <a:defRPr sz="2400">
+              <a:defRPr sz="2300">
                 <a:solidFill>
                   <a:srgbClr val="1D3226"/>
                 </a:solidFill>
               </a:defRPr>
             </a:pPr>
             <a:r>
-              <a:t>• Meilisearch Documentation: FAQ and Configuration</a:t>
-            </a:r>
-          </a:p>
-          <a:p>
-            <a:pPr>
-              <a:spcAft>
-                <a:spcPts val="1000"/>
-              </a:spcAft>
-              <a:defRPr sz="2400">
-                <a:solidFill>
-                  <a:srgbClr val="1D3226"/>
-                </a:solidFill>
-              </a:defRPr>
-            </a:pPr>
-            <a:r>
-              <a:t>• Meilisearch Documentation: Security and tenant tokens</a:t>
-            </a:r>
-          </a:p>
-          <a:p>
-            <a:pPr>
-              <a:spcAft>
-                <a:spcPts val="1000"/>
-              </a:spcAft>
-              <a:defRPr sz="2400">
-                <a:solidFill>
-                  <a:srgbClr val="1D3226"/>
-                </a:solidFill>
-              </a:defRPr>
-            </a:pPr>
-            <a:r>
-              <a:t>• Meilisearch Documentation: Community vs Enterprise</a:t>
-            </a:r>
-          </a:p>
-          <a:p>
-            <a:pPr>
-              <a:spcAft>
-                <a:spcPts val="1000"/>
-              </a:spcAft>
-              <a:defRPr sz="2400">
-                <a:solidFill>
-                  <a:srgbClr val="1D3226"/>
-                </a:solidFill>
-              </a:defRPr>
-            </a:pPr>
-            <a:r>
-              <a:t>• Meilisearch Documentation: Indexing performance guidance</a:t>
+              <a:t>• Scale only after pilot metrics are stable.</a:t>
             </a:r>
           </a:p>
         </p:txBody>

</xml_diff>